<commit_message>
Refine motivation slides and add reusable-rubric talk script
</commit_message>
<xml_diff>
--- a/slides/SCRIBE_EMNLP2026.pptx
+++ b/slides/SCRIBE_EMNLP2026.pptx
@@ -10,7 +10,6 @@
   </p:notesMasterIdLst>
   <p:sldIdLst>
     <p:sldId id="256" r:id="rId9"/>
-    <p:sldId id="257" r:id="rId10"/>
     <p:sldId id="258" r:id="rId11"/>
     <p:sldId id="259" r:id="rId12"/>
     <p:sldId id="260" r:id="rId13"/>
@@ -315,23 +314,6 @@
   <p:cm authorId="0" idx="4" dt="2026-09-28T17:43:09.284">
     <p:pos x="6000" y="0"/>
     <p:text>At some point, within the first 2 minutes of this presentation, you need to give a slide summarizing the contributions of the work.</p:text>
-  </p:cm>
-</p:cmLst>
-</file>
-
-<file path=ppt/comments/comment2.xml><?xml version="1.0" encoding="utf-8"?>
-<p:cmLst xmlns:a="http://schemas.openxmlformats.org/drawingml/2006/main" xmlns:r="http://schemas.openxmlformats.org/officeDocument/2006/relationships" xmlns:mc="http://schemas.openxmlformats.org/markup-compatibility/2006" xmlns:mv="urn:schemas-microsoft-com:mac:vml" xmlns:p="http://schemas.openxmlformats.org/presentationml/2006/main" xmlns:c="http://schemas.openxmlformats.org/drawingml/2006/chart" xmlns:dgm="http://schemas.openxmlformats.org/drawingml/2006/diagram" xmlns:o="urn:schemas-microsoft-com:office:office" xmlns:v="urn:schemas-microsoft-com:vml" xmlns:pvml="urn:schemas-microsoft-com:office:powerpoint" xmlns:com="http://schemas.openxmlformats.org/drawingml/2006/compatibility" xmlns:p14="http://schemas.microsoft.com/office/powerpoint/2010/main" xmlns:p15="http://schemas.microsoft.com/office/powerpoint/2012/main" xmlns:ahyp="http://schemas.microsoft.com/office/drawing/2018/hyperlinkcolor">
-  <p:cm authorId="0" idx="5" dt="2026-09-28T17:35:06.214">
-    <p:pos x="6000" y="0"/>
-    <p:text>While a lot does necessarily depend on your voice track (what you say), the slide should still be relatively self explanatory (at a high level) without either the voice track or extensive text. Try to make the figure more central. A partial initial example is shown in the next (hidden) slide.</p:text>
-  </p:cm>
-  <p:cm authorId="0" idx="6" dt="2026-09-28T17:38:56.707">
-    <p:pos x="276" y="103"/>
-    <p:text>Title case!</p:text>
-  </p:cm>
-  <p:cm authorId="0" idx="7" dt="2026-09-28T17:38:56.707">
-    <p:pos x="276" y="103"/>
-    <p:text>This applies to nearly all slides, but I won't keep commenting it.</p:text>
   </p:cm>
 </p:cmLst>
 </file>
@@ -928,22 +910,9 @@
           </a:bodyPr>
           <a:lstStyle/>
           <a:p>
-            <a:pPr indent="0" lvl="0" marL="457200" rtl="0" algn="l">
-              <a:lnSpc>
-                <a:spcPct val="100000"/>
-              </a:lnSpc>
-              <a:spcBef>
-                <a:spcPts val="0"/>
-              </a:spcBef>
-              <a:spcAft>
-                <a:spcPts val="0"/>
-              </a:spcAft>
-              <a:buNone/>
-            </a:pPr>
             <a:r>
-              <a:t/>
+              <a:t>Hello everyone. I’m Yuxuan Jiang from the University of Maryland, Baltimore County. This is joint work with my advisor, Francis Ferraro. Today I’ll present SCRIBE. Our core contribution is reusable rubrics: shared scoring criteria for reasoning skills that can be applied across different problems. Instead of creating a new rubric around each problem’s reference answer, we organize evaluation around what an intermediate reasoning step is trying to accomplish. I’ll show how we build these rubrics, how they guide reinforcement learning, and why reuse helps make rewards more consistent. The QR code links to our project and slides.</a:t>
             </a:r>
-            <a:endParaRPr/>
           </a:p>
         </p:txBody>
       </p:sp>
@@ -1044,23 +1013,9 @@
           </a:bodyPr>
           <a:lstStyle/>
           <a:p>
-            <a:pPr indent="-298450" lvl="0" marL="457200" rtl="0" algn="l">
-              <a:lnSpc>
-                <a:spcPct val="100000"/>
-              </a:lnSpc>
-              <a:spcBef>
-                <a:spcPts val="0"/>
-              </a:spcBef>
-              <a:spcAft>
-                <a:spcPts val="0"/>
-              </a:spcAft>
-              <a:buSzPts val="1100"/>
-              <a:buChar char="●"/>
-            </a:pPr>
             <a:r>
-              <a:t/>
+              <a:t>With SCRIBE, the rubric construction does not require reference answers. In this comparison, SCRIBE reaches 95.8 on MATH500, 63.3 on AIME25, and 51.3 on BFCL overall. It outperforms the reference-based RaR configuration shown here on all three measures. The important point is that removing the reference-answer dependency does not force us to abandon explicit criteria. We obtain those criteria from reusable reasoning skills instead.</a:t>
             </a:r>
-            <a:endParaRPr/>
           </a:p>
         </p:txBody>
       </p:sp>
@@ -1162,7 +1117,7 @@
           <a:lstStyle/>
           <a:p>
             <a:r>
-              <a:t>Protocol matches the camera-ready paper: fix problem, trajectory, rubric and judge; repeat 10 times with independent sampling. The math input is a constructed explanation of the protocol, not an actual recorded sample. No individual scores are invented.</a:t>
+              <a:t>Now let’s examine reward consistency directly. In this illustrative example, the solution establishes that x times one minus x is at most one quarter, but does not demonstrate attainment. We hold the problem, trajectory, judge, and available rubric fixed and score the same input ten times. We then measure score agreement and variation. The table reports aggregate experimental results, not ten scores for this illustration. SCRIBE has the highest agreement and lowest standard deviation among these methods. A shared rubric makes repeated evaluation more stable.</a:t>
             </a:r>
           </a:p>
         </p:txBody>
@@ -1265,7 +1220,7 @@
           <a:lstStyle/>
           <a:p>
             <a:r>
-              <a:t>Illustrative examples of the unproved-tightness failure type. Actual experiment: manually collect 50 groups of 2–11 semantically matched subgoals (mean 5.2), isolate target spans, score under Direct PRM, relevant RaR rubric dimension, and shared SCRIBE prototype. Report pairwise exact agreement and mean absolute score gap. Example-specific model scores are not available and are not shown.</a:t>
+              <a:t>The second test asks a different question: do similar behaviors receive similar scores across different problems? The two illustrative solutions here both jump from an upper bound to a maximum without showing attainment. Their numbers differ, but the reasoning gap is the same. In the experiment, we group matching subgoal behaviors across instances and compare their scores. SCRIBE reaches 86.8 percent agreement with a reward gap of 0.24. This is where reuse matters most: the same underlying behavior is assessed using the same standard.</a:t>
             </a:r>
           </a:p>
         </p:txBody>
@@ -1367,22 +1322,9 @@
           </a:bodyPr>
           <a:lstStyle/>
           <a:p>
-            <a:pPr indent="0" lvl="0" marL="0" rtl="0" algn="l">
-              <a:lnSpc>
-                <a:spcPct val="100000"/>
-              </a:lnSpc>
-              <a:spcBef>
-                <a:spcPts val="0"/>
-              </a:spcBef>
-              <a:spcAft>
-                <a:spcPts val="0"/>
-              </a:spcAft>
-              <a:buNone/>
-            </a:pPr>
             <a:r>
-              <a:t/>
+              <a:t>These results address two complementary concerns. Repeated scoring tests whether the reward changes when the input does not. Cross-instance scoring tests whether it changes unnecessarily when the problem changes but the behavior stays the same. SCRIBE improves both measures in these experiments. Together, they support the role of reusable skill rubrics as a more consistent source of process supervision.</a:t>
             </a:r>
-            <a:endParaRPr/>
           </a:p>
         </p:txBody>
       </p:sp>
@@ -1483,23 +1425,9 @@
           </a:bodyPr>
           <a:lstStyle/>
           <a:p>
-            <a:pPr indent="0" lvl="0" marL="0" rtl="0" algn="l">
-              <a:lnSpc>
-                <a:spcPct val="100000"/>
-              </a:lnSpc>
-              <a:spcBef>
-                <a:spcPts val="0"/>
-              </a:spcBef>
-              <a:spcAft>
-                <a:spcPts val="0"/>
-              </a:spcAft>
-              <a:buSzPts val="1100"/>
-              <a:buNone/>
-            </a:pPr>
             <a:r>
-              <a:t/>
+              <a:t>We next ask whether these rewards translate into better task performance. We evaluate mathematical reasoning on MATH500 and AIME25, using both Qwen and LLaMA backbones. The base and standard PRM rows provide reference points. This lets us check whether the benefit extends beyond scoring consistency to the behavior of the trained policy.</a:t>
             </a:r>
-            <a:endParaRPr/>
           </a:p>
         </p:txBody>
       </p:sp>
@@ -1668,23 +1596,9 @@
           </a:bodyPr>
           <a:lstStyle/>
           <a:p>
-            <a:pPr indent="0" lvl="0" marL="0" rtl="0" algn="l">
-              <a:lnSpc>
-                <a:spcPct val="100000"/>
-              </a:lnSpc>
-              <a:spcBef>
-                <a:spcPts val="0"/>
-              </a:spcBef>
-              <a:spcAft>
-                <a:spcPts val="0"/>
-              </a:spcAft>
-              <a:buSzPts val="1100"/>
-              <a:buNone/>
-            </a:pPr>
             <a:r>
-              <a:t/>
+              <a:t>Adding SCRIBE improves both models on both benchmarks shown here. For Qwen, AIME25 improves from 43.3 for the base model to 63.3 with SCRIBE, compared with 51.7 using the standard PRM. For LLaMA, MATH500 improves from 40.8 to 63.4. The main message is that better-structured process supervision is accompanied by stronger final task performance across the two backbones.</a:t>
             </a:r>
-            <a:endParaRPr/>
           </a:p>
         </p:txBody>
       </p:sp>
@@ -1808,23 +1722,9 @@
           </a:bodyPr>
           <a:lstStyle/>
           <a:p>
-            <a:pPr indent="0" lvl="0" marL="0" rtl="0" algn="l">
-              <a:lnSpc>
-                <a:spcPct val="100000"/>
-              </a:lnSpc>
-              <a:spcBef>
-                <a:spcPts val="0"/>
-              </a:spcBef>
-              <a:spcAft>
-                <a:spcPts val="0"/>
-              </a:spcAft>
-              <a:buSzPts val="1100"/>
-              <a:buNone/>
-            </a:pPr>
             <a:r>
-              <a:t/>
+              <a:t>We also evaluate tool use with BFCL V4. Here, success requires selecting an appropriate tool, supplying suitable arguments, and coordinating calls when the task involves multiple steps. The benchmark includes search, memory, single-turn, and multi-turn settings. These tasks provide a different test of our approach: reusable skills must support tool-using behavior as well as mathematical reasoning.</a:t>
             </a:r>
-            <a:endParaRPr/>
           </a:p>
         </p:txBody>
       </p:sp>
@@ -1970,23 +1870,9 @@
           </a:bodyPr>
           <a:lstStyle/>
           <a:p>
-            <a:pPr indent="0" lvl="0" marL="0" rtl="0" algn="l">
-              <a:lnSpc>
-                <a:spcPct val="100000"/>
-              </a:lnSpc>
-              <a:spcBef>
-                <a:spcPts val="0"/>
-              </a:spcBef>
-              <a:spcAft>
-                <a:spcPts val="0"/>
-              </a:spcAft>
-              <a:buSzPts val="1100"/>
-              <a:buNone/>
-            </a:pPr>
             <a:r>
-              <a:t/>
+              <a:t>This table places the tool-use results beside the math results. Looking first at the base model and standard PRM rows, process supervision already provides a useful improvement in several settings. The remaining question is whether conditioning the reward on reusable skill rubrics provides additional gains. I’ll reveal those rows next.</a:t>
             </a:r>
-            <a:endParaRPr/>
           </a:p>
         </p:txBody>
       </p:sp>
@@ -2155,23 +2041,9 @@
           </a:bodyPr>
           <a:lstStyle/>
           <a:p>
-            <a:pPr indent="0" lvl="0" marL="0" rtl="0" algn="l">
-              <a:lnSpc>
-                <a:spcPct val="100000"/>
-              </a:lnSpc>
-              <a:spcBef>
-                <a:spcPts val="0"/>
-              </a:spcBef>
-              <a:spcAft>
-                <a:spcPts val="0"/>
-              </a:spcAft>
-              <a:buSzPts val="1100"/>
-              <a:buNone/>
-            </a:pPr>
             <a:r>
-              <a:t/>
+              <a:t>SCRIBE improves BFCL overall performance for both backbones shown here. Qwen rises from 33.0 at the base model to 51.3 with SCRIBE, while LLaMA rises from 21.5 to 30.8. The gains also appear in the single-turn and multi-turn results. Together with the math evaluation, these results suggest that reusable skill-level criteria can provide effective supervision across different task types.</a:t>
             </a:r>
-            <a:endParaRPr/>
           </a:p>
         </p:txBody>
       </p:sp>
@@ -2340,208 +2212,9 @@
           </a:bodyPr>
           <a:lstStyle/>
           <a:p>
-            <a:pPr indent="0" lvl="0" marL="0" rtl="0" algn="l">
-              <a:lnSpc>
-                <a:spcPct val="100000"/>
-              </a:lnSpc>
-              <a:spcBef>
-                <a:spcPts val="0"/>
-              </a:spcBef>
-              <a:spcAft>
-                <a:spcPts val="0"/>
-              </a:spcAft>
-              <a:buSzPts val="1100"/>
-              <a:buNone/>
-            </a:pPr>
             <a:r>
-              <a:t/>
+              <a:t>The takeaway is simple: reuse the evaluation standard, rather than building it around each reference answer. SCRIBE turns recurring reasoning skills into reusable rubrics, uses those rubrics to score intermediate behavior, and trains the policy with the resulting rewards. Our experiments show more consistent scoring and stronger performance on mathematical reasoning and tool use. The core contribution is reusable rubrics for process rewards. Thank you. The QR code links to the project and slides, and I’d be happy to take questions.</a:t>
             </a:r>
-            <a:endParaRPr/>
-          </a:p>
-        </p:txBody>
-      </p:sp>
-    </p:spTree>
-  </p:cSld>
-  <p:clrMapOvr>
-    <a:masterClrMapping/>
-  </p:clrMapOvr>
-</p:notes>
-</file>
-
-<file path=ppt/notesSlides/notesSlide2.xml><?xml version="1.0" encoding="utf-8"?>
-<p:notes xmlns:a="http://schemas.openxmlformats.org/drawingml/2006/main" xmlns:r="http://schemas.openxmlformats.org/officeDocument/2006/relationships" xmlns:mc="http://schemas.openxmlformats.org/markup-compatibility/2006" xmlns:mv="urn:schemas-microsoft-com:mac:vml" xmlns:p="http://schemas.openxmlformats.org/presentationml/2006/main" xmlns:c="http://schemas.openxmlformats.org/drawingml/2006/chart" xmlns:dgm="http://schemas.openxmlformats.org/drawingml/2006/diagram" xmlns:o="urn:schemas-microsoft-com:office:office" xmlns:v="urn:schemas-microsoft-com:vml" xmlns:pvml="urn:schemas-microsoft-com:office:powerpoint" xmlns:com="http://schemas.openxmlformats.org/drawingml/2006/compatibility" xmlns:p14="http://schemas.microsoft.com/office/powerpoint/2010/main" xmlns:p15="http://schemas.microsoft.com/office/powerpoint/2012/main" xmlns:ahyp="http://schemas.microsoft.com/office/drawing/2018/hyperlinkcolor" showMasterPhAnim="0" showMasterSp="0">
-  <p:cSld>
-    <p:spTree>
-      <p:nvGrpSpPr>
-        <p:cNvPr id="116" name="Shape 116"/>
-        <p:cNvGrpSpPr/>
-        <p:nvPr/>
-      </p:nvGrpSpPr>
-      <p:grpSpPr>
-        <a:xfrm>
-          <a:off x="0" y="0"/>
-          <a:ext cx="0" cy="0"/>
-          <a:chOff x="0" y="0"/>
-          <a:chExt cx="0" cy="0"/>
-        </a:xfrm>
-      </p:grpSpPr>
-      <p:sp>
-        <p:nvSpPr>
-          <p:cNvPr id="117" name="Google Shape;117;h6c8d82ef383c8eb1_2_50:notes"/>
-          <p:cNvSpPr/>
-          <p:nvPr>
-            <p:ph idx="2" type="sldImg"/>
-          </p:nvPr>
-        </p:nvSpPr>
-        <p:spPr>
-          <a:xfrm>
-            <a:off x="381000" y="881063"/>
-            <a:ext cx="6096000" cy="3429000"/>
-          </a:xfrm>
-          <a:custGeom>
-            <a:rect b="b" l="l" r="r" t="t"/>
-            <a:pathLst>
-              <a:path extrusionOk="0" h="120000" w="120000">
-                <a:moveTo>
-                  <a:pt x="0" y="0"/>
-                </a:moveTo>
-                <a:lnTo>
-                  <a:pt x="120000" y="0"/>
-                </a:lnTo>
-                <a:lnTo>
-                  <a:pt x="120000" y="120000"/>
-                </a:lnTo>
-                <a:lnTo>
-                  <a:pt x="0" y="120000"/>
-                </a:lnTo>
-                <a:close/>
-              </a:path>
-            </a:pathLst>
-          </a:custGeom>
-          <a:noFill/>
-          <a:ln cap="flat" cmpd="sng" w="9525">
-            <a:solidFill>
-              <a:srgbClr val="000000"/>
-            </a:solidFill>
-            <a:prstDash val="solid"/>
-            <a:round/>
-            <a:headEnd len="sm" w="sm" type="none"/>
-            <a:tailEnd len="sm" w="sm" type="none"/>
-          </a:ln>
-        </p:spPr>
-      </p:sp>
-      <p:sp>
-        <p:nvSpPr>
-          <p:cNvPr id="118" name="Google Shape;118;h6c8d82ef383c8eb1_2_50:notes"/>
-          <p:cNvSpPr txBox="1"/>
-          <p:nvPr>
-            <p:ph idx="1" type="body"/>
-          </p:nvPr>
-        </p:nvSpPr>
-        <p:spPr>
-          <a:xfrm>
-            <a:off x="685800" y="4572000"/>
-            <a:ext cx="5486400" cy="3886200"/>
-          </a:xfrm>
-          <a:prstGeom prst="rect">
-            <a:avLst/>
-          </a:prstGeom>
-          <a:noFill/>
-          <a:ln>
-            <a:noFill/>
-          </a:ln>
-        </p:spPr>
-        <p:txBody>
-          <a:bodyPr anchorCtr="0" anchor="t" bIns="91425" lIns="91425" spcFirstLastPara="1" rIns="91425" wrap="square" tIns="91425">
-            <a:noAutofit/>
-          </a:bodyPr>
-          <a:lstStyle/>
-          <a:p>
-            <a:pPr indent="0" lvl="0" marL="0" rtl="0" algn="l">
-              <a:lnSpc>
-                <a:spcPct val="100000"/>
-              </a:lnSpc>
-              <a:spcBef>
-                <a:spcPts val="0"/>
-              </a:spcBef>
-              <a:spcAft>
-                <a:spcPts val="0"/>
-              </a:spcAft>
-              <a:buSzPts val="1100"/>
-              <a:buNone/>
-            </a:pPr>
-            <a:r>
-              <a:t/>
-            </a:r>
-            <a:endParaRPr/>
-          </a:p>
-        </p:txBody>
-      </p:sp>
-      <p:sp>
-        <p:nvSpPr>
-          <p:cNvPr id="119" name="Google Shape;119;h6c8d82ef383c8eb1_2_50:notes"/>
-          <p:cNvSpPr txBox="1"/>
-          <p:nvPr>
-            <p:ph idx="12" type="sldNum"/>
-          </p:nvPr>
-        </p:nvSpPr>
-        <p:spPr>
-          <a:xfrm>
-            <a:off x="3884613" y="8685213"/>
-            <a:ext cx="2971800" cy="457200"/>
-          </a:xfrm>
-          <a:prstGeom prst="rect">
-            <a:avLst/>
-          </a:prstGeom>
-          <a:noFill/>
-          <a:ln>
-            <a:noFill/>
-          </a:ln>
-        </p:spPr>
-        <p:txBody>
-          <a:bodyPr anchorCtr="0" anchor="ctr" bIns="89600" lIns="89600" spcFirstLastPara="1" rIns="89600" wrap="square" tIns="89600">
-            <a:noAutofit/>
-          </a:bodyPr>
-          <a:lstStyle/>
-          <a:p>
-            <a:pPr indent="0" lvl="0" marL="0" marR="0" rtl="0" algn="l">
-              <a:lnSpc>
-                <a:spcPct val="100000"/>
-              </a:lnSpc>
-              <a:spcBef>
-                <a:spcPts val="0"/>
-              </a:spcBef>
-              <a:spcAft>
-                <a:spcPts val="0"/>
-              </a:spcAft>
-              <a:buClr>
-                <a:srgbClr val="000000"/>
-              </a:buClr>
-              <a:buSzPts val="1200"/>
-              <a:buFont typeface="Arial"/>
-              <a:buNone/>
-            </a:pPr>
-            <a:fld id="{00000000-1234-1234-1234-123412341234}" type="slidenum">
-              <a:rPr b="0" i="0" lang="en" sz="1400" u="none" cap="none" strike="noStrike">
-                <a:solidFill>
-                  <a:srgbClr val="000000"/>
-                </a:solidFill>
-                <a:latin typeface="Arial"/>
-                <a:ea typeface="Arial"/>
-                <a:cs typeface="Arial"/>
-                <a:sym typeface="Arial"/>
-              </a:rPr>
-              <a:t>‹#›</a:t>
-            </a:fld>
-            <a:endParaRPr b="0" i="0" sz="1400" u="none" cap="none" strike="noStrike">
-              <a:solidFill>
-                <a:srgbClr val="000000"/>
-              </a:solidFill>
-              <a:latin typeface="Arial"/>
-              <a:ea typeface="Arial"/>
-              <a:cs typeface="Arial"/>
-              <a:sym typeface="Arial"/>
-            </a:endParaRPr>
           </a:p>
         </p:txBody>
       </p:sp>
@@ -2642,23 +2315,9 @@
           </a:bodyPr>
           <a:lstStyle/>
           <a:p>
-            <a:pPr indent="0" lvl="0" marL="0" rtl="0" algn="l">
-              <a:lnSpc>
-                <a:spcPct val="100000"/>
-              </a:lnSpc>
-              <a:spcBef>
-                <a:spcPts val="0"/>
-              </a:spcBef>
-              <a:spcAft>
-                <a:spcPts val="0"/>
-              </a:spcAft>
-              <a:buSzPts val="1100"/>
-              <a:buNone/>
-            </a:pPr>
             <a:r>
-              <a:t/>
+              <a:t>Let’s start with the problem. These two trajectories illustrate two ways an LLM judge can give a misleading reward. On the left, the model reaches the correct final answer through flawed reasoning, but receives a high reward. On the right, the strategy is sound, but a minor syntax error leads to a low reward. These are illustrative examples. The issue is that a correct final answer and a well-executed reasoning process are different things. Without explicit criteria for the behavior being evaluated, the judge can reward the wrong thing or penalize useful progress.</a:t>
             </a:r>
-            <a:endParaRPr/>
           </a:p>
         </p:txBody>
       </p:sp>
@@ -2828,7 +2487,7 @@
           <a:lstStyle/>
           <a:p>
             <a:r>
-              <a:t>Restored clipped x-axis tick labels (0–1200) on the original image. Curve pixels and vertical axis are unchanged. No new experimental values were generated.</a:t>
+              <a:t>That distinction matters during reinforcement learning. The reward is the signal that tells the policy which behaviors to repeat. If it overlooks reasoning flaws or over-penalizes small execution errors, training can reinforce the wrong behavior. The curve on the right illustrates the instability that motivates this work. Our response is to make the evaluation standard explicit and reusable, so that a step is judged against a clear intermediate objective.</a:t>
             </a:r>
           </a:p>
         </p:txBody>
@@ -2998,23 +2657,9 @@
           </a:bodyPr>
           <a:lstStyle/>
           <a:p>
-            <a:pPr indent="0" lvl="0" marL="0" rtl="0" algn="l">
-              <a:lnSpc>
-                <a:spcPct val="100000"/>
-              </a:lnSpc>
-              <a:spcBef>
-                <a:spcPts val="0"/>
-              </a:spcBef>
-              <a:spcAft>
-                <a:spcPts val="0"/>
-              </a:spcAft>
-              <a:buSzPts val="1100"/>
-              <a:buNone/>
-            </a:pPr>
             <a:r>
-              <a:t/>
+              <a:t>SCRIBE starts by identifying what each part of a trajectory is trying to accomplish. Consider a solution that factorizes a number, filters the factors, and then sums the remaining values. Each stage has a different objective and calls for a different skill. Rather than judging the entire trace with one vague standard, we evaluate whether each subgoal has been completed appropriately. This gives us a useful middle level between the final answer and individual tokens or lines of code.</a:t>
             </a:r>
-            <a:endParaRPr/>
           </a:p>
         </p:txBody>
       </p:sp>
@@ -3115,23 +2760,9 @@
           </a:bodyPr>
           <a:lstStyle/>
           <a:p>
-            <a:pPr indent="0" lvl="0" marL="0" rtl="0" algn="l">
-              <a:lnSpc>
-                <a:spcPct val="100000"/>
-              </a:lnSpc>
-              <a:spcBef>
-                <a:spcPts val="0"/>
-              </a:spcBef>
-              <a:spcAft>
-                <a:spcPts val="0"/>
-              </a:spcAft>
-              <a:buSzPts val="1100"/>
-              <a:buNone/>
-            </a:pPr>
             <a:r>
-              <a:t/>
+              <a:t>We build a library from reasoning trajectories. First, we extract subgoals, the skills they require, and the corresponding spans of reasoning. Then we group similar skills and distill each group into a skill prototype. A prototype describes when the skill applies, what successful execution looks like, and common mistakes with their scores. Crucially, it abstracts away the particular numbers and final answer. That is what makes the rubric reusable across instances.</a:t>
             </a:r>
-            <a:endParaRPr/>
           </a:p>
         </p:txBody>
       </p:sp>
@@ -3232,23 +2863,9 @@
           </a:bodyPr>
           <a:lstStyle/>
           <a:p>
-            <a:pPr indent="0" lvl="0" marL="0" rtl="0" algn="l">
-              <a:lnSpc>
-                <a:spcPct val="100000"/>
-              </a:lnSpc>
-              <a:spcBef>
-                <a:spcPts val="0"/>
-              </a:spcBef>
-              <a:spcAft>
-                <a:spcPts val="0"/>
-              </a:spcAft>
-              <a:buSzPts val="1100"/>
-              <a:buNone/>
-            </a:pPr>
             <a:r>
-              <a:t/>
+              <a:t>During training, the policy generates a trajectory. A router identifies its subgoals and matches them to the appropriate prototypes. The judge then scores each subgoal using the retrieved rubric. We aggregate these scores into a process reward and use that reward for policy optimization with GRPO. The judge still interprets the reasoning, but it now has a shared checklist to follow. The prototype library provides a consistent reference for evaluating the same skill across different rollouts.</a:t>
             </a:r>
-            <a:endParaRPr/>
           </a:p>
         </p:txBody>
       </p:sp>
@@ -3349,23 +2966,9 @@
           </a:bodyPr>
           <a:lstStyle/>
           <a:p>
-            <a:pPr indent="0" lvl="0" marL="0" rtl="0" algn="l">
-              <a:lnSpc>
-                <a:spcPct val="100000"/>
-              </a:lnSpc>
-              <a:spcBef>
-                <a:spcPts val="0"/>
-              </a:spcBef>
-              <a:spcAft>
-                <a:spcPts val="0"/>
-              </a:spcAft>
-              <a:buSzPts val="1100"/>
-              <a:buNone/>
-            </a:pPr>
             <a:r>
-              <a:t/>
+              <a:t>Here is a concrete prototype: drawing a conclusion from bounds. Suppose a solution establishes an upper bound and then claims that it is the maximum. The rubric asks whether the bound is attainable, whether the domain constraints are satisfied, and whether the relevant cases are covered. A rigorous conclusion receives the highest score. A correct-looking answer with an unproved tightness claim receives a lower score. These checks apply to many different optimization problems. We reuse the reasoning standard, without requiring a separate reference solution for each one.</a:t>
             </a:r>
-            <a:endParaRPr/>
           </a:p>
         </p:txBody>
       </p:sp>
@@ -3466,23 +3069,9 @@
           </a:bodyPr>
           <a:lstStyle/>
           <a:p>
-            <a:pPr indent="-298450" lvl="0" marL="457200" rtl="0" algn="l">
-              <a:lnSpc>
-                <a:spcPct val="100000"/>
-              </a:lnSpc>
-              <a:spcBef>
-                <a:spcPts val="0"/>
-              </a:spcBef>
-              <a:spcAft>
-                <a:spcPts val="0"/>
-              </a:spcAft>
-              <a:buSzPts val="1100"/>
-              <a:buChar char="●"/>
-            </a:pPr>
             <a:r>
-              <a:t/>
+              <a:t>A natural comparison is instance-level rubric generation. RaR uses a reference answer to construct criteria for an individual problem. This makes evaluation explicit, but the criteria depend on the reference and must be constructed for that instance. Our question is whether a shared skill-level standard can provide useful supervision without that dependency. The next results compare the two approaches on mathematical reasoning and tool use.</a:t>
             </a:r>
-            <a:endParaRPr/>
           </a:p>
         </p:txBody>
       </p:sp>
@@ -16132,6 +15721,45 @@
                 <a:hlinkClick r:id="rId9"/>
               </a:rPr>
               <a:t>Project &amp; Slides</a:t>
+            </a:r>
+          </a:p>
+        </p:txBody>
+      </p:sp>
+      <p:sp>
+        <p:nvSpPr>
+          <p:cNvPr id="120" name="TextBox 119"/>
+          <p:cNvSpPr txBox="1"/>
+          <p:nvPr/>
+        </p:nvSpPr>
+        <p:spPr>
+          <a:xfrm>
+            <a:off x="2743200" y="4315968"/>
+            <a:ext cx="3493008" cy="228600"/>
+          </a:xfrm>
+          <a:prstGeom prst="rect">
+            <a:avLst/>
+          </a:prstGeom>
+          <a:noFill/>
+        </p:spPr>
+        <p:txBody>
+          <a:bodyPr wrap="square" lIns="0" rIns="0" tIns="0" bIns="0">
+            <a:spAutoFit/>
+          </a:bodyPr>
+          <a:lstStyle/>
+          <a:p>
+            <a:pPr algn="ctr">
+              <a:spcAft>
+                <a:spcPts val="0"/>
+              </a:spcAft>
+              <a:defRPr sz="1300">
+                <a:solidFill>
+                  <a:srgbClr val="193354"/>
+                </a:solidFill>
+                <a:latin typeface="Arial"/>
+              </a:defRPr>
+            </a:pPr>
+            <a:r>
+              <a:t>yuxuanj1@umbc.edu</a:t>
             </a:r>
           </a:p>
         </p:txBody>
@@ -30421,360 +30049,8 @@
 </p:sld>
 </file>
 
-<file path=ppt/slides/slide2.xml><?xml version="1.0" encoding="utf-8"?>
-<p:sld xmlns:a="http://schemas.openxmlformats.org/drawingml/2006/main" xmlns:r="http://schemas.openxmlformats.org/officeDocument/2006/relationships" xmlns:mc="http://schemas.openxmlformats.org/markup-compatibility/2006" xmlns:mv="urn:schemas-microsoft-com:mac:vml" xmlns:p="http://schemas.openxmlformats.org/presentationml/2006/main" xmlns:c="http://schemas.openxmlformats.org/drawingml/2006/chart" xmlns:dgm="http://schemas.openxmlformats.org/drawingml/2006/diagram" xmlns:o="urn:schemas-microsoft-com:office:office" xmlns:v="urn:schemas-microsoft-com:vml" xmlns:pvml="urn:schemas-microsoft-com:office:powerpoint" xmlns:com="http://schemas.openxmlformats.org/drawingml/2006/compatibility" xmlns:p14="http://schemas.microsoft.com/office/powerpoint/2010/main" xmlns:p15="http://schemas.microsoft.com/office/powerpoint/2012/main" xmlns:ahyp="http://schemas.microsoft.com/office/drawing/2018/hyperlinkcolor">
-  <p:cSld>
-    <p:spTree>
-      <p:nvGrpSpPr>
-        <p:cNvPr id="120" name="Shape 120"/>
-        <p:cNvGrpSpPr/>
-        <p:nvPr/>
-      </p:nvGrpSpPr>
-      <p:grpSpPr>
-        <a:xfrm>
-          <a:off x="0" y="0"/>
-          <a:ext cx="0" cy="0"/>
-          <a:chOff x="0" y="0"/>
-          <a:chExt cx="0" cy="0"/>
-        </a:xfrm>
-      </p:grpSpPr>
-      <p:sp>
-        <p:nvSpPr>
-          <p:cNvPr id="121" name="Google Shape;121;p30"/>
-          <p:cNvSpPr txBox="1"/>
-          <p:nvPr>
-            <p:ph idx="1" type="body"/>
-          </p:nvPr>
-        </p:nvSpPr>
-        <p:spPr>
-          <a:xfrm>
-            <a:off x="419100" y="857250"/>
-            <a:ext cx="8305800" cy="4000500"/>
-          </a:xfrm>
-          <a:prstGeom prst="rect">
-            <a:avLst/>
-          </a:prstGeom>
-          <a:noFill/>
-          <a:ln>
-            <a:noFill/>
-          </a:ln>
-        </p:spPr>
-        <p:txBody>
-          <a:bodyPr anchorCtr="0" anchor="t" bIns="34275" lIns="68575" spcFirstLastPara="1" rIns="68575" wrap="square" tIns="34275">
-            <a:noAutofit/>
-          </a:bodyPr>
-          <a:lstStyle/>
-          <a:p>
-            <a:pPr indent="0" lvl="0" marL="0" rtl="0" algn="l">
-              <a:lnSpc>
-                <a:spcPct val="115000"/>
-              </a:lnSpc>
-              <a:spcBef>
-                <a:spcPts val="900"/>
-              </a:spcBef>
-              <a:spcAft>
-                <a:spcPts val="0"/>
-              </a:spcAft>
-              <a:buSzPts val="1400"/>
-              <a:buNone/>
-            </a:pPr>
-            <a:r>
-              <a:rPr b="1" lang="en" sz="1100">
-                <a:solidFill>
-                  <a:schemeClr val="dk1"/>
-                </a:solidFill>
-                <a:latin typeface="Arial"/>
-                <a:ea typeface="Arial"/>
-                <a:cs typeface="Arial"/>
-                <a:sym typeface="Arial"/>
-              </a:rPr>
-              <a:t>Over-rewarding:</a:t>
-            </a:r>
-            <a:r>
-              <a:rPr lang="en" sz="1100">
-                <a:solidFill>
-                  <a:schemeClr val="dk1"/>
-                </a:solidFill>
-                <a:latin typeface="Arial"/>
-                <a:ea typeface="Arial"/>
-                <a:cs typeface="Arial"/>
-                <a:sym typeface="Arial"/>
-              </a:rPr>
-              <a:t> Correct Answer + Flawed Logic </a:t>
-            </a:r>
-            <a:endParaRPr b="1" sz="1100">
-              <a:solidFill>
-                <a:schemeClr val="dk1"/>
-              </a:solidFill>
-              <a:latin typeface="Arial"/>
-              <a:ea typeface="Arial"/>
-              <a:cs typeface="Arial"/>
-              <a:sym typeface="Arial"/>
-            </a:endParaRPr>
-          </a:p>
-          <a:p>
-            <a:pPr indent="0" lvl="0" marL="0" rtl="0" algn="l">
-              <a:lnSpc>
-                <a:spcPct val="115000"/>
-              </a:lnSpc>
-              <a:spcBef>
-                <a:spcPts val="900"/>
-              </a:spcBef>
-              <a:spcAft>
-                <a:spcPts val="0"/>
-              </a:spcAft>
-              <a:buSzPts val="1400"/>
-              <a:buNone/>
-            </a:pPr>
-            <a:r>
-              <a:rPr b="1" lang="en" sz="1100">
-                <a:solidFill>
-                  <a:schemeClr val="dk1"/>
-                </a:solidFill>
-                <a:latin typeface="Arial"/>
-                <a:ea typeface="Arial"/>
-                <a:cs typeface="Arial"/>
-                <a:sym typeface="Arial"/>
-              </a:rPr>
-              <a:t>Over-penalizing:</a:t>
-            </a:r>
-            <a:r>
-              <a:rPr lang="en" sz="1100">
-                <a:solidFill>
-                  <a:schemeClr val="dk1"/>
-                </a:solidFill>
-                <a:latin typeface="Arial"/>
-                <a:ea typeface="Arial"/>
-                <a:cs typeface="Arial"/>
-                <a:sym typeface="Arial"/>
-              </a:rPr>
-              <a:t> Sound Strategy + Minor Syntax Error </a:t>
-            </a:r>
-            <a:endParaRPr b="1" sz="1100">
-              <a:solidFill>
-                <a:schemeClr val="dk1"/>
-              </a:solidFill>
-              <a:latin typeface="Arial"/>
-              <a:ea typeface="Arial"/>
-              <a:cs typeface="Arial"/>
-              <a:sym typeface="Arial"/>
-            </a:endParaRPr>
-          </a:p>
-          <a:p>
-            <a:pPr indent="0" lvl="0" marL="342900" rtl="0" algn="l">
-              <a:lnSpc>
-                <a:spcPct val="115000"/>
-              </a:lnSpc>
-              <a:spcBef>
-                <a:spcPts val="900"/>
-              </a:spcBef>
-              <a:spcAft>
-                <a:spcPts val="0"/>
-              </a:spcAft>
-              <a:buSzPts val="1400"/>
-              <a:buNone/>
-            </a:pPr>
-            <a:br>
-              <a:rPr lang="en" sz="1500">
-                <a:solidFill>
-                  <a:schemeClr val="dk1"/>
-                </a:solidFill>
-                <a:latin typeface="Arial"/>
-                <a:ea typeface="Arial"/>
-                <a:cs typeface="Arial"/>
-                <a:sym typeface="Arial"/>
-              </a:rPr>
-            </a:br>
-            <a:endParaRPr sz="1500">
-              <a:solidFill>
-                <a:schemeClr val="dk1"/>
-              </a:solidFill>
-              <a:latin typeface="Arial"/>
-              <a:ea typeface="Arial"/>
-              <a:cs typeface="Arial"/>
-              <a:sym typeface="Arial"/>
-            </a:endParaRPr>
-          </a:p>
-          <a:p>
-            <a:pPr indent="0" lvl="0" marL="0" rtl="0" algn="l">
-              <a:lnSpc>
-                <a:spcPct val="100000"/>
-              </a:lnSpc>
-              <a:spcBef>
-                <a:spcPts val="900"/>
-              </a:spcBef>
-              <a:spcAft>
-                <a:spcPts val="0"/>
-              </a:spcAft>
-              <a:buSzPts val="1400"/>
-              <a:buNone/>
-            </a:pPr>
-            <a:r>
-              <a:t/>
-            </a:r>
-            <a:endParaRPr/>
-          </a:p>
-        </p:txBody>
-      </p:sp>
-      <p:sp>
-        <p:nvSpPr>
-          <p:cNvPr id="122" name="Google Shape;122;p30"/>
-          <p:cNvSpPr txBox="1"/>
-          <p:nvPr>
-            <p:ph type="ctrTitle"/>
-          </p:nvPr>
-        </p:nvSpPr>
-        <p:spPr>
-          <a:xfrm>
-            <a:off x="438912" y="164592"/>
-            <a:ext cx="8266200" cy="475500"/>
-          </a:xfrm>
-          <a:prstGeom prst="rect">
-            <a:avLst/>
-          </a:prstGeom>
-          <a:noFill/>
-          <a:ln>
-            <a:noFill/>
-          </a:ln>
-        </p:spPr>
-        <p:txBody>
-          <a:bodyPr anchorCtr="0" anchor="t" bIns="91425" lIns="0" spcFirstLastPara="1" rIns="0" wrap="square" tIns="91425">
-            <a:normAutofit fontScale="90000"/>
-          </a:bodyPr>
-          <a:lstStyle/>
-          <a:p>
-            <a:pPr indent="0" lvl="0" marL="0" rtl="0" algn="l">
-              <a:lnSpc>
-                <a:spcPct val="100000"/>
-              </a:lnSpc>
-              <a:spcBef>
-                <a:spcPts val="0"/>
-              </a:spcBef>
-              <a:spcAft>
-                <a:spcPts val="0"/>
-              </a:spcAft>
-              <a:buSzPct val="96618"/>
-              <a:buNone/>
-            </a:pPr>
-            <a:r>
-              <a:rPr b="1" lang="en" sz="2300">
-                <a:solidFill>
-                  <a:srgbClr val="162849"/>
-                </a:solidFill>
-                <a:latin typeface="Play"/>
-                <a:ea typeface="Play"/>
-                <a:cs typeface="Play"/>
-                <a:sym typeface="Play"/>
-              </a:rPr>
-              <a:t>Motivation: Unreliable Reward Leads to Unreliable RL Training</a:t>
-            </a:r>
-            <a:endParaRPr/>
-          </a:p>
-        </p:txBody>
-      </p:sp>
-      <p:pic>
-        <p:nvPicPr>
-          <p:cNvPr id="123" name="Google Shape;123;p30"/>
-          <p:cNvPicPr preferRelativeResize="0"/>
-          <p:nvPr/>
-        </p:nvPicPr>
-        <p:blipFill rotWithShape="1">
-          <a:blip r:embed="rId4">
-            <a:alphaModFix/>
-          </a:blip>
-          <a:srcRect b="0" l="0" r="0" t="0"/>
-          <a:stretch/>
-        </p:blipFill>
-        <p:spPr>
-          <a:xfrm>
-            <a:off x="0" y="1490500"/>
-            <a:ext cx="5313174" cy="3272275"/>
-          </a:xfrm>
-          <a:prstGeom prst="rect">
-            <a:avLst/>
-          </a:prstGeom>
-          <a:noFill/>
-          <a:ln>
-            <a:noFill/>
-          </a:ln>
-        </p:spPr>
-      </p:pic>
-      <p:sp>
-        <p:nvSpPr>
-          <p:cNvPr id="124" name="Google Shape;124;p30"/>
-          <p:cNvSpPr/>
-          <p:nvPr/>
-        </p:nvSpPr>
-        <p:spPr>
-          <a:xfrm>
-            <a:off x="438912" y="740664"/>
-            <a:ext cx="8266200" cy="13800"/>
-          </a:xfrm>
-          <a:prstGeom prst="rect">
-            <a:avLst/>
-          </a:prstGeom>
-          <a:solidFill>
-            <a:srgbClr val="DAE1EB"/>
-          </a:solidFill>
-          <a:ln>
-            <a:noFill/>
-          </a:ln>
-          <a:effectLst>
-            <a:outerShdw blurRad="40000" rotWithShape="0" dir="5400000" dist="23000">
-              <a:srgbClr val="000000">
-                <a:alpha val="34902"/>
-              </a:srgbClr>
-            </a:outerShdw>
-          </a:effectLst>
-        </p:spPr>
-        <p:txBody>
-          <a:bodyPr anchorCtr="0" anchor="ctr" bIns="45700" lIns="91425" spcFirstLastPara="1" rIns="91425" wrap="square" tIns="45700">
-            <a:noAutofit/>
-          </a:bodyPr>
-          <a:lstStyle/>
-          <a:p>
-            <a:pPr indent="0" lvl="0" marL="0" marR="0" rtl="0" algn="ctr">
-              <a:lnSpc>
-                <a:spcPct val="100000"/>
-              </a:lnSpc>
-              <a:spcBef>
-                <a:spcPts val="0"/>
-              </a:spcBef>
-              <a:spcAft>
-                <a:spcPts val="0"/>
-              </a:spcAft>
-              <a:buClr>
-                <a:srgbClr val="000000"/>
-              </a:buClr>
-              <a:buSzPts val="1400"/>
-              <a:buFont typeface="Arial"/>
-              <a:buNone/>
-            </a:pPr>
-            <a:r>
-              <a:t/>
-            </a:r>
-            <a:endParaRPr b="0" i="0" sz="1400" u="none" cap="none" strike="noStrike">
-              <a:solidFill>
-                <a:schemeClr val="lt1"/>
-              </a:solidFill>
-              <a:latin typeface="Arial"/>
-              <a:ea typeface="Arial"/>
-              <a:cs typeface="Arial"/>
-              <a:sym typeface="Arial"/>
-            </a:endParaRPr>
-          </a:p>
-        </p:txBody>
-      </p:sp>
-    </p:spTree>
-  </p:cSld>
-  <p:clrMapOvr>
-    <a:masterClrMapping/>
-  </p:clrMapOvr>
-</p:sld>
-</file>
-
 <file path=ppt/slides/slide3.xml><?xml version="1.0" encoding="utf-8"?>
-<p:sld xmlns:a="http://schemas.openxmlformats.org/drawingml/2006/main" xmlns:r="http://schemas.openxmlformats.org/officeDocument/2006/relationships" xmlns:mc="http://schemas.openxmlformats.org/markup-compatibility/2006" xmlns:mv="urn:schemas-microsoft-com:mac:vml" xmlns:p="http://schemas.openxmlformats.org/presentationml/2006/main" xmlns:c="http://schemas.openxmlformats.org/drawingml/2006/chart" xmlns:dgm="http://schemas.openxmlformats.org/drawingml/2006/diagram" xmlns:o="urn:schemas-microsoft-com:office:office" xmlns:v="urn:schemas-microsoft-com:vml" xmlns:pvml="urn:schemas-microsoft-com:office:powerpoint" xmlns:com="http://schemas.openxmlformats.org/drawingml/2006/compatibility" xmlns:p14="http://schemas.microsoft.com/office/powerpoint/2010/main" xmlns:p15="http://schemas.microsoft.com/office/powerpoint/2012/main" xmlns:ahyp="http://schemas.microsoft.com/office/drawing/2018/hyperlinkcolor" show="0">
+<p:sld xmlns:a="http://schemas.openxmlformats.org/drawingml/2006/main" xmlns:r="http://schemas.openxmlformats.org/officeDocument/2006/relationships" xmlns:mc="http://schemas.openxmlformats.org/markup-compatibility/2006" xmlns:mv="urn:schemas-microsoft-com:mac:vml" xmlns:p="http://schemas.openxmlformats.org/presentationml/2006/main" xmlns:c="http://schemas.openxmlformats.org/drawingml/2006/chart" xmlns:dgm="http://schemas.openxmlformats.org/drawingml/2006/diagram" xmlns:o="urn:schemas-microsoft-com:office:office" xmlns:v="urn:schemas-microsoft-com:vml" xmlns:pvml="urn:schemas-microsoft-com:office:powerpoint" xmlns:com="http://schemas.openxmlformats.org/drawingml/2006/compatibility" xmlns:p14="http://schemas.microsoft.com/office/powerpoint/2010/main" xmlns:p15="http://schemas.microsoft.com/office/powerpoint/2012/main" xmlns:ahyp="http://schemas.microsoft.com/office/drawing/2018/hyperlinkcolor" show="1">
   <p:cSld>
     <p:spTree>
       <p:nvGrpSpPr>
@@ -30976,7 +30252,7 @@
                 <a:cs typeface="Play"/>
                 <a:sym typeface="Play"/>
               </a:rPr>
-              <a:t>Motivation: Unreliable Reward Leads to Unreliable RL Training</a:t>
+              <a:t>Unreliable LLM-as-a-Judge Reward</a:t>
             </a:r>
             <a:endParaRPr/>
           </a:p>
@@ -30984,16 +30260,17 @@
       </p:sp>
       <p:pic>
         <p:nvPicPr>
-          <p:cNvPr id="132" name="Google Shape;132;p31"/>
-          <p:cNvPicPr preferRelativeResize="0"/>
+          <p:cNvPr id="136" name="Picture 135" descr="reward-illustration-editable-background.png"/>
+          <p:cNvPicPr>
+            <a:picLocks noChangeAspect="1"/>
+          </p:cNvPicPr>
           <p:nvPr/>
         </p:nvPicPr>
-        <p:blipFill rotWithShape="1">
-          <a:blip r:embed="rId4">
-            <a:alphaModFix/>
-          </a:blip>
-          <a:srcRect b="8817" l="0" r="0" t="0"/>
-          <a:stretch/>
+        <p:blipFill>
+          <a:blip r:embed="rId5"/>
+          <a:stretch>
+            <a:fillRect/>
+          </a:stretch>
         </p:blipFill>
         <p:spPr>
           <a:xfrm>
@@ -31003,10 +30280,6 @@
           <a:prstGeom prst="rect">
             <a:avLst/>
           </a:prstGeom>
-          <a:noFill/>
-          <a:ln>
-            <a:noFill/>
-          </a:ln>
         </p:spPr>
       </p:pic>
       <p:sp>
@@ -31200,6 +30473,148 @@
               <a:t>Sound Strategy + Minor Syntax Error </a:t>
             </a:r>
             <a:endParaRPr/>
+          </a:p>
+        </p:txBody>
+      </p:sp>
+      <p:sp>
+        <p:nvSpPr>
+          <p:cNvPr id="137" name="TextBox 136"/>
+          <p:cNvSpPr txBox="1"/>
+          <p:nvPr/>
+        </p:nvSpPr>
+        <p:spPr>
+          <a:xfrm>
+            <a:off x="2177901" y="3760126"/>
+            <a:ext cx="1394186" cy="367791"/>
+          </a:xfrm>
+          <a:prstGeom prst="rect">
+            <a:avLst/>
+          </a:prstGeom>
+          <a:noFill/>
+        </p:spPr>
+        <p:txBody>
+          <a:bodyPr wrap="square" lIns="0" rIns="0" tIns="0" bIns="0">
+            <a:spAutoFit/>
+          </a:bodyPr>
+          <a:lstStyle/>
+          <a:p>
+            <a:pPr algn="l">
+              <a:spcAft>
+                <a:spcPts val="0"/>
+              </a:spcAft>
+              <a:defRPr sz="958">
+                <a:solidFill>
+                  <a:srgbClr val="193354"/>
+                </a:solidFill>
+                <a:latin typeface="Arial"/>
+              </a:defRPr>
+            </a:pPr>
+            <a:r>
+              <a:t>Correct final answer;</a:t>
+            </a:r>
+          </a:p>
+          <a:p>
+            <a:pPr algn="l">
+              <a:spcAft>
+                <a:spcPts val="0"/>
+              </a:spcAft>
+              <a:defRPr sz="958">
+                <a:solidFill>
+                  <a:srgbClr val="193354"/>
+                </a:solidFill>
+                <a:latin typeface="Arial"/>
+              </a:defRPr>
+            </a:pPr>
+            <a:r>
+              <a:t>flawed reasoning.</a:t>
+            </a:r>
+          </a:p>
+          <a:p>
+            <a:pPr algn="l">
+              <a:spcAft>
+                <a:spcPts val="0"/>
+              </a:spcAft>
+              <a:defRPr sz="958">
+                <a:solidFill>
+                  <a:srgbClr val="193354"/>
+                </a:solidFill>
+                <a:latin typeface="Arial"/>
+              </a:defRPr>
+            </a:pPr>
+            <a:r>
+              <a:t>High reward.</a:t>
+            </a:r>
+          </a:p>
+        </p:txBody>
+      </p:sp>
+      <p:sp>
+        <p:nvSpPr>
+          <p:cNvPr id="138" name="TextBox 137"/>
+          <p:cNvSpPr txBox="1"/>
+          <p:nvPr/>
+        </p:nvSpPr>
+        <p:spPr>
+          <a:xfrm>
+            <a:off x="5185486" y="3752131"/>
+            <a:ext cx="1297733" cy="463737"/>
+          </a:xfrm>
+          <a:prstGeom prst="rect">
+            <a:avLst/>
+          </a:prstGeom>
+          <a:noFill/>
+        </p:spPr>
+        <p:txBody>
+          <a:bodyPr wrap="square" lIns="0" rIns="0" tIns="0" bIns="0">
+            <a:spAutoFit/>
+          </a:bodyPr>
+          <a:lstStyle/>
+          <a:p>
+            <a:pPr algn="l">
+              <a:spcAft>
+                <a:spcPts val="0"/>
+              </a:spcAft>
+              <a:defRPr sz="958">
+                <a:solidFill>
+                  <a:srgbClr val="193354"/>
+                </a:solidFill>
+                <a:latin typeface="Arial"/>
+              </a:defRPr>
+            </a:pPr>
+            <a:r>
+              <a:t>Sound strategy;</a:t>
+            </a:r>
+          </a:p>
+          <a:p>
+            <a:pPr algn="l">
+              <a:spcAft>
+                <a:spcPts val="0"/>
+              </a:spcAft>
+              <a:defRPr sz="958">
+                <a:solidFill>
+                  <a:srgbClr val="193354"/>
+                </a:solidFill>
+                <a:latin typeface="Arial"/>
+              </a:defRPr>
+            </a:pPr>
+            <a:r>
+              <a:t>minor syntax error.</a:t>
+            </a:r>
+          </a:p>
+          <a:p>
+            <a:pPr algn="l">
+              <a:spcAft>
+                <a:spcPts val="0"/>
+              </a:spcAft>
+              <a:defRPr sz="958">
+                <a:solidFill>
+                  <a:srgbClr val="193354"/>
+                </a:solidFill>
+                <a:latin typeface="Arial"/>
+              </a:defRPr>
+            </a:pPr>
+            <a:r>
+              <a:t>Low reward.</a:t>
+            </a:r>
           </a:p>
         </p:txBody>
       </p:sp>
@@ -31464,16 +30879,17 @@
       </p:sp>
       <p:pic>
         <p:nvPicPr>
-          <p:cNvPr id="143" name="Google Shape;143;p32"/>
-          <p:cNvPicPr preferRelativeResize="0"/>
+          <p:cNvPr id="148" name="Picture 147" descr="reward-illustration-editable-background.png"/>
+          <p:cNvPicPr>
+            <a:picLocks noChangeAspect="1"/>
+          </p:cNvPicPr>
           <p:nvPr/>
         </p:nvPicPr>
-        <p:blipFill rotWithShape="1">
-          <a:blip r:embed="rId4">
-            <a:alphaModFix/>
-          </a:blip>
-          <a:srcRect b="0" l="0" r="0" t="0"/>
-          <a:stretch/>
+        <p:blipFill>
+          <a:blip r:embed="rId7"/>
+          <a:stretch>
+            <a:fillRect/>
+          </a:stretch>
         </p:blipFill>
         <p:spPr>
           <a:xfrm>
@@ -31483,10 +30899,6 @@
           <a:prstGeom prst="rect">
             <a:avLst/>
           </a:prstGeom>
-          <a:noFill/>
-          <a:ln>
-            <a:noFill/>
-          </a:ln>
         </p:spPr>
       </p:pic>
       <p:sp>
@@ -31645,6 +31057,148 @@
           </a:prstGeom>
         </p:spPr>
       </p:pic>
+      <p:sp>
+        <p:nvSpPr>
+          <p:cNvPr id="149" name="TextBox 148"/>
+          <p:cNvSpPr txBox="1"/>
+          <p:nvPr/>
+        </p:nvSpPr>
+        <p:spPr>
+          <a:xfrm>
+            <a:off x="727925" y="4007634"/>
+            <a:ext cx="1081683" cy="312941"/>
+          </a:xfrm>
+          <a:prstGeom prst="rect">
+            <a:avLst/>
+          </a:prstGeom>
+          <a:noFill/>
+        </p:spPr>
+        <p:txBody>
+          <a:bodyPr wrap="square" lIns="0" rIns="0" tIns="0" bIns="0">
+            <a:spAutoFit/>
+          </a:bodyPr>
+          <a:lstStyle/>
+          <a:p>
+            <a:pPr algn="l">
+              <a:spcAft>
+                <a:spcPts val="0"/>
+              </a:spcAft>
+              <a:defRPr sz="743">
+                <a:solidFill>
+                  <a:srgbClr val="193354"/>
+                </a:solidFill>
+                <a:latin typeface="Arial"/>
+              </a:defRPr>
+            </a:pPr>
+            <a:r>
+              <a:t>Correct final answer;</a:t>
+            </a:r>
+          </a:p>
+          <a:p>
+            <a:pPr algn="l">
+              <a:spcAft>
+                <a:spcPts val="0"/>
+              </a:spcAft>
+              <a:defRPr sz="743">
+                <a:solidFill>
+                  <a:srgbClr val="193354"/>
+                </a:solidFill>
+                <a:latin typeface="Arial"/>
+              </a:defRPr>
+            </a:pPr>
+            <a:r>
+              <a:t>flawed reasoning.</a:t>
+            </a:r>
+          </a:p>
+          <a:p>
+            <a:pPr algn="l">
+              <a:spcAft>
+                <a:spcPts val="0"/>
+              </a:spcAft>
+              <a:defRPr sz="743">
+                <a:solidFill>
+                  <a:srgbClr val="193354"/>
+                </a:solidFill>
+                <a:latin typeface="Arial"/>
+              </a:defRPr>
+            </a:pPr>
+            <a:r>
+              <a:t>High reward.</a:t>
+            </a:r>
+          </a:p>
+        </p:txBody>
+      </p:sp>
+      <p:sp>
+        <p:nvSpPr>
+          <p:cNvPr id="150" name="TextBox 149"/>
+          <p:cNvSpPr txBox="1"/>
+          <p:nvPr/>
+        </p:nvSpPr>
+        <p:spPr>
+          <a:xfrm>
+            <a:off x="3061367" y="4000831"/>
+            <a:ext cx="1006849" cy="394577"/>
+          </a:xfrm>
+          <a:prstGeom prst="rect">
+            <a:avLst/>
+          </a:prstGeom>
+          <a:noFill/>
+        </p:spPr>
+        <p:txBody>
+          <a:bodyPr wrap="square" lIns="0" rIns="0" tIns="0" bIns="0">
+            <a:spAutoFit/>
+          </a:bodyPr>
+          <a:lstStyle/>
+          <a:p>
+            <a:pPr algn="l">
+              <a:spcAft>
+                <a:spcPts val="0"/>
+              </a:spcAft>
+              <a:defRPr sz="743">
+                <a:solidFill>
+                  <a:srgbClr val="193354"/>
+                </a:solidFill>
+                <a:latin typeface="Arial"/>
+              </a:defRPr>
+            </a:pPr>
+            <a:r>
+              <a:t>Sound strategy;</a:t>
+            </a:r>
+          </a:p>
+          <a:p>
+            <a:pPr algn="l">
+              <a:spcAft>
+                <a:spcPts val="0"/>
+              </a:spcAft>
+              <a:defRPr sz="743">
+                <a:solidFill>
+                  <a:srgbClr val="193354"/>
+                </a:solidFill>
+                <a:latin typeface="Arial"/>
+              </a:defRPr>
+            </a:pPr>
+            <a:r>
+              <a:t>minor syntax error.</a:t>
+            </a:r>
+          </a:p>
+          <a:p>
+            <a:pPr algn="l">
+              <a:spcAft>
+                <a:spcPts val="0"/>
+              </a:spcAft>
+              <a:defRPr sz="743">
+                <a:solidFill>
+                  <a:srgbClr val="193354"/>
+                </a:solidFill>
+                <a:latin typeface="Arial"/>
+              </a:defRPr>
+            </a:pPr>
+            <a:r>
+              <a:t>Low reward.</a:t>
+            </a:r>
+          </a:p>
+        </p:txBody>
+      </p:sp>
     </p:spTree>
   </p:cSld>
   <p:clrMapOvr>

</xml_diff>

<commit_message>
Update reward illustration wording and include editable source
</commit_message>
<xml_diff>
--- a/slides/SCRIBE_EMNLP2026.pptx
+++ b/slides/SCRIBE_EMNLP2026.pptx
@@ -15777,834 +15777,6 @@
   <p:cSld>
     <p:spTree>
       <p:nvGrpSpPr>
-        <p:cNvPr id="209" name="Shape 209"/>
-        <p:cNvGrpSpPr/>
-        <p:nvPr/>
-      </p:nvGrpSpPr>
-      <p:grpSpPr>
-        <a:xfrm>
-          <a:off x="0" y="0"/>
-          <a:ext cx="0" cy="0"/>
-          <a:chOff x="0" y="0"/>
-          <a:chExt cx="0" cy="0"/>
-        </a:xfrm>
-      </p:grpSpPr>
-      <p:sp>
-        <p:nvSpPr>
-          <p:cNvPr id="210" name="Google Shape;210;p38"/>
-          <p:cNvSpPr/>
-          <p:nvPr/>
-        </p:nvSpPr>
-        <p:spPr>
-          <a:xfrm>
-            <a:off x="438912" y="740664"/>
-            <a:ext cx="8266200" cy="13800"/>
-          </a:xfrm>
-          <a:prstGeom prst="rect">
-            <a:avLst/>
-          </a:prstGeom>
-          <a:solidFill>
-            <a:srgbClr val="DAE1EB"/>
-          </a:solidFill>
-          <a:ln>
-            <a:noFill/>
-          </a:ln>
-          <a:effectLst>
-            <a:outerShdw blurRad="40000" rotWithShape="0" dir="5400000" dist="23000">
-              <a:srgbClr val="000000">
-                <a:alpha val="34900"/>
-              </a:srgbClr>
-            </a:outerShdw>
-          </a:effectLst>
-        </p:spPr>
-        <p:txBody>
-          <a:bodyPr anchorCtr="0" anchor="ctr" bIns="45700" lIns="91425" spcFirstLastPara="1" rIns="91425" wrap="square" tIns="45700">
-            <a:noAutofit/>
-          </a:bodyPr>
-          <a:lstStyle/>
-          <a:p>
-            <a:pPr indent="0" lvl="0" marL="0" marR="0" rtl="0" algn="ctr">
-              <a:lnSpc>
-                <a:spcPct val="100000"/>
-              </a:lnSpc>
-              <a:spcBef>
-                <a:spcPts val="0"/>
-              </a:spcBef>
-              <a:spcAft>
-                <a:spcPts val="0"/>
-              </a:spcAft>
-              <a:buClr>
-                <a:srgbClr val="000000"/>
-              </a:buClr>
-              <a:buSzPts val="1400"/>
-              <a:buFont typeface="Arial"/>
-              <a:buNone/>
-            </a:pPr>
-            <a:r>
-              <a:t/>
-            </a:r>
-            <a:endParaRPr b="0" i="0" sz="1400" u="none" cap="none" strike="noStrike">
-              <a:solidFill>
-                <a:schemeClr val="lt1"/>
-              </a:solidFill>
-              <a:latin typeface="Arial"/>
-              <a:ea typeface="Arial"/>
-              <a:cs typeface="Arial"/>
-              <a:sym typeface="Arial"/>
-            </a:endParaRPr>
-          </a:p>
-        </p:txBody>
-      </p:sp>
-      <p:sp>
-        <p:nvSpPr>
-          <p:cNvPr id="211" name="Google Shape;211;p38"/>
-          <p:cNvSpPr txBox="1"/>
-          <p:nvPr/>
-        </p:nvSpPr>
-        <p:spPr>
-          <a:xfrm>
-            <a:off x="438912" y="164592"/>
-            <a:ext cx="8321100" cy="354000"/>
-          </a:xfrm>
-          <a:prstGeom prst="rect">
-            <a:avLst/>
-          </a:prstGeom>
-          <a:noFill/>
-          <a:ln>
-            <a:noFill/>
-          </a:ln>
-        </p:spPr>
-        <p:txBody>
-          <a:bodyPr anchorCtr="0" anchor="t" bIns="0" lIns="0" spcFirstLastPara="1" rIns="0" wrap="square" tIns="0">
-            <a:spAutoFit/>
-          </a:bodyPr>
-          <a:lstStyle/>
-          <a:p>
-            <a:pPr indent="0" lvl="0" marL="0" marR="0" rtl="0" algn="l">
-              <a:lnSpc>
-                <a:spcPct val="100000"/>
-              </a:lnSpc>
-              <a:spcBef>
-                <a:spcPts val="0"/>
-              </a:spcBef>
-              <a:spcAft>
-                <a:spcPts val="0"/>
-              </a:spcAft>
-              <a:buNone/>
-            </a:pPr>
-            <a:r>
-              <a:rPr b="1" i="0" lang="en" sz="2300" u="none" cap="none" strike="noStrike">
-                <a:solidFill>
-                  <a:srgbClr val="183153"/>
-                </a:solidFill>
-                <a:latin typeface="Arial"/>
-                <a:ea typeface="Arial"/>
-                <a:cs typeface="Arial"/>
-                <a:sym typeface="Arial"/>
-              </a:rPr>
-              <a:t>Reference Quality Matters for Instance-Level Rubrics</a:t>
-            </a:r>
-            <a:endParaRPr/>
-          </a:p>
-        </p:txBody>
-      </p:sp>
-      <p:sp>
-        <p:nvSpPr>
-          <p:cNvPr id="212" name="Google Shape;212;p38"/>
-          <p:cNvSpPr txBox="1"/>
-          <p:nvPr/>
-        </p:nvSpPr>
-        <p:spPr>
-          <a:xfrm>
-            <a:off x="530352" y="941832"/>
-            <a:ext cx="8138100" cy="461700"/>
-          </a:xfrm>
-          <a:prstGeom prst="rect">
-            <a:avLst/>
-          </a:prstGeom>
-          <a:noFill/>
-          <a:ln>
-            <a:noFill/>
-          </a:ln>
-        </p:spPr>
-        <p:txBody>
-          <a:bodyPr anchorCtr="0" anchor="t" bIns="0" lIns="0" spcFirstLastPara="1" rIns="0" wrap="square" tIns="0">
-            <a:spAutoFit/>
-          </a:bodyPr>
-          <a:lstStyle/>
-          <a:p>
-            <a:pPr indent="0" lvl="0" marL="0" marR="0" rtl="0" algn="l">
-              <a:lnSpc>
-                <a:spcPct val="100000"/>
-              </a:lnSpc>
-              <a:spcBef>
-                <a:spcPts val="0"/>
-              </a:spcBef>
-              <a:spcAft>
-                <a:spcPts val="0"/>
-              </a:spcAft>
-              <a:buNone/>
-            </a:pPr>
-            <a:r>
-              <a:rPr b="0" i="0" lang="en" sz="1500" u="none" cap="none" strike="noStrike">
-                <a:solidFill>
-                  <a:srgbClr val="183153"/>
-                </a:solidFill>
-                <a:latin typeface="Arial"/>
-                <a:ea typeface="Arial"/>
-                <a:cs typeface="Arial"/>
-                <a:sym typeface="Arial"/>
-              </a:rPr>
-              <a:t>RaR builds a rubric from each problem’s reference answer.</a:t>
-            </a:r>
-            <a:endParaRPr/>
-          </a:p>
-          <a:p>
-            <a:pPr indent="0" lvl="0" marL="0" marR="0" rtl="0" algn="l">
-              <a:lnSpc>
-                <a:spcPct val="100000"/>
-              </a:lnSpc>
-              <a:spcBef>
-                <a:spcPts val="0"/>
-              </a:spcBef>
-              <a:spcAft>
-                <a:spcPts val="0"/>
-              </a:spcAft>
-              <a:buNone/>
-            </a:pPr>
-            <a:r>
-              <a:rPr b="0" i="0" lang="en" sz="1500" u="none" cap="none" strike="noStrike">
-                <a:solidFill>
-                  <a:srgbClr val="183153"/>
-                </a:solidFill>
-                <a:latin typeface="Arial"/>
-                <a:ea typeface="Arial"/>
-                <a:cs typeface="Arial"/>
-                <a:sym typeface="Arial"/>
-              </a:rPr>
-              <a:t>SCRIBE reuses skill rubrics without requiring golden reference answers.</a:t>
-            </a:r>
-            <a:endParaRPr/>
-          </a:p>
-        </p:txBody>
-      </p:sp>
-      <p:graphicFrame>
-        <p:nvGraphicFramePr>
-          <p:cNvPr id="213" name="Google Shape;213;p38"/>
-          <p:cNvGraphicFramePr/>
-          <p:nvPr/>
-        </p:nvGraphicFramePr>
-        <p:xfrm>
-          <a:off x="530352" y="2487168"/>
-          <a:ext cx="3000000" cy="3000000"/>
-        </p:xfrm>
-        <a:graphic>
-          <a:graphicData uri="http://schemas.openxmlformats.org/drawingml/2006/table">
-            <a:tbl>
-              <a:tblPr bandRow="1" firstRow="1">
-                <a:noFill/>
-                <a:tableStyleId>{60C7E03B-85A4-41BA-8E18-2549407F5BF5}</a:tableStyleId>
-              </a:tblPr>
-              <a:tblGrid>
-                <a:gridCol w="1856225"/>
-                <a:gridCol w="2386575"/>
-                <a:gridCol w="1280150"/>
-                <a:gridCol w="1280150"/>
-                <a:gridCol w="1280150"/>
-              </a:tblGrid>
-              <a:tr h="420625">
-                <a:tc>
-                  <a:txBody>
-                    <a:bodyPr/>
-                    <a:lstStyle/>
-                    <a:p>
-                      <a:pPr indent="0" lvl="0" marL="0" marR="0" rtl="0" algn="l">
-                        <a:lnSpc>
-                          <a:spcPct val="100000"/>
-                        </a:lnSpc>
-                        <a:spcBef>
-                          <a:spcPts val="0"/>
-                        </a:spcBef>
-                        <a:spcAft>
-                          <a:spcPts val="0"/>
-                        </a:spcAft>
-                        <a:buNone/>
-                      </a:pPr>
-                      <a:r>
-                        <a:rPr b="1" lang="en" sz="1300" u="none" cap="none" strike="noStrike">
-                          <a:solidFill>
-                            <a:srgbClr val="FFFFFF"/>
-                          </a:solidFill>
-                          <a:latin typeface="Arial"/>
-                          <a:ea typeface="Arial"/>
-                          <a:cs typeface="Arial"/>
-                          <a:sym typeface="Arial"/>
-                        </a:rPr>
-                        <a:t>Method</a:t>
-                      </a:r>
-                      <a:endParaRPr/>
-                    </a:p>
-                  </a:txBody>
-                  <a:tcPr marT="45725" marB="36575" marR="45725" marL="91450" anchor="ctr">
-                    <a:solidFill>
-                      <a:srgbClr val="183153"/>
-                    </a:solidFill>
-                  </a:tcPr>
-                </a:tc>
-                <a:tc>
-                  <a:txBody>
-                    <a:bodyPr/>
-                    <a:lstStyle/>
-                    <a:p>
-                      <a:pPr indent="0" lvl="0" marL="0" marR="0" rtl="0" algn="ctr">
-                        <a:lnSpc>
-                          <a:spcPct val="100000"/>
-                        </a:lnSpc>
-                        <a:spcBef>
-                          <a:spcPts val="0"/>
-                        </a:spcBef>
-                        <a:spcAft>
-                          <a:spcPts val="0"/>
-                        </a:spcAft>
-                        <a:buNone/>
-                      </a:pPr>
-                      <a:r>
-                        <a:rPr b="1" lang="en" sz="1300" u="none" cap="none" strike="noStrike">
-                          <a:solidFill>
-                            <a:srgbClr val="FFFFFF"/>
-                          </a:solidFill>
-                          <a:latin typeface="Arial"/>
-                          <a:ea typeface="Arial"/>
-                          <a:cs typeface="Arial"/>
-                          <a:sym typeface="Arial"/>
-                        </a:rPr>
-                        <a:t>Reference source</a:t>
-                      </a:r>
-                      <a:endParaRPr/>
-                    </a:p>
-                  </a:txBody>
-                  <a:tcPr marT="45725" marB="36575" marR="45725" marL="91450" anchor="ctr">
-                    <a:solidFill>
-                      <a:srgbClr val="183153"/>
-                    </a:solidFill>
-                  </a:tcPr>
-                </a:tc>
-                <a:tc>
-                  <a:txBody>
-                    <a:bodyPr/>
-                    <a:lstStyle/>
-                    <a:p>
-                      <a:pPr indent="0" lvl="0" marL="0" marR="0" rtl="0" algn="ctr">
-                        <a:lnSpc>
-                          <a:spcPct val="100000"/>
-                        </a:lnSpc>
-                        <a:spcBef>
-                          <a:spcPts val="0"/>
-                        </a:spcBef>
-                        <a:spcAft>
-                          <a:spcPts val="0"/>
-                        </a:spcAft>
-                        <a:buNone/>
-                      </a:pPr>
-                      <a:r>
-                        <a:rPr b="1" lang="en" sz="1300" u="none" cap="none" strike="noStrike">
-                          <a:solidFill>
-                            <a:srgbClr val="FFFFFF"/>
-                          </a:solidFill>
-                          <a:latin typeface="Arial"/>
-                          <a:ea typeface="Arial"/>
-                          <a:cs typeface="Arial"/>
-                          <a:sym typeface="Arial"/>
-                        </a:rPr>
-                        <a:t>MATH500</a:t>
-                      </a:r>
-                      <a:endParaRPr/>
-                    </a:p>
-                  </a:txBody>
-                  <a:tcPr marT="45725" marB="36575" marR="45725" marL="91450" anchor="ctr">
-                    <a:solidFill>
-                      <a:srgbClr val="183153"/>
-                    </a:solidFill>
-                  </a:tcPr>
-                </a:tc>
-                <a:tc>
-                  <a:txBody>
-                    <a:bodyPr/>
-                    <a:lstStyle/>
-                    <a:p>
-                      <a:pPr indent="0" lvl="0" marL="0" marR="0" rtl="0" algn="ctr">
-                        <a:lnSpc>
-                          <a:spcPct val="100000"/>
-                        </a:lnSpc>
-                        <a:spcBef>
-                          <a:spcPts val="0"/>
-                        </a:spcBef>
-                        <a:spcAft>
-                          <a:spcPts val="0"/>
-                        </a:spcAft>
-                        <a:buNone/>
-                      </a:pPr>
-                      <a:r>
-                        <a:rPr b="1" lang="en" sz="1300" u="none" cap="none" strike="noStrike">
-                          <a:solidFill>
-                            <a:srgbClr val="FFFFFF"/>
-                          </a:solidFill>
-                          <a:latin typeface="Arial"/>
-                          <a:ea typeface="Arial"/>
-                          <a:cs typeface="Arial"/>
-                          <a:sym typeface="Arial"/>
-                        </a:rPr>
-                        <a:t>AIME25</a:t>
-                      </a:r>
-                      <a:endParaRPr/>
-                    </a:p>
-                  </a:txBody>
-                  <a:tcPr marT="45725" marB="36575" marR="45725" marL="91450" anchor="ctr">
-                    <a:solidFill>
-                      <a:srgbClr val="183153"/>
-                    </a:solidFill>
-                  </a:tcPr>
-                </a:tc>
-                <a:tc>
-                  <a:txBody>
-                    <a:bodyPr/>
-                    <a:lstStyle/>
-                    <a:p>
-                      <a:pPr indent="0" lvl="0" marL="0" marR="0" rtl="0" algn="ctr">
-                        <a:lnSpc>
-                          <a:spcPct val="100000"/>
-                        </a:lnSpc>
-                        <a:spcBef>
-                          <a:spcPts val="0"/>
-                        </a:spcBef>
-                        <a:spcAft>
-                          <a:spcPts val="0"/>
-                        </a:spcAft>
-                        <a:buNone/>
-                      </a:pPr>
-                      <a:r>
-                        <a:rPr b="1" lang="en" sz="1300" u="none" cap="none" strike="noStrike">
-                          <a:solidFill>
-                            <a:srgbClr val="FFFFFF"/>
-                          </a:solidFill>
-                          <a:latin typeface="Arial"/>
-                          <a:ea typeface="Arial"/>
-                          <a:cs typeface="Arial"/>
-                          <a:sym typeface="Arial"/>
-                        </a:rPr>
-                        <a:t>BFCL</a:t>
-                      </a:r>
-                      <a:endParaRPr/>
-                    </a:p>
-                  </a:txBody>
-                  <a:tcPr marT="45725" marB="36575" marR="45725" marL="91450" anchor="ctr">
-                    <a:solidFill>
-                      <a:srgbClr val="183153"/>
-                    </a:solidFill>
-                  </a:tcPr>
-                </a:tc>
-              </a:tr>
-              <a:tr h="420625">
-                <a:tc>
-                  <a:txBody>
-                    <a:bodyPr/>
-                    <a:lstStyle/>
-                    <a:p>
-                      <a:pPr indent="0" lvl="0" marL="0" marR="0" rtl="0" algn="l">
-                        <a:lnSpc>
-                          <a:spcPct val="100000"/>
-                        </a:lnSpc>
-                        <a:spcBef>
-                          <a:spcPts val="0"/>
-                        </a:spcBef>
-                        <a:spcAft>
-                          <a:spcPts val="0"/>
-                        </a:spcAft>
-                        <a:buNone/>
-                      </a:pPr>
-                      <a:r>
-                        <a:rPr b="0" lang="en" sz="1300" u="none" cap="none" strike="noStrike">
-                          <a:solidFill>
-                            <a:srgbClr val="183153"/>
-                          </a:solidFill>
-                          <a:latin typeface="Arial"/>
-                          <a:ea typeface="Arial"/>
-                          <a:cs typeface="Arial"/>
-                          <a:sym typeface="Arial"/>
-                        </a:rPr>
-                        <a:t>RaR</a:t>
-                      </a:r>
-                      <a:endParaRPr/>
-                    </a:p>
-                  </a:txBody>
-                  <a:tcPr marT="45725" marB="36575" marR="45725" marL="91450" anchor="ctr">
-                    <a:solidFill>
-                      <a:srgbClr val="F7F9FC"/>
-                    </a:solidFill>
-                  </a:tcPr>
-                </a:tc>
-                <a:tc>
-                  <a:txBody>
-                    <a:bodyPr/>
-                    <a:lstStyle/>
-                    <a:p>
-                      <a:pPr indent="0" lvl="0" marL="0" marR="0" rtl="0" algn="ctr">
-                        <a:lnSpc>
-                          <a:spcPct val="100000"/>
-                        </a:lnSpc>
-                        <a:spcBef>
-                          <a:spcPts val="0"/>
-                        </a:spcBef>
-                        <a:spcAft>
-                          <a:spcPts val="0"/>
-                        </a:spcAft>
-                        <a:buNone/>
-                      </a:pPr>
-                      <a:r>
-                        <a:rPr b="0" lang="en" sz="1300" u="none" cap="none" strike="noStrike">
-                          <a:solidFill>
-                            <a:srgbClr val="183153"/>
-                          </a:solidFill>
-                          <a:latin typeface="Arial"/>
-                          <a:ea typeface="Arial"/>
-                          <a:cs typeface="Arial"/>
-                          <a:sym typeface="Arial"/>
-                        </a:rPr>
-                        <a:t>GPT-5.1 labeled</a:t>
-                      </a:r>
-                      <a:endParaRPr/>
-                    </a:p>
-                  </a:txBody>
-                  <a:tcPr marT="45725" marB="36575" marR="45725" marL="91450" anchor="ctr">
-                    <a:solidFill>
-                      <a:srgbClr val="F7F9FC"/>
-                    </a:solidFill>
-                  </a:tcPr>
-                </a:tc>
-                <a:tc>
-                  <a:txBody>
-                    <a:bodyPr/>
-                    <a:lstStyle/>
-                    <a:p>
-                      <a:pPr indent="0" lvl="0" marL="0" marR="0" rtl="0" algn="ctr">
-                        <a:lnSpc>
-                          <a:spcPct val="100000"/>
-                        </a:lnSpc>
-                        <a:spcBef>
-                          <a:spcPts val="0"/>
-                        </a:spcBef>
-                        <a:spcAft>
-                          <a:spcPts val="0"/>
-                        </a:spcAft>
-                        <a:buNone/>
-                      </a:pPr>
-                      <a:r>
-                        <a:rPr b="0" lang="en" sz="1300" u="none" cap="none" strike="noStrike">
-                          <a:solidFill>
-                            <a:srgbClr val="183153"/>
-                          </a:solidFill>
-                          <a:latin typeface="Arial"/>
-                          <a:ea typeface="Arial"/>
-                          <a:cs typeface="Arial"/>
-                          <a:sym typeface="Arial"/>
-                        </a:rPr>
-                        <a:t>90.7</a:t>
-                      </a:r>
-                      <a:endParaRPr/>
-                    </a:p>
-                  </a:txBody>
-                  <a:tcPr marT="45725" marB="36575" marR="45725" marL="91450" anchor="ctr">
-                    <a:solidFill>
-                      <a:srgbClr val="F7F9FC"/>
-                    </a:solidFill>
-                  </a:tcPr>
-                </a:tc>
-                <a:tc>
-                  <a:txBody>
-                    <a:bodyPr/>
-                    <a:lstStyle/>
-                    <a:p>
-                      <a:pPr indent="0" lvl="0" marL="0" marR="0" rtl="0" algn="ctr">
-                        <a:lnSpc>
-                          <a:spcPct val="100000"/>
-                        </a:lnSpc>
-                        <a:spcBef>
-                          <a:spcPts val="0"/>
-                        </a:spcBef>
-                        <a:spcAft>
-                          <a:spcPts val="0"/>
-                        </a:spcAft>
-                        <a:buNone/>
-                      </a:pPr>
-                      <a:r>
-                        <a:rPr b="0" lang="en" sz="1300" u="none" cap="none" strike="noStrike">
-                          <a:solidFill>
-                            <a:srgbClr val="183153"/>
-                          </a:solidFill>
-                          <a:latin typeface="Arial"/>
-                          <a:ea typeface="Arial"/>
-                          <a:cs typeface="Arial"/>
-                          <a:sym typeface="Arial"/>
-                        </a:rPr>
-                        <a:t>43.3</a:t>
-                      </a:r>
-                      <a:endParaRPr/>
-                    </a:p>
-                  </a:txBody>
-                  <a:tcPr marT="45725" marB="36575" marR="45725" marL="91450" anchor="ctr">
-                    <a:solidFill>
-                      <a:srgbClr val="F7F9FC"/>
-                    </a:solidFill>
-                  </a:tcPr>
-                </a:tc>
-                <a:tc>
-                  <a:txBody>
-                    <a:bodyPr/>
-                    <a:lstStyle/>
-                    <a:p>
-                      <a:pPr indent="0" lvl="0" marL="0" marR="0" rtl="0" algn="ctr">
-                        <a:lnSpc>
-                          <a:spcPct val="100000"/>
-                        </a:lnSpc>
-                        <a:spcBef>
-                          <a:spcPts val="0"/>
-                        </a:spcBef>
-                        <a:spcAft>
-                          <a:spcPts val="0"/>
-                        </a:spcAft>
-                        <a:buNone/>
-                      </a:pPr>
-                      <a:r>
-                        <a:rPr b="0" lang="en" sz="1300" u="none" cap="none" strike="noStrike">
-                          <a:solidFill>
-                            <a:srgbClr val="183153"/>
-                          </a:solidFill>
-                          <a:latin typeface="Arial"/>
-                          <a:ea typeface="Arial"/>
-                          <a:cs typeface="Arial"/>
-                          <a:sym typeface="Arial"/>
-                        </a:rPr>
-                        <a:t>46.2</a:t>
-                      </a:r>
-                      <a:endParaRPr/>
-                    </a:p>
-                  </a:txBody>
-                  <a:tcPr marT="45725" marB="36575" marR="45725" marL="91450" anchor="ctr">
-                    <a:solidFill>
-                      <a:srgbClr val="F7F9FC"/>
-                    </a:solidFill>
-                  </a:tcPr>
-                </a:tc>
-              </a:tr>
-              <a:tr h="420625">
-                <a:tc>
-                  <a:txBody>
-                    <a:bodyPr/>
-                    <a:lstStyle/>
-                    <a:p>
-                      <a:pPr indent="0" lvl="0" marL="0" marR="0" rtl="0" algn="l">
-                        <a:lnSpc>
-                          <a:spcPct val="100000"/>
-                        </a:lnSpc>
-                        <a:spcBef>
-                          <a:spcPts val="0"/>
-                        </a:spcBef>
-                        <a:spcAft>
-                          <a:spcPts val="0"/>
-                        </a:spcAft>
-                        <a:buNone/>
-                      </a:pPr>
-                      <a:r>
-                        <a:rPr b="1" lang="en" sz="1300" u="none" cap="none" strike="noStrike">
-                          <a:solidFill>
-                            <a:srgbClr val="183153"/>
-                          </a:solidFill>
-                          <a:latin typeface="Arial"/>
-                          <a:ea typeface="Arial"/>
-                          <a:cs typeface="Arial"/>
-                          <a:sym typeface="Arial"/>
-                        </a:rPr>
-                        <a:t>SCRIBE</a:t>
-                      </a:r>
-                      <a:endParaRPr/>
-                    </a:p>
-                  </a:txBody>
-                  <a:tcPr marT="45725" marB="36575" marR="45725" marL="91450" anchor="ctr">
-                    <a:solidFill>
-                      <a:srgbClr val="EDF4FC"/>
-                    </a:solidFill>
-                  </a:tcPr>
-                </a:tc>
-                <a:tc>
-                  <a:txBody>
-                    <a:bodyPr/>
-                    <a:lstStyle/>
-                    <a:p>
-                      <a:pPr indent="0" lvl="0" marL="0" marR="0" rtl="0" algn="ctr">
-                        <a:lnSpc>
-                          <a:spcPct val="100000"/>
-                        </a:lnSpc>
-                        <a:spcBef>
-                          <a:spcPts val="0"/>
-                        </a:spcBef>
-                        <a:spcAft>
-                          <a:spcPts val="0"/>
-                        </a:spcAft>
-                        <a:buNone/>
-                      </a:pPr>
-                      <a:r>
-                        <a:rPr b="1" lang="en" sz="1300" u="none" cap="none" strike="noStrike">
-                          <a:solidFill>
-                            <a:srgbClr val="183153"/>
-                          </a:solidFill>
-                          <a:latin typeface="Arial"/>
-                          <a:ea typeface="Arial"/>
-                          <a:cs typeface="Arial"/>
-                          <a:sym typeface="Arial"/>
-                        </a:rPr>
-                        <a:t>Not required</a:t>
-                      </a:r>
-                      <a:endParaRPr/>
-                    </a:p>
-                  </a:txBody>
-                  <a:tcPr marT="45725" marB="36575" marR="45725" marL="91450" anchor="ctr">
-                    <a:solidFill>
-                      <a:srgbClr val="EDF4FC"/>
-                    </a:solidFill>
-                  </a:tcPr>
-                </a:tc>
-                <a:tc>
-                  <a:txBody>
-                    <a:bodyPr/>
-                    <a:lstStyle/>
-                    <a:p>
-                      <a:pPr indent="0" lvl="0" marL="0" marR="0" rtl="0" algn="ctr">
-                        <a:lnSpc>
-                          <a:spcPct val="100000"/>
-                        </a:lnSpc>
-                        <a:spcBef>
-                          <a:spcPts val="0"/>
-                        </a:spcBef>
-                        <a:spcAft>
-                          <a:spcPts val="0"/>
-                        </a:spcAft>
-                        <a:buNone/>
-                      </a:pPr>
-                      <a:r>
-                        <a:rPr b="1" lang="en" sz="1300" u="none" cap="none" strike="noStrike">
-                          <a:solidFill>
-                            <a:srgbClr val="183153"/>
-                          </a:solidFill>
-                          <a:latin typeface="Arial"/>
-                          <a:ea typeface="Arial"/>
-                          <a:cs typeface="Arial"/>
-                          <a:sym typeface="Arial"/>
-                        </a:rPr>
-                        <a:t>95.8</a:t>
-                      </a:r>
-                      <a:endParaRPr/>
-                    </a:p>
-                  </a:txBody>
-                  <a:tcPr marT="45725" marB="36575" marR="45725" marL="91450" anchor="ctr">
-                    <a:solidFill>
-                      <a:srgbClr val="EDF4FC"/>
-                    </a:solidFill>
-                  </a:tcPr>
-                </a:tc>
-                <a:tc>
-                  <a:txBody>
-                    <a:bodyPr/>
-                    <a:lstStyle/>
-                    <a:p>
-                      <a:pPr indent="0" lvl="0" marL="0" marR="0" rtl="0" algn="ctr">
-                        <a:lnSpc>
-                          <a:spcPct val="100000"/>
-                        </a:lnSpc>
-                        <a:spcBef>
-                          <a:spcPts val="0"/>
-                        </a:spcBef>
-                        <a:spcAft>
-                          <a:spcPts val="0"/>
-                        </a:spcAft>
-                        <a:buNone/>
-                      </a:pPr>
-                      <a:r>
-                        <a:rPr b="1" lang="en" sz="1300" u="none" cap="none" strike="noStrike">
-                          <a:solidFill>
-                            <a:srgbClr val="183153"/>
-                          </a:solidFill>
-                          <a:latin typeface="Arial"/>
-                          <a:ea typeface="Arial"/>
-                          <a:cs typeface="Arial"/>
-                          <a:sym typeface="Arial"/>
-                        </a:rPr>
-                        <a:t>63.3</a:t>
-                      </a:r>
-                      <a:endParaRPr/>
-                    </a:p>
-                  </a:txBody>
-                  <a:tcPr marT="45725" marB="36575" marR="45725" marL="91450" anchor="ctr">
-                    <a:solidFill>
-                      <a:srgbClr val="EDF4FC"/>
-                    </a:solidFill>
-                  </a:tcPr>
-                </a:tc>
-                <a:tc>
-                  <a:txBody>
-                    <a:bodyPr/>
-                    <a:lstStyle/>
-                    <a:p>
-                      <a:pPr indent="0" lvl="0" marL="0" marR="0" rtl="0" algn="ctr">
-                        <a:lnSpc>
-                          <a:spcPct val="100000"/>
-                        </a:lnSpc>
-                        <a:spcBef>
-                          <a:spcPts val="0"/>
-                        </a:spcBef>
-                        <a:spcAft>
-                          <a:spcPts val="0"/>
-                        </a:spcAft>
-                        <a:buNone/>
-                      </a:pPr>
-                      <a:r>
-                        <a:rPr b="1" lang="en" sz="1300" u="none" cap="none" strike="noStrike">
-                          <a:solidFill>
-                            <a:srgbClr val="183153"/>
-                          </a:solidFill>
-                          <a:latin typeface="Arial"/>
-                          <a:ea typeface="Arial"/>
-                          <a:cs typeface="Arial"/>
-                          <a:sym typeface="Arial"/>
-                        </a:rPr>
-                        <a:t>51.3</a:t>
-                      </a:r>
-                      <a:endParaRPr/>
-                    </a:p>
-                  </a:txBody>
-                  <a:tcPr marT="45725" marB="36575" marR="45725" marL="91450" anchor="ctr">
-                    <a:solidFill>
-                      <a:srgbClr val="EDF4FC"/>
-                    </a:solidFill>
-                  </a:tcPr>
-                </a:tc>
-              </a:tr>
-            </a:tbl>
-          </a:graphicData>
-        </a:graphic>
-      </p:graphicFrame>
-    </p:spTree>
-  </p:cSld>
-  <p:clrMapOvr>
-    <a:masterClrMapping/>
-  </p:clrMapOvr>
-</p:sld>
-</file>
-
-<file path=ppt/slides/slide11.xml><?xml version="1.0" encoding="utf-8"?>
-<p:sld xmlns:a="http://schemas.openxmlformats.org/drawingml/2006/main" xmlns:r="http://schemas.openxmlformats.org/officeDocument/2006/relationships" xmlns:mc="http://schemas.openxmlformats.org/markup-compatibility/2006" xmlns:mv="urn:schemas-microsoft-com:mac:vml" xmlns:p="http://schemas.openxmlformats.org/presentationml/2006/main" xmlns:c="http://schemas.openxmlformats.org/drawingml/2006/chart" xmlns:dgm="http://schemas.openxmlformats.org/drawingml/2006/diagram" xmlns:o="urn:schemas-microsoft-com:office:office" xmlns:v="urn:schemas-microsoft-com:vml" xmlns:pvml="urn:schemas-microsoft-com:office:powerpoint" xmlns:com="http://schemas.openxmlformats.org/drawingml/2006/compatibility" xmlns:p14="http://schemas.microsoft.com/office/powerpoint/2010/main" xmlns:p15="http://schemas.microsoft.com/office/powerpoint/2012/main" xmlns:ahyp="http://schemas.microsoft.com/office/drawing/2018/hyperlinkcolor">
-  <p:cSld>
-    <p:spTree>
-      <p:nvGrpSpPr>
         <p:cNvPr id="217" name="Shape 217"/>
         <p:cNvGrpSpPr/>
         <p:nvPr/>
@@ -17531,7 +16703,7 @@
 </p:sld>
 </file>
 
-<file path=ppt/slides/slide12.xml><?xml version="1.0" encoding="utf-8"?>
+<file path=ppt/slides/slide11.xml><?xml version="1.0" encoding="utf-8"?>
 <p:sld xmlns:a="http://schemas.openxmlformats.org/drawingml/2006/main" xmlns:r="http://schemas.openxmlformats.org/officeDocument/2006/relationships" xmlns:mc="http://schemas.openxmlformats.org/markup-compatibility/2006" xmlns:mv="urn:schemas-microsoft-com:mac:vml" xmlns:p="http://schemas.openxmlformats.org/presentationml/2006/main" xmlns:c="http://schemas.openxmlformats.org/drawingml/2006/chart" xmlns:dgm="http://schemas.openxmlformats.org/drawingml/2006/diagram" xmlns:o="urn:schemas-microsoft-com:office:office" xmlns:v="urn:schemas-microsoft-com:vml" xmlns:pvml="urn:schemas-microsoft-com:office:powerpoint" xmlns:com="http://schemas.openxmlformats.org/drawingml/2006/compatibility" xmlns:p14="http://schemas.microsoft.com/office/powerpoint/2010/main" xmlns:p15="http://schemas.microsoft.com/office/powerpoint/2012/main" xmlns:ahyp="http://schemas.microsoft.com/office/drawing/2018/hyperlinkcolor">
   <p:cSld>
     <p:spTree>
@@ -18617,7 +17789,7 @@
 </p:sld>
 </file>
 
-<file path=ppt/slides/slide13.xml><?xml version="1.0" encoding="utf-8"?>
+<file path=ppt/slides/slide12.xml><?xml version="1.0" encoding="utf-8"?>
 <p:sld xmlns:a="http://schemas.openxmlformats.org/drawingml/2006/main" xmlns:r="http://schemas.openxmlformats.org/officeDocument/2006/relationships" xmlns:mc="http://schemas.openxmlformats.org/markup-compatibility/2006" xmlns:mv="urn:schemas-microsoft-com:mac:vml" xmlns:p="http://schemas.openxmlformats.org/presentationml/2006/main" xmlns:c="http://schemas.openxmlformats.org/drawingml/2006/chart" xmlns:dgm="http://schemas.openxmlformats.org/drawingml/2006/diagram" xmlns:o="urn:schemas-microsoft-com:office:office" xmlns:v="urn:schemas-microsoft-com:vml" xmlns:pvml="urn:schemas-microsoft-com:office:powerpoint" xmlns:com="http://schemas.openxmlformats.org/drawingml/2006/compatibility" xmlns:p14="http://schemas.microsoft.com/office/powerpoint/2010/main" xmlns:p15="http://schemas.microsoft.com/office/powerpoint/2012/main" xmlns:ahyp="http://schemas.microsoft.com/office/drawing/2018/hyperlinkcolor">
   <p:cSld>
     <p:spTree>
@@ -20079,7 +19251,7 @@
 </p:sld>
 </file>
 
-<file path=ppt/slides/slide14.xml><?xml version="1.0" encoding="utf-8"?>
+<file path=ppt/slides/slide13.xml><?xml version="1.0" encoding="utf-8"?>
 <p:sld xmlns:a="http://schemas.openxmlformats.org/drawingml/2006/main" xmlns:r="http://schemas.openxmlformats.org/officeDocument/2006/relationships" xmlns:mc="http://schemas.openxmlformats.org/markup-compatibility/2006" xmlns:mv="urn:schemas-microsoft-com:mac:vml" xmlns:p="http://schemas.openxmlformats.org/presentationml/2006/main" xmlns:c="http://schemas.openxmlformats.org/drawingml/2006/chart" xmlns:dgm="http://schemas.openxmlformats.org/drawingml/2006/diagram" xmlns:o="urn:schemas-microsoft-com:office:office" xmlns:v="urn:schemas-microsoft-com:vml" xmlns:pvml="urn:schemas-microsoft-com:office:powerpoint" xmlns:com="http://schemas.openxmlformats.org/drawingml/2006/compatibility" xmlns:p14="http://schemas.microsoft.com/office/powerpoint/2010/main" xmlns:p15="http://schemas.microsoft.com/office/powerpoint/2012/main" xmlns:ahyp="http://schemas.microsoft.com/office/drawing/2018/hyperlinkcolor">
   <p:cSld>
     <p:spTree>
@@ -20942,7 +20114,7 @@
 </p:sld>
 </file>
 
-<file path=ppt/slides/slide15.xml><?xml version="1.0" encoding="utf-8"?>
+<file path=ppt/slides/slide14.xml><?xml version="1.0" encoding="utf-8"?>
 <p:sld xmlns:a="http://schemas.openxmlformats.org/drawingml/2006/main" xmlns:r="http://schemas.openxmlformats.org/officeDocument/2006/relationships" xmlns:mc="http://schemas.openxmlformats.org/markup-compatibility/2006" xmlns:mv="urn:schemas-microsoft-com:mac:vml" xmlns:p="http://schemas.openxmlformats.org/presentationml/2006/main" xmlns:c="http://schemas.openxmlformats.org/drawingml/2006/chart" xmlns:dgm="http://schemas.openxmlformats.org/drawingml/2006/diagram" xmlns:o="urn:schemas-microsoft-com:office:office" xmlns:v="urn:schemas-microsoft-com:vml" xmlns:pvml="urn:schemas-microsoft-com:office:powerpoint" xmlns:com="http://schemas.openxmlformats.org/drawingml/2006/compatibility" xmlns:p14="http://schemas.microsoft.com/office/powerpoint/2010/main" xmlns:p15="http://schemas.microsoft.com/office/powerpoint/2012/main" xmlns:ahyp="http://schemas.microsoft.com/office/drawing/2018/hyperlinkcolor">
   <p:cSld>
     <p:spTree>
@@ -21817,7 +20989,7 @@
 </p:sld>
 </file>
 
-<file path=ppt/slides/slide16.xml><?xml version="1.0" encoding="utf-8"?>
+<file path=ppt/slides/slide15.xml><?xml version="1.0" encoding="utf-8"?>
 <p:sld xmlns:a="http://schemas.openxmlformats.org/drawingml/2006/main" xmlns:r="http://schemas.openxmlformats.org/officeDocument/2006/relationships" xmlns:mc="http://schemas.openxmlformats.org/markup-compatibility/2006" xmlns:mv="urn:schemas-microsoft-com:mac:vml" xmlns:p="http://schemas.openxmlformats.org/presentationml/2006/main" xmlns:c="http://schemas.openxmlformats.org/drawingml/2006/chart" xmlns:dgm="http://schemas.openxmlformats.org/drawingml/2006/diagram" xmlns:o="urn:schemas-microsoft-com:office:office" xmlns:v="urn:schemas-microsoft-com:vml" xmlns:pvml="urn:schemas-microsoft-com:office:powerpoint" xmlns:com="http://schemas.openxmlformats.org/drawingml/2006/compatibility" xmlns:p14="http://schemas.microsoft.com/office/powerpoint/2010/main" xmlns:p15="http://schemas.microsoft.com/office/powerpoint/2012/main" xmlns:ahyp="http://schemas.microsoft.com/office/drawing/2018/hyperlinkcolor">
   <p:cSld>
     <p:bg>
@@ -23134,7 +22306,7 @@
 </p:sld>
 </file>
 
-<file path=ppt/slides/slide17.xml><?xml version="1.0" encoding="utf-8"?>
+<file path=ppt/slides/slide16.xml><?xml version="1.0" encoding="utf-8"?>
 <p:sld xmlns:a="http://schemas.openxmlformats.org/drawingml/2006/main" xmlns:r="http://schemas.openxmlformats.org/officeDocument/2006/relationships" xmlns:mc="http://schemas.openxmlformats.org/markup-compatibility/2006" xmlns:mv="urn:schemas-microsoft-com:mac:vml" xmlns:p="http://schemas.openxmlformats.org/presentationml/2006/main" xmlns:c="http://schemas.openxmlformats.org/drawingml/2006/chart" xmlns:dgm="http://schemas.openxmlformats.org/drawingml/2006/diagram" xmlns:o="urn:schemas-microsoft-com:office:office" xmlns:v="urn:schemas-microsoft-com:vml" xmlns:pvml="urn:schemas-microsoft-com:office:powerpoint" xmlns:com="http://schemas.openxmlformats.org/drawingml/2006/compatibility" xmlns:p14="http://schemas.microsoft.com/office/powerpoint/2010/main" xmlns:p15="http://schemas.microsoft.com/office/powerpoint/2012/main" xmlns:ahyp="http://schemas.microsoft.com/office/drawing/2018/hyperlinkcolor">
   <p:cSld>
     <p:spTree>
@@ -26127,7 +25299,7 @@
 </p:sld>
 </file>
 
-<file path=ppt/slides/slide18.xml><?xml version="1.0" encoding="utf-8"?>
+<file path=ppt/slides/slide17.xml><?xml version="1.0" encoding="utf-8"?>
 <p:sld xmlns:a="http://schemas.openxmlformats.org/drawingml/2006/main" xmlns:r="http://schemas.openxmlformats.org/officeDocument/2006/relationships" xmlns:mc="http://schemas.openxmlformats.org/markup-compatibility/2006" xmlns:mv="urn:schemas-microsoft-com:mac:vml" xmlns:p="http://schemas.openxmlformats.org/presentationml/2006/main" xmlns:c="http://schemas.openxmlformats.org/drawingml/2006/chart" xmlns:dgm="http://schemas.openxmlformats.org/drawingml/2006/diagram" xmlns:o="urn:schemas-microsoft-com:office:office" xmlns:v="urn:schemas-microsoft-com:vml" xmlns:pvml="urn:schemas-microsoft-com:office:powerpoint" xmlns:com="http://schemas.openxmlformats.org/drawingml/2006/compatibility" xmlns:p14="http://schemas.microsoft.com/office/powerpoint/2010/main" xmlns:p15="http://schemas.microsoft.com/office/powerpoint/2012/main" xmlns:ahyp="http://schemas.microsoft.com/office/drawing/2018/hyperlinkcolor">
   <p:cSld>
     <p:spTree>
@@ -29200,7 +28372,7 @@
 </p:sld>
 </file>
 
-<file path=ppt/slides/slide19.xml><?xml version="1.0" encoding="utf-8"?>
+<file path=ppt/slides/slide18.xml><?xml version="1.0" encoding="utf-8"?>
 <p:sld xmlns:a="http://schemas.openxmlformats.org/drawingml/2006/main" xmlns:r="http://schemas.openxmlformats.org/officeDocument/2006/relationships" xmlns:mc="http://schemas.openxmlformats.org/markup-compatibility/2006" xmlns:mv="urn:schemas-microsoft-com:mac:vml" xmlns:p="http://schemas.openxmlformats.org/presentationml/2006/main" xmlns:c="http://schemas.openxmlformats.org/drawingml/2006/chart" xmlns:dgm="http://schemas.openxmlformats.org/drawingml/2006/diagram" xmlns:o="urn:schemas-microsoft-com:office:office" xmlns:v="urn:schemas-microsoft-com:vml" xmlns:pvml="urn:schemas-microsoft-com:office:powerpoint" xmlns:com="http://schemas.openxmlformats.org/drawingml/2006/compatibility" xmlns:p14="http://schemas.microsoft.com/office/powerpoint/2010/main" xmlns:p15="http://schemas.microsoft.com/office/powerpoint/2012/main" xmlns:ahyp="http://schemas.microsoft.com/office/drawing/2018/hyperlinkcolor">
   <p:cSld>
     <p:spTree>
@@ -30049,7 +29221,7 @@
 </p:sld>
 </file>
 
-<file path=ppt/slides/slide3.xml><?xml version="1.0" encoding="utf-8"?>
+<file path=ppt/slides/slide2.xml><?xml version="1.0" encoding="utf-8"?>
 <p:sld xmlns:a="http://schemas.openxmlformats.org/drawingml/2006/main" xmlns:r="http://schemas.openxmlformats.org/officeDocument/2006/relationships" xmlns:mc="http://schemas.openxmlformats.org/markup-compatibility/2006" xmlns:mv="urn:schemas-microsoft-com:mac:vml" xmlns:p="http://schemas.openxmlformats.org/presentationml/2006/main" xmlns:c="http://schemas.openxmlformats.org/drawingml/2006/chart" xmlns:dgm="http://schemas.openxmlformats.org/drawingml/2006/diagram" xmlns:o="urn:schemas-microsoft-com:office:office" xmlns:v="urn:schemas-microsoft-com:vml" xmlns:pvml="urn:schemas-microsoft-com:office:powerpoint" xmlns:com="http://schemas.openxmlformats.org/drawingml/2006/compatibility" xmlns:p14="http://schemas.microsoft.com/office/powerpoint/2010/main" xmlns:p15="http://schemas.microsoft.com/office/powerpoint/2012/main" xmlns:ahyp="http://schemas.microsoft.com/office/drawing/2018/hyperlinkcolor" show="1">
   <p:cSld>
     <p:spTree>
@@ -30510,39 +29682,31 @@
               </a:defRPr>
             </a:pPr>
             <a:r>
-              <a:t>Correct final answer;</a:t>
-            </a:r>
-          </a:p>
-          <a:p>
-            <a:pPr algn="l">
-              <a:spcAft>
-                <a:spcPts val="0"/>
-              </a:spcAft>
-              <a:defRPr sz="958">
+              <a:rPr sz="862">
                 <a:solidFill>
                   <a:srgbClr val="193354"/>
                 </a:solidFill>
                 <a:latin typeface="Arial"/>
-              </a:defRPr>
-            </a:pPr>
+              </a:rPr>
+              <a:t>The final answer is correct; assign a </a:t>
+            </a:r>
             <a:r>
-              <a:t>flawed reasoning.</a:t>
+              <a:rPr sz="862">
+                <a:solidFill>
+                  <a:srgbClr val="CC0000"/>
+                </a:solidFill>
+                <a:latin typeface="Arial"/>
+              </a:rPr>
+              <a:t>high</a:t>
             </a:r>
-          </a:p>
-          <a:p>
-            <a:pPr algn="l">
-              <a:spcAft>
-                <a:spcPts val="0"/>
-              </a:spcAft>
-              <a:defRPr sz="958">
+            <a:r>
+              <a:rPr sz="862">
                 <a:solidFill>
                   <a:srgbClr val="193354"/>
                 </a:solidFill>
                 <a:latin typeface="Arial"/>
-              </a:defRPr>
-            </a:pPr>
-            <a:r>
-              <a:t>High reward.</a:t>
+              </a:rPr>
+              <a:t> reward.</a:t>
             </a:r>
           </a:p>
         </p:txBody>
@@ -30581,39 +29745,31 @@
               </a:defRPr>
             </a:pPr>
             <a:r>
-              <a:t>Sound strategy;</a:t>
-            </a:r>
-          </a:p>
-          <a:p>
-            <a:pPr algn="l">
-              <a:spcAft>
-                <a:spcPts val="0"/>
-              </a:spcAft>
-              <a:defRPr sz="958">
+              <a:rPr sz="862">
                 <a:solidFill>
                   <a:srgbClr val="193354"/>
                 </a:solidFill>
                 <a:latin typeface="Arial"/>
-              </a:defRPr>
-            </a:pPr>
+              </a:rPr>
+              <a:t>The code contains a syntax error; assign a </a:t>
+            </a:r>
             <a:r>
-              <a:t>minor syntax error.</a:t>
+              <a:rPr sz="862">
+                <a:solidFill>
+                  <a:srgbClr val="000099"/>
+                </a:solidFill>
+                <a:latin typeface="Arial"/>
+              </a:rPr>
+              <a:t>low</a:t>
             </a:r>
-          </a:p>
-          <a:p>
-            <a:pPr algn="l">
-              <a:spcAft>
-                <a:spcPts val="0"/>
-              </a:spcAft>
-              <a:defRPr sz="958">
+            <a:r>
+              <a:rPr sz="862">
                 <a:solidFill>
                   <a:srgbClr val="193354"/>
                 </a:solidFill>
                 <a:latin typeface="Arial"/>
-              </a:defRPr>
-            </a:pPr>
-            <a:r>
-              <a:t>Low reward.</a:t>
+              </a:rPr>
+              <a:t> reward.</a:t>
             </a:r>
           </a:p>
         </p:txBody>
@@ -30626,7 +29782,7 @@
 </p:sld>
 </file>
 
-<file path=ppt/slides/slide4.xml><?xml version="1.0" encoding="utf-8"?>
+<file path=ppt/slides/slide3.xml><?xml version="1.0" encoding="utf-8"?>
 <p:sld xmlns:a="http://schemas.openxmlformats.org/drawingml/2006/main" xmlns:r="http://schemas.openxmlformats.org/officeDocument/2006/relationships" xmlns:mc="http://schemas.openxmlformats.org/markup-compatibility/2006" xmlns:mv="urn:schemas-microsoft-com:mac:vml" xmlns:p="http://schemas.openxmlformats.org/presentationml/2006/main" xmlns:c="http://schemas.openxmlformats.org/drawingml/2006/chart" xmlns:dgm="http://schemas.openxmlformats.org/drawingml/2006/diagram" xmlns:o="urn:schemas-microsoft-com:office:office" xmlns:v="urn:schemas-microsoft-com:vml" xmlns:pvml="urn:schemas-microsoft-com:office:powerpoint" xmlns:com="http://schemas.openxmlformats.org/drawingml/2006/compatibility" xmlns:p14="http://schemas.microsoft.com/office/powerpoint/2010/main" xmlns:p15="http://schemas.microsoft.com/office/powerpoint/2012/main" xmlns:ahyp="http://schemas.microsoft.com/office/drawing/2018/hyperlinkcolor">
   <p:cSld>
     <p:spTree>
@@ -31091,39 +30247,31 @@
               </a:defRPr>
             </a:pPr>
             <a:r>
-              <a:t>Correct final answer;</a:t>
-            </a:r>
-          </a:p>
-          <a:p>
-            <a:pPr algn="l">
-              <a:spcAft>
-                <a:spcPts val="0"/>
-              </a:spcAft>
-              <a:defRPr sz="743">
+              <a:rPr sz="668">
                 <a:solidFill>
                   <a:srgbClr val="193354"/>
                 </a:solidFill>
                 <a:latin typeface="Arial"/>
-              </a:defRPr>
-            </a:pPr>
+              </a:rPr>
+              <a:t>The final answer is correct; assign a </a:t>
+            </a:r>
             <a:r>
-              <a:t>flawed reasoning.</a:t>
+              <a:rPr sz="668">
+                <a:solidFill>
+                  <a:srgbClr val="CC0000"/>
+                </a:solidFill>
+                <a:latin typeface="Arial"/>
+              </a:rPr>
+              <a:t>high</a:t>
             </a:r>
-          </a:p>
-          <a:p>
-            <a:pPr algn="l">
-              <a:spcAft>
-                <a:spcPts val="0"/>
-              </a:spcAft>
-              <a:defRPr sz="743">
+            <a:r>
+              <a:rPr sz="668">
                 <a:solidFill>
                   <a:srgbClr val="193354"/>
                 </a:solidFill>
                 <a:latin typeface="Arial"/>
-              </a:defRPr>
-            </a:pPr>
-            <a:r>
-              <a:t>High reward.</a:t>
+              </a:rPr>
+              <a:t> reward.</a:t>
             </a:r>
           </a:p>
         </p:txBody>
@@ -31162,39 +30310,31 @@
               </a:defRPr>
             </a:pPr>
             <a:r>
-              <a:t>Sound strategy;</a:t>
-            </a:r>
-          </a:p>
-          <a:p>
-            <a:pPr algn="l">
-              <a:spcAft>
-                <a:spcPts val="0"/>
-              </a:spcAft>
-              <a:defRPr sz="743">
+              <a:rPr sz="668">
                 <a:solidFill>
                   <a:srgbClr val="193354"/>
                 </a:solidFill>
                 <a:latin typeface="Arial"/>
-              </a:defRPr>
-            </a:pPr>
+              </a:rPr>
+              <a:t>The code contains a syntax error; assign a </a:t>
+            </a:r>
             <a:r>
-              <a:t>minor syntax error.</a:t>
+              <a:rPr sz="668">
+                <a:solidFill>
+                  <a:srgbClr val="000099"/>
+                </a:solidFill>
+                <a:latin typeface="Arial"/>
+              </a:rPr>
+              <a:t>low</a:t>
             </a:r>
-          </a:p>
-          <a:p>
-            <a:pPr algn="l">
-              <a:spcAft>
-                <a:spcPts val="0"/>
-              </a:spcAft>
-              <a:defRPr sz="743">
+            <a:r>
+              <a:rPr sz="668">
                 <a:solidFill>
                   <a:srgbClr val="193354"/>
                 </a:solidFill>
                 <a:latin typeface="Arial"/>
-              </a:defRPr>
-            </a:pPr>
-            <a:r>
-              <a:t>Low reward.</a:t>
+              </a:rPr>
+              <a:t> reward.</a:t>
             </a:r>
           </a:p>
         </p:txBody>
@@ -31207,7 +30347,7 @@
 </p:sld>
 </file>
 
-<file path=ppt/slides/slide5.xml><?xml version="1.0" encoding="utf-8"?>
+<file path=ppt/slides/slide4.xml><?xml version="1.0" encoding="utf-8"?>
 <p:sld xmlns:a="http://schemas.openxmlformats.org/drawingml/2006/main" xmlns:r="http://schemas.openxmlformats.org/officeDocument/2006/relationships" xmlns:mc="http://schemas.openxmlformats.org/markup-compatibility/2006" xmlns:mv="urn:schemas-microsoft-com:mac:vml" xmlns:p="http://schemas.openxmlformats.org/presentationml/2006/main" xmlns:c="http://schemas.openxmlformats.org/drawingml/2006/chart" xmlns:dgm="http://schemas.openxmlformats.org/drawingml/2006/diagram" xmlns:o="urn:schemas-microsoft-com:office:office" xmlns:v="urn:schemas-microsoft-com:vml" xmlns:pvml="urn:schemas-microsoft-com:office:powerpoint" xmlns:com="http://schemas.openxmlformats.org/drawingml/2006/compatibility" xmlns:p14="http://schemas.microsoft.com/office/powerpoint/2010/main" xmlns:p15="http://schemas.microsoft.com/office/powerpoint/2012/main" xmlns:ahyp="http://schemas.microsoft.com/office/drawing/2018/hyperlinkcolor">
   <p:cSld>
     <p:spTree>
@@ -31381,7 +30521,7 @@
 </p:sld>
 </file>
 
-<file path=ppt/slides/slide6.xml><?xml version="1.0" encoding="utf-8"?>
+<file path=ppt/slides/slide5.xml><?xml version="1.0" encoding="utf-8"?>
 <p:sld xmlns:a="http://schemas.openxmlformats.org/drawingml/2006/main" xmlns:r="http://schemas.openxmlformats.org/officeDocument/2006/relationships" xmlns:mc="http://schemas.openxmlformats.org/markup-compatibility/2006" xmlns:mv="urn:schemas-microsoft-com:mac:vml" xmlns:p="http://schemas.openxmlformats.org/presentationml/2006/main" xmlns:c="http://schemas.openxmlformats.org/drawingml/2006/chart" xmlns:dgm="http://schemas.openxmlformats.org/drawingml/2006/diagram" xmlns:o="urn:schemas-microsoft-com:office:office" xmlns:v="urn:schemas-microsoft-com:vml" xmlns:pvml="urn:schemas-microsoft-com:office:powerpoint" xmlns:com="http://schemas.openxmlformats.org/drawingml/2006/compatibility" xmlns:p14="http://schemas.microsoft.com/office/powerpoint/2010/main" xmlns:p15="http://schemas.microsoft.com/office/powerpoint/2012/main" xmlns:ahyp="http://schemas.microsoft.com/office/drawing/2018/hyperlinkcolor">
   <p:cSld>
     <p:spTree>
@@ -31555,7 +30695,7 @@
 </p:sld>
 </file>
 
-<file path=ppt/slides/slide7.xml><?xml version="1.0" encoding="utf-8"?>
+<file path=ppt/slides/slide6.xml><?xml version="1.0" encoding="utf-8"?>
 <p:sld xmlns:a="http://schemas.openxmlformats.org/drawingml/2006/main" xmlns:r="http://schemas.openxmlformats.org/officeDocument/2006/relationships" xmlns:mc="http://schemas.openxmlformats.org/markup-compatibility/2006" xmlns:mv="urn:schemas-microsoft-com:mac:vml" xmlns:p="http://schemas.openxmlformats.org/presentationml/2006/main" xmlns:c="http://schemas.openxmlformats.org/drawingml/2006/chart" xmlns:dgm="http://schemas.openxmlformats.org/drawingml/2006/diagram" xmlns:o="urn:schemas-microsoft-com:office:office" xmlns:v="urn:schemas-microsoft-com:vml" xmlns:pvml="urn:schemas-microsoft-com:office:powerpoint" xmlns:com="http://schemas.openxmlformats.org/drawingml/2006/compatibility" xmlns:p14="http://schemas.microsoft.com/office/powerpoint/2010/main" xmlns:p15="http://schemas.microsoft.com/office/powerpoint/2012/main" xmlns:ahyp="http://schemas.microsoft.com/office/drawing/2018/hyperlinkcolor">
   <p:cSld>
     <p:spTree>
@@ -31729,7 +30869,7 @@
 </p:sld>
 </file>
 
-<file path=ppt/slides/slide8.xml><?xml version="1.0" encoding="utf-8"?>
+<file path=ppt/slides/slide7.xml><?xml version="1.0" encoding="utf-8"?>
 <p:sld xmlns:a="http://schemas.openxmlformats.org/drawingml/2006/main" xmlns:r="http://schemas.openxmlformats.org/officeDocument/2006/relationships" xmlns:mc="http://schemas.openxmlformats.org/markup-compatibility/2006" xmlns:mv="urn:schemas-microsoft-com:mac:vml" xmlns:p="http://schemas.openxmlformats.org/presentationml/2006/main" xmlns:c="http://schemas.openxmlformats.org/drawingml/2006/chart" xmlns:dgm="http://schemas.openxmlformats.org/drawingml/2006/diagram" xmlns:o="urn:schemas-microsoft-com:office:office" xmlns:v="urn:schemas-microsoft-com:vml" xmlns:pvml="urn:schemas-microsoft-com:office:powerpoint" xmlns:com="http://schemas.openxmlformats.org/drawingml/2006/compatibility" xmlns:p14="http://schemas.microsoft.com/office/powerpoint/2010/main" xmlns:p15="http://schemas.microsoft.com/office/powerpoint/2012/main" xmlns:ahyp="http://schemas.microsoft.com/office/drawing/2018/hyperlinkcolor">
   <p:cSld>
     <p:spTree>
@@ -33750,7 +32890,7 @@
 </p:sld>
 </file>
 
-<file path=ppt/slides/slide9.xml><?xml version="1.0" encoding="utf-8"?>
+<file path=ppt/slides/slide8.xml><?xml version="1.0" encoding="utf-8"?>
 <p:sld xmlns:a="http://schemas.openxmlformats.org/drawingml/2006/main" xmlns:r="http://schemas.openxmlformats.org/officeDocument/2006/relationships" xmlns:mc="http://schemas.openxmlformats.org/markup-compatibility/2006" xmlns:mv="urn:schemas-microsoft-com:mac:vml" xmlns:p="http://schemas.openxmlformats.org/presentationml/2006/main" xmlns:c="http://schemas.openxmlformats.org/drawingml/2006/chart" xmlns:dgm="http://schemas.openxmlformats.org/drawingml/2006/diagram" xmlns:o="urn:schemas-microsoft-com:office:office" xmlns:v="urn:schemas-microsoft-com:vml" xmlns:pvml="urn:schemas-microsoft-com:office:powerpoint" xmlns:com="http://schemas.openxmlformats.org/drawingml/2006/compatibility" xmlns:p14="http://schemas.microsoft.com/office/powerpoint/2010/main" xmlns:p15="http://schemas.microsoft.com/office/powerpoint/2012/main" xmlns:ahyp="http://schemas.microsoft.com/office/drawing/2018/hyperlinkcolor">
   <p:cSld>
     <p:spTree>
@@ -34528,6 +33668,834 @@
                       </a:pPr>
                       <a:r>
                         <a:t/>
+                      </a:r>
+                      <a:endParaRPr/>
+                    </a:p>
+                  </a:txBody>
+                  <a:tcPr marT="45725" marB="36575" marR="45725" marL="91450" anchor="ctr">
+                    <a:solidFill>
+                      <a:srgbClr val="EDF4FC"/>
+                    </a:solidFill>
+                  </a:tcPr>
+                </a:tc>
+              </a:tr>
+            </a:tbl>
+          </a:graphicData>
+        </a:graphic>
+      </p:graphicFrame>
+    </p:spTree>
+  </p:cSld>
+  <p:clrMapOvr>
+    <a:masterClrMapping/>
+  </p:clrMapOvr>
+</p:sld>
+</file>
+
+<file path=ppt/slides/slide9.xml><?xml version="1.0" encoding="utf-8"?>
+<p:sld xmlns:a="http://schemas.openxmlformats.org/drawingml/2006/main" xmlns:r="http://schemas.openxmlformats.org/officeDocument/2006/relationships" xmlns:mc="http://schemas.openxmlformats.org/markup-compatibility/2006" xmlns:mv="urn:schemas-microsoft-com:mac:vml" xmlns:p="http://schemas.openxmlformats.org/presentationml/2006/main" xmlns:c="http://schemas.openxmlformats.org/drawingml/2006/chart" xmlns:dgm="http://schemas.openxmlformats.org/drawingml/2006/diagram" xmlns:o="urn:schemas-microsoft-com:office:office" xmlns:v="urn:schemas-microsoft-com:vml" xmlns:pvml="urn:schemas-microsoft-com:office:powerpoint" xmlns:com="http://schemas.openxmlformats.org/drawingml/2006/compatibility" xmlns:p14="http://schemas.microsoft.com/office/powerpoint/2010/main" xmlns:p15="http://schemas.microsoft.com/office/powerpoint/2012/main" xmlns:ahyp="http://schemas.microsoft.com/office/drawing/2018/hyperlinkcolor">
+  <p:cSld>
+    <p:spTree>
+      <p:nvGrpSpPr>
+        <p:cNvPr id="209" name="Shape 209"/>
+        <p:cNvGrpSpPr/>
+        <p:nvPr/>
+      </p:nvGrpSpPr>
+      <p:grpSpPr>
+        <a:xfrm>
+          <a:off x="0" y="0"/>
+          <a:ext cx="0" cy="0"/>
+          <a:chOff x="0" y="0"/>
+          <a:chExt cx="0" cy="0"/>
+        </a:xfrm>
+      </p:grpSpPr>
+      <p:sp>
+        <p:nvSpPr>
+          <p:cNvPr id="210" name="Google Shape;210;p38"/>
+          <p:cNvSpPr/>
+          <p:nvPr/>
+        </p:nvSpPr>
+        <p:spPr>
+          <a:xfrm>
+            <a:off x="438912" y="740664"/>
+            <a:ext cx="8266200" cy="13800"/>
+          </a:xfrm>
+          <a:prstGeom prst="rect">
+            <a:avLst/>
+          </a:prstGeom>
+          <a:solidFill>
+            <a:srgbClr val="DAE1EB"/>
+          </a:solidFill>
+          <a:ln>
+            <a:noFill/>
+          </a:ln>
+          <a:effectLst>
+            <a:outerShdw blurRad="40000" rotWithShape="0" dir="5400000" dist="23000">
+              <a:srgbClr val="000000">
+                <a:alpha val="34900"/>
+              </a:srgbClr>
+            </a:outerShdw>
+          </a:effectLst>
+        </p:spPr>
+        <p:txBody>
+          <a:bodyPr anchorCtr="0" anchor="ctr" bIns="45700" lIns="91425" spcFirstLastPara="1" rIns="91425" wrap="square" tIns="45700">
+            <a:noAutofit/>
+          </a:bodyPr>
+          <a:lstStyle/>
+          <a:p>
+            <a:pPr indent="0" lvl="0" marL="0" marR="0" rtl="0" algn="ctr">
+              <a:lnSpc>
+                <a:spcPct val="100000"/>
+              </a:lnSpc>
+              <a:spcBef>
+                <a:spcPts val="0"/>
+              </a:spcBef>
+              <a:spcAft>
+                <a:spcPts val="0"/>
+              </a:spcAft>
+              <a:buClr>
+                <a:srgbClr val="000000"/>
+              </a:buClr>
+              <a:buSzPts val="1400"/>
+              <a:buFont typeface="Arial"/>
+              <a:buNone/>
+            </a:pPr>
+            <a:r>
+              <a:t/>
+            </a:r>
+            <a:endParaRPr b="0" i="0" sz="1400" u="none" cap="none" strike="noStrike">
+              <a:solidFill>
+                <a:schemeClr val="lt1"/>
+              </a:solidFill>
+              <a:latin typeface="Arial"/>
+              <a:ea typeface="Arial"/>
+              <a:cs typeface="Arial"/>
+              <a:sym typeface="Arial"/>
+            </a:endParaRPr>
+          </a:p>
+        </p:txBody>
+      </p:sp>
+      <p:sp>
+        <p:nvSpPr>
+          <p:cNvPr id="211" name="Google Shape;211;p38"/>
+          <p:cNvSpPr txBox="1"/>
+          <p:nvPr/>
+        </p:nvSpPr>
+        <p:spPr>
+          <a:xfrm>
+            <a:off x="438912" y="164592"/>
+            <a:ext cx="8321100" cy="354000"/>
+          </a:xfrm>
+          <a:prstGeom prst="rect">
+            <a:avLst/>
+          </a:prstGeom>
+          <a:noFill/>
+          <a:ln>
+            <a:noFill/>
+          </a:ln>
+        </p:spPr>
+        <p:txBody>
+          <a:bodyPr anchorCtr="0" anchor="t" bIns="0" lIns="0" spcFirstLastPara="1" rIns="0" wrap="square" tIns="0">
+            <a:spAutoFit/>
+          </a:bodyPr>
+          <a:lstStyle/>
+          <a:p>
+            <a:pPr indent="0" lvl="0" marL="0" marR="0" rtl="0" algn="l">
+              <a:lnSpc>
+                <a:spcPct val="100000"/>
+              </a:lnSpc>
+              <a:spcBef>
+                <a:spcPts val="0"/>
+              </a:spcBef>
+              <a:spcAft>
+                <a:spcPts val="0"/>
+              </a:spcAft>
+              <a:buNone/>
+            </a:pPr>
+            <a:r>
+              <a:rPr b="1" i="0" lang="en" sz="2300" u="none" cap="none" strike="noStrike">
+                <a:solidFill>
+                  <a:srgbClr val="183153"/>
+                </a:solidFill>
+                <a:latin typeface="Arial"/>
+                <a:ea typeface="Arial"/>
+                <a:cs typeface="Arial"/>
+                <a:sym typeface="Arial"/>
+              </a:rPr>
+              <a:t>Reference Quality Matters for Instance-Level Rubrics</a:t>
+            </a:r>
+            <a:endParaRPr/>
+          </a:p>
+        </p:txBody>
+      </p:sp>
+      <p:sp>
+        <p:nvSpPr>
+          <p:cNvPr id="212" name="Google Shape;212;p38"/>
+          <p:cNvSpPr txBox="1"/>
+          <p:nvPr/>
+        </p:nvSpPr>
+        <p:spPr>
+          <a:xfrm>
+            <a:off x="530352" y="941832"/>
+            <a:ext cx="8138100" cy="461700"/>
+          </a:xfrm>
+          <a:prstGeom prst="rect">
+            <a:avLst/>
+          </a:prstGeom>
+          <a:noFill/>
+          <a:ln>
+            <a:noFill/>
+          </a:ln>
+        </p:spPr>
+        <p:txBody>
+          <a:bodyPr anchorCtr="0" anchor="t" bIns="0" lIns="0" spcFirstLastPara="1" rIns="0" wrap="square" tIns="0">
+            <a:spAutoFit/>
+          </a:bodyPr>
+          <a:lstStyle/>
+          <a:p>
+            <a:pPr indent="0" lvl="0" marL="0" marR="0" rtl="0" algn="l">
+              <a:lnSpc>
+                <a:spcPct val="100000"/>
+              </a:lnSpc>
+              <a:spcBef>
+                <a:spcPts val="0"/>
+              </a:spcBef>
+              <a:spcAft>
+                <a:spcPts val="0"/>
+              </a:spcAft>
+              <a:buNone/>
+            </a:pPr>
+            <a:r>
+              <a:rPr b="0" i="0" lang="en" sz="1500" u="none" cap="none" strike="noStrike">
+                <a:solidFill>
+                  <a:srgbClr val="183153"/>
+                </a:solidFill>
+                <a:latin typeface="Arial"/>
+                <a:ea typeface="Arial"/>
+                <a:cs typeface="Arial"/>
+                <a:sym typeface="Arial"/>
+              </a:rPr>
+              <a:t>RaR builds a rubric from each problem’s reference answer.</a:t>
+            </a:r>
+            <a:endParaRPr/>
+          </a:p>
+          <a:p>
+            <a:pPr indent="0" lvl="0" marL="0" marR="0" rtl="0" algn="l">
+              <a:lnSpc>
+                <a:spcPct val="100000"/>
+              </a:lnSpc>
+              <a:spcBef>
+                <a:spcPts val="0"/>
+              </a:spcBef>
+              <a:spcAft>
+                <a:spcPts val="0"/>
+              </a:spcAft>
+              <a:buNone/>
+            </a:pPr>
+            <a:r>
+              <a:rPr b="0" i="0" lang="en" sz="1500" u="none" cap="none" strike="noStrike">
+                <a:solidFill>
+                  <a:srgbClr val="183153"/>
+                </a:solidFill>
+                <a:latin typeface="Arial"/>
+                <a:ea typeface="Arial"/>
+                <a:cs typeface="Arial"/>
+                <a:sym typeface="Arial"/>
+              </a:rPr>
+              <a:t>SCRIBE reuses skill rubrics without requiring golden reference answers.</a:t>
+            </a:r>
+            <a:endParaRPr/>
+          </a:p>
+        </p:txBody>
+      </p:sp>
+      <p:graphicFrame>
+        <p:nvGraphicFramePr>
+          <p:cNvPr id="213" name="Google Shape;213;p38"/>
+          <p:cNvGraphicFramePr/>
+          <p:nvPr/>
+        </p:nvGraphicFramePr>
+        <p:xfrm>
+          <a:off x="530352" y="2487168"/>
+          <a:ext cx="3000000" cy="3000000"/>
+        </p:xfrm>
+        <a:graphic>
+          <a:graphicData uri="http://schemas.openxmlformats.org/drawingml/2006/table">
+            <a:tbl>
+              <a:tblPr bandRow="1" firstRow="1">
+                <a:noFill/>
+                <a:tableStyleId>{60C7E03B-85A4-41BA-8E18-2549407F5BF5}</a:tableStyleId>
+              </a:tblPr>
+              <a:tblGrid>
+                <a:gridCol w="1856225"/>
+                <a:gridCol w="2386575"/>
+                <a:gridCol w="1280150"/>
+                <a:gridCol w="1280150"/>
+                <a:gridCol w="1280150"/>
+              </a:tblGrid>
+              <a:tr h="420625">
+                <a:tc>
+                  <a:txBody>
+                    <a:bodyPr/>
+                    <a:lstStyle/>
+                    <a:p>
+                      <a:pPr indent="0" lvl="0" marL="0" marR="0" rtl="0" algn="l">
+                        <a:lnSpc>
+                          <a:spcPct val="100000"/>
+                        </a:lnSpc>
+                        <a:spcBef>
+                          <a:spcPts val="0"/>
+                        </a:spcBef>
+                        <a:spcAft>
+                          <a:spcPts val="0"/>
+                        </a:spcAft>
+                        <a:buNone/>
+                      </a:pPr>
+                      <a:r>
+                        <a:rPr b="1" lang="en" sz="1300" u="none" cap="none" strike="noStrike">
+                          <a:solidFill>
+                            <a:srgbClr val="FFFFFF"/>
+                          </a:solidFill>
+                          <a:latin typeface="Arial"/>
+                          <a:ea typeface="Arial"/>
+                          <a:cs typeface="Arial"/>
+                          <a:sym typeface="Arial"/>
+                        </a:rPr>
+                        <a:t>Method</a:t>
+                      </a:r>
+                      <a:endParaRPr/>
+                    </a:p>
+                  </a:txBody>
+                  <a:tcPr marT="45725" marB="36575" marR="45725" marL="91450" anchor="ctr">
+                    <a:solidFill>
+                      <a:srgbClr val="183153"/>
+                    </a:solidFill>
+                  </a:tcPr>
+                </a:tc>
+                <a:tc>
+                  <a:txBody>
+                    <a:bodyPr/>
+                    <a:lstStyle/>
+                    <a:p>
+                      <a:pPr indent="0" lvl="0" marL="0" marR="0" rtl="0" algn="ctr">
+                        <a:lnSpc>
+                          <a:spcPct val="100000"/>
+                        </a:lnSpc>
+                        <a:spcBef>
+                          <a:spcPts val="0"/>
+                        </a:spcBef>
+                        <a:spcAft>
+                          <a:spcPts val="0"/>
+                        </a:spcAft>
+                        <a:buNone/>
+                      </a:pPr>
+                      <a:r>
+                        <a:rPr b="1" lang="en" sz="1300" u="none" cap="none" strike="noStrike">
+                          <a:solidFill>
+                            <a:srgbClr val="FFFFFF"/>
+                          </a:solidFill>
+                          <a:latin typeface="Arial"/>
+                          <a:ea typeface="Arial"/>
+                          <a:cs typeface="Arial"/>
+                          <a:sym typeface="Arial"/>
+                        </a:rPr>
+                        <a:t>Reference source</a:t>
+                      </a:r>
+                      <a:endParaRPr/>
+                    </a:p>
+                  </a:txBody>
+                  <a:tcPr marT="45725" marB="36575" marR="45725" marL="91450" anchor="ctr">
+                    <a:solidFill>
+                      <a:srgbClr val="183153"/>
+                    </a:solidFill>
+                  </a:tcPr>
+                </a:tc>
+                <a:tc>
+                  <a:txBody>
+                    <a:bodyPr/>
+                    <a:lstStyle/>
+                    <a:p>
+                      <a:pPr indent="0" lvl="0" marL="0" marR="0" rtl="0" algn="ctr">
+                        <a:lnSpc>
+                          <a:spcPct val="100000"/>
+                        </a:lnSpc>
+                        <a:spcBef>
+                          <a:spcPts val="0"/>
+                        </a:spcBef>
+                        <a:spcAft>
+                          <a:spcPts val="0"/>
+                        </a:spcAft>
+                        <a:buNone/>
+                      </a:pPr>
+                      <a:r>
+                        <a:rPr b="1" lang="en" sz="1300" u="none" cap="none" strike="noStrike">
+                          <a:solidFill>
+                            <a:srgbClr val="FFFFFF"/>
+                          </a:solidFill>
+                          <a:latin typeface="Arial"/>
+                          <a:ea typeface="Arial"/>
+                          <a:cs typeface="Arial"/>
+                          <a:sym typeface="Arial"/>
+                        </a:rPr>
+                        <a:t>MATH500</a:t>
+                      </a:r>
+                      <a:endParaRPr/>
+                    </a:p>
+                  </a:txBody>
+                  <a:tcPr marT="45725" marB="36575" marR="45725" marL="91450" anchor="ctr">
+                    <a:solidFill>
+                      <a:srgbClr val="183153"/>
+                    </a:solidFill>
+                  </a:tcPr>
+                </a:tc>
+                <a:tc>
+                  <a:txBody>
+                    <a:bodyPr/>
+                    <a:lstStyle/>
+                    <a:p>
+                      <a:pPr indent="0" lvl="0" marL="0" marR="0" rtl="0" algn="ctr">
+                        <a:lnSpc>
+                          <a:spcPct val="100000"/>
+                        </a:lnSpc>
+                        <a:spcBef>
+                          <a:spcPts val="0"/>
+                        </a:spcBef>
+                        <a:spcAft>
+                          <a:spcPts val="0"/>
+                        </a:spcAft>
+                        <a:buNone/>
+                      </a:pPr>
+                      <a:r>
+                        <a:rPr b="1" lang="en" sz="1300" u="none" cap="none" strike="noStrike">
+                          <a:solidFill>
+                            <a:srgbClr val="FFFFFF"/>
+                          </a:solidFill>
+                          <a:latin typeface="Arial"/>
+                          <a:ea typeface="Arial"/>
+                          <a:cs typeface="Arial"/>
+                          <a:sym typeface="Arial"/>
+                        </a:rPr>
+                        <a:t>AIME25</a:t>
+                      </a:r>
+                      <a:endParaRPr/>
+                    </a:p>
+                  </a:txBody>
+                  <a:tcPr marT="45725" marB="36575" marR="45725" marL="91450" anchor="ctr">
+                    <a:solidFill>
+                      <a:srgbClr val="183153"/>
+                    </a:solidFill>
+                  </a:tcPr>
+                </a:tc>
+                <a:tc>
+                  <a:txBody>
+                    <a:bodyPr/>
+                    <a:lstStyle/>
+                    <a:p>
+                      <a:pPr indent="0" lvl="0" marL="0" marR="0" rtl="0" algn="ctr">
+                        <a:lnSpc>
+                          <a:spcPct val="100000"/>
+                        </a:lnSpc>
+                        <a:spcBef>
+                          <a:spcPts val="0"/>
+                        </a:spcBef>
+                        <a:spcAft>
+                          <a:spcPts val="0"/>
+                        </a:spcAft>
+                        <a:buNone/>
+                      </a:pPr>
+                      <a:r>
+                        <a:rPr b="1" lang="en" sz="1300" u="none" cap="none" strike="noStrike">
+                          <a:solidFill>
+                            <a:srgbClr val="FFFFFF"/>
+                          </a:solidFill>
+                          <a:latin typeface="Arial"/>
+                          <a:ea typeface="Arial"/>
+                          <a:cs typeface="Arial"/>
+                          <a:sym typeface="Arial"/>
+                        </a:rPr>
+                        <a:t>BFCL</a:t>
+                      </a:r>
+                      <a:endParaRPr/>
+                    </a:p>
+                  </a:txBody>
+                  <a:tcPr marT="45725" marB="36575" marR="45725" marL="91450" anchor="ctr">
+                    <a:solidFill>
+                      <a:srgbClr val="183153"/>
+                    </a:solidFill>
+                  </a:tcPr>
+                </a:tc>
+              </a:tr>
+              <a:tr h="420625">
+                <a:tc>
+                  <a:txBody>
+                    <a:bodyPr/>
+                    <a:lstStyle/>
+                    <a:p>
+                      <a:pPr indent="0" lvl="0" marL="0" marR="0" rtl="0" algn="l">
+                        <a:lnSpc>
+                          <a:spcPct val="100000"/>
+                        </a:lnSpc>
+                        <a:spcBef>
+                          <a:spcPts val="0"/>
+                        </a:spcBef>
+                        <a:spcAft>
+                          <a:spcPts val="0"/>
+                        </a:spcAft>
+                        <a:buNone/>
+                      </a:pPr>
+                      <a:r>
+                        <a:rPr b="0" lang="en" sz="1300" u="none" cap="none" strike="noStrike">
+                          <a:solidFill>
+                            <a:srgbClr val="183153"/>
+                          </a:solidFill>
+                          <a:latin typeface="Arial"/>
+                          <a:ea typeface="Arial"/>
+                          <a:cs typeface="Arial"/>
+                          <a:sym typeface="Arial"/>
+                        </a:rPr>
+                        <a:t>RaR</a:t>
+                      </a:r>
+                      <a:endParaRPr/>
+                    </a:p>
+                  </a:txBody>
+                  <a:tcPr marT="45725" marB="36575" marR="45725" marL="91450" anchor="ctr">
+                    <a:solidFill>
+                      <a:srgbClr val="F7F9FC"/>
+                    </a:solidFill>
+                  </a:tcPr>
+                </a:tc>
+                <a:tc>
+                  <a:txBody>
+                    <a:bodyPr/>
+                    <a:lstStyle/>
+                    <a:p>
+                      <a:pPr indent="0" lvl="0" marL="0" marR="0" rtl="0" algn="ctr">
+                        <a:lnSpc>
+                          <a:spcPct val="100000"/>
+                        </a:lnSpc>
+                        <a:spcBef>
+                          <a:spcPts val="0"/>
+                        </a:spcBef>
+                        <a:spcAft>
+                          <a:spcPts val="0"/>
+                        </a:spcAft>
+                        <a:buNone/>
+                      </a:pPr>
+                      <a:r>
+                        <a:rPr b="0" lang="en" sz="1300" u="none" cap="none" strike="noStrike">
+                          <a:solidFill>
+                            <a:srgbClr val="183153"/>
+                          </a:solidFill>
+                          <a:latin typeface="Arial"/>
+                          <a:ea typeface="Arial"/>
+                          <a:cs typeface="Arial"/>
+                          <a:sym typeface="Arial"/>
+                        </a:rPr>
+                        <a:t>GPT-5.1 labeled</a:t>
+                      </a:r>
+                      <a:endParaRPr/>
+                    </a:p>
+                  </a:txBody>
+                  <a:tcPr marT="45725" marB="36575" marR="45725" marL="91450" anchor="ctr">
+                    <a:solidFill>
+                      <a:srgbClr val="F7F9FC"/>
+                    </a:solidFill>
+                  </a:tcPr>
+                </a:tc>
+                <a:tc>
+                  <a:txBody>
+                    <a:bodyPr/>
+                    <a:lstStyle/>
+                    <a:p>
+                      <a:pPr indent="0" lvl="0" marL="0" marR="0" rtl="0" algn="ctr">
+                        <a:lnSpc>
+                          <a:spcPct val="100000"/>
+                        </a:lnSpc>
+                        <a:spcBef>
+                          <a:spcPts val="0"/>
+                        </a:spcBef>
+                        <a:spcAft>
+                          <a:spcPts val="0"/>
+                        </a:spcAft>
+                        <a:buNone/>
+                      </a:pPr>
+                      <a:r>
+                        <a:rPr b="0" lang="en" sz="1300" u="none" cap="none" strike="noStrike">
+                          <a:solidFill>
+                            <a:srgbClr val="183153"/>
+                          </a:solidFill>
+                          <a:latin typeface="Arial"/>
+                          <a:ea typeface="Arial"/>
+                          <a:cs typeface="Arial"/>
+                          <a:sym typeface="Arial"/>
+                        </a:rPr>
+                        <a:t>90.7</a:t>
+                      </a:r>
+                      <a:endParaRPr/>
+                    </a:p>
+                  </a:txBody>
+                  <a:tcPr marT="45725" marB="36575" marR="45725" marL="91450" anchor="ctr">
+                    <a:solidFill>
+                      <a:srgbClr val="F7F9FC"/>
+                    </a:solidFill>
+                  </a:tcPr>
+                </a:tc>
+                <a:tc>
+                  <a:txBody>
+                    <a:bodyPr/>
+                    <a:lstStyle/>
+                    <a:p>
+                      <a:pPr indent="0" lvl="0" marL="0" marR="0" rtl="0" algn="ctr">
+                        <a:lnSpc>
+                          <a:spcPct val="100000"/>
+                        </a:lnSpc>
+                        <a:spcBef>
+                          <a:spcPts val="0"/>
+                        </a:spcBef>
+                        <a:spcAft>
+                          <a:spcPts val="0"/>
+                        </a:spcAft>
+                        <a:buNone/>
+                      </a:pPr>
+                      <a:r>
+                        <a:rPr b="0" lang="en" sz="1300" u="none" cap="none" strike="noStrike">
+                          <a:solidFill>
+                            <a:srgbClr val="183153"/>
+                          </a:solidFill>
+                          <a:latin typeface="Arial"/>
+                          <a:ea typeface="Arial"/>
+                          <a:cs typeface="Arial"/>
+                          <a:sym typeface="Arial"/>
+                        </a:rPr>
+                        <a:t>43.3</a:t>
+                      </a:r>
+                      <a:endParaRPr/>
+                    </a:p>
+                  </a:txBody>
+                  <a:tcPr marT="45725" marB="36575" marR="45725" marL="91450" anchor="ctr">
+                    <a:solidFill>
+                      <a:srgbClr val="F7F9FC"/>
+                    </a:solidFill>
+                  </a:tcPr>
+                </a:tc>
+                <a:tc>
+                  <a:txBody>
+                    <a:bodyPr/>
+                    <a:lstStyle/>
+                    <a:p>
+                      <a:pPr indent="0" lvl="0" marL="0" marR="0" rtl="0" algn="ctr">
+                        <a:lnSpc>
+                          <a:spcPct val="100000"/>
+                        </a:lnSpc>
+                        <a:spcBef>
+                          <a:spcPts val="0"/>
+                        </a:spcBef>
+                        <a:spcAft>
+                          <a:spcPts val="0"/>
+                        </a:spcAft>
+                        <a:buNone/>
+                      </a:pPr>
+                      <a:r>
+                        <a:rPr b="0" lang="en" sz="1300" u="none" cap="none" strike="noStrike">
+                          <a:solidFill>
+                            <a:srgbClr val="183153"/>
+                          </a:solidFill>
+                          <a:latin typeface="Arial"/>
+                          <a:ea typeface="Arial"/>
+                          <a:cs typeface="Arial"/>
+                          <a:sym typeface="Arial"/>
+                        </a:rPr>
+                        <a:t>46.2</a:t>
+                      </a:r>
+                      <a:endParaRPr/>
+                    </a:p>
+                  </a:txBody>
+                  <a:tcPr marT="45725" marB="36575" marR="45725" marL="91450" anchor="ctr">
+                    <a:solidFill>
+                      <a:srgbClr val="F7F9FC"/>
+                    </a:solidFill>
+                  </a:tcPr>
+                </a:tc>
+              </a:tr>
+              <a:tr h="420625">
+                <a:tc>
+                  <a:txBody>
+                    <a:bodyPr/>
+                    <a:lstStyle/>
+                    <a:p>
+                      <a:pPr indent="0" lvl="0" marL="0" marR="0" rtl="0" algn="l">
+                        <a:lnSpc>
+                          <a:spcPct val="100000"/>
+                        </a:lnSpc>
+                        <a:spcBef>
+                          <a:spcPts val="0"/>
+                        </a:spcBef>
+                        <a:spcAft>
+                          <a:spcPts val="0"/>
+                        </a:spcAft>
+                        <a:buNone/>
+                      </a:pPr>
+                      <a:r>
+                        <a:rPr b="1" lang="en" sz="1300" u="none" cap="none" strike="noStrike">
+                          <a:solidFill>
+                            <a:srgbClr val="183153"/>
+                          </a:solidFill>
+                          <a:latin typeface="Arial"/>
+                          <a:ea typeface="Arial"/>
+                          <a:cs typeface="Arial"/>
+                          <a:sym typeface="Arial"/>
+                        </a:rPr>
+                        <a:t>SCRIBE</a:t>
+                      </a:r>
+                      <a:endParaRPr/>
+                    </a:p>
+                  </a:txBody>
+                  <a:tcPr marT="45725" marB="36575" marR="45725" marL="91450" anchor="ctr">
+                    <a:solidFill>
+                      <a:srgbClr val="EDF4FC"/>
+                    </a:solidFill>
+                  </a:tcPr>
+                </a:tc>
+                <a:tc>
+                  <a:txBody>
+                    <a:bodyPr/>
+                    <a:lstStyle/>
+                    <a:p>
+                      <a:pPr indent="0" lvl="0" marL="0" marR="0" rtl="0" algn="ctr">
+                        <a:lnSpc>
+                          <a:spcPct val="100000"/>
+                        </a:lnSpc>
+                        <a:spcBef>
+                          <a:spcPts val="0"/>
+                        </a:spcBef>
+                        <a:spcAft>
+                          <a:spcPts val="0"/>
+                        </a:spcAft>
+                        <a:buNone/>
+                      </a:pPr>
+                      <a:r>
+                        <a:rPr b="1" lang="en" sz="1300" u="none" cap="none" strike="noStrike">
+                          <a:solidFill>
+                            <a:srgbClr val="183153"/>
+                          </a:solidFill>
+                          <a:latin typeface="Arial"/>
+                          <a:ea typeface="Arial"/>
+                          <a:cs typeface="Arial"/>
+                          <a:sym typeface="Arial"/>
+                        </a:rPr>
+                        <a:t>Not required</a:t>
+                      </a:r>
+                      <a:endParaRPr/>
+                    </a:p>
+                  </a:txBody>
+                  <a:tcPr marT="45725" marB="36575" marR="45725" marL="91450" anchor="ctr">
+                    <a:solidFill>
+                      <a:srgbClr val="EDF4FC"/>
+                    </a:solidFill>
+                  </a:tcPr>
+                </a:tc>
+                <a:tc>
+                  <a:txBody>
+                    <a:bodyPr/>
+                    <a:lstStyle/>
+                    <a:p>
+                      <a:pPr indent="0" lvl="0" marL="0" marR="0" rtl="0" algn="ctr">
+                        <a:lnSpc>
+                          <a:spcPct val="100000"/>
+                        </a:lnSpc>
+                        <a:spcBef>
+                          <a:spcPts val="0"/>
+                        </a:spcBef>
+                        <a:spcAft>
+                          <a:spcPts val="0"/>
+                        </a:spcAft>
+                        <a:buNone/>
+                      </a:pPr>
+                      <a:r>
+                        <a:rPr b="1" lang="en" sz="1300" u="none" cap="none" strike="noStrike">
+                          <a:solidFill>
+                            <a:srgbClr val="183153"/>
+                          </a:solidFill>
+                          <a:latin typeface="Arial"/>
+                          <a:ea typeface="Arial"/>
+                          <a:cs typeface="Arial"/>
+                          <a:sym typeface="Arial"/>
+                        </a:rPr>
+                        <a:t>95.8</a:t>
+                      </a:r>
+                      <a:endParaRPr/>
+                    </a:p>
+                  </a:txBody>
+                  <a:tcPr marT="45725" marB="36575" marR="45725" marL="91450" anchor="ctr">
+                    <a:solidFill>
+                      <a:srgbClr val="EDF4FC"/>
+                    </a:solidFill>
+                  </a:tcPr>
+                </a:tc>
+                <a:tc>
+                  <a:txBody>
+                    <a:bodyPr/>
+                    <a:lstStyle/>
+                    <a:p>
+                      <a:pPr indent="0" lvl="0" marL="0" marR="0" rtl="0" algn="ctr">
+                        <a:lnSpc>
+                          <a:spcPct val="100000"/>
+                        </a:lnSpc>
+                        <a:spcBef>
+                          <a:spcPts val="0"/>
+                        </a:spcBef>
+                        <a:spcAft>
+                          <a:spcPts val="0"/>
+                        </a:spcAft>
+                        <a:buNone/>
+                      </a:pPr>
+                      <a:r>
+                        <a:rPr b="1" lang="en" sz="1300" u="none" cap="none" strike="noStrike">
+                          <a:solidFill>
+                            <a:srgbClr val="183153"/>
+                          </a:solidFill>
+                          <a:latin typeface="Arial"/>
+                          <a:ea typeface="Arial"/>
+                          <a:cs typeface="Arial"/>
+                          <a:sym typeface="Arial"/>
+                        </a:rPr>
+                        <a:t>63.3</a:t>
+                      </a:r>
+                      <a:endParaRPr/>
+                    </a:p>
+                  </a:txBody>
+                  <a:tcPr marT="45725" marB="36575" marR="45725" marL="91450" anchor="ctr">
+                    <a:solidFill>
+                      <a:srgbClr val="EDF4FC"/>
+                    </a:solidFill>
+                  </a:tcPr>
+                </a:tc>
+                <a:tc>
+                  <a:txBody>
+                    <a:bodyPr/>
+                    <a:lstStyle/>
+                    <a:p>
+                      <a:pPr indent="0" lvl="0" marL="0" marR="0" rtl="0" algn="ctr">
+                        <a:lnSpc>
+                          <a:spcPct val="100000"/>
+                        </a:lnSpc>
+                        <a:spcBef>
+                          <a:spcPts val="0"/>
+                        </a:spcBef>
+                        <a:spcAft>
+                          <a:spcPts val="0"/>
+                        </a:spcAft>
+                        <a:buNone/>
+                      </a:pPr>
+                      <a:r>
+                        <a:rPr b="1" lang="en" sz="1300" u="none" cap="none" strike="noStrike">
+                          <a:solidFill>
+                            <a:srgbClr val="183153"/>
+                          </a:solidFill>
+                          <a:latin typeface="Arial"/>
+                          <a:ea typeface="Arial"/>
+                          <a:cs typeface="Arial"/>
+                          <a:sym typeface="Arial"/>
+                        </a:rPr>
+                        <a:t>51.3</a:t>
                       </a:r>
                       <a:endParaRPr/>
                     </a:p>

</xml_diff>

<commit_message>
Replace abstract BFCL overview with concrete tool-call example
</commit_message>
<xml_diff>
--- a/slides/SCRIBE_EMNLP2026.pptx
+++ b/slides/SCRIBE_EMNLP2026.pptx
@@ -1689,7 +1689,7 @@
           <a:lstStyle/>
           <a:p>
             <a:r>
-              <a:t>We also evaluate tool use with BFCL V4. Here, success requires selecting an appropriate tool, supplying suitable arguments, and coordinating calls when the task involves multiple steps. The benchmark includes search, memory, single-turn, and multi-turn settings. These tasks provide a different test of our approach: reusable skills must support tool-using behavior as well as mathematical reasoning.</a:t>
+              <a:t>BFCL V4 tests whether models can use tools correctly. Here is a simple example adapted from the official BFCL multi-step explanation, a category retained in V4. The user asks for the weather in Berkeley. The model first calls the city-to-ZIP-code tool and receives 94710. It then uses that returned value to call the weather tool. The important behavior is choosing the appropriate functions, filling the arguments correctly, and respecting the dependency between the calls. Guessing a ZIP code instead of looking it up skips a required step in this example. V4 also includes single-turn and multi-turn tasks, web search, and memory. This connects to SCRIBE: we want rewards to recognize whether each intermediate tool-use subgoal was completed correctly. Source: https://gorilla.cs.berkeley.edu/blogs/13_bfcl_v3_multi_turn.html and https://gorilla.cs.berkeley.edu/leaderboard</a:t>
             </a:r>
           </a:p>
         </p:txBody>
@@ -22478,7 +22478,7 @@
         <p:spPr>
           <a:xfrm>
             <a:off x="438912" y="292608"/>
-            <a:ext cx="7818000" cy="421800"/>
+            <a:ext cx="8266175" cy="421800"/>
           </a:xfrm>
           <a:prstGeom prst="rect">
             <a:avLst/>
@@ -22494,1191 +22494,17 @@
           </a:bodyPr>
           <a:lstStyle/>
           <a:p>
-            <a:pPr marL="0" marR="0" lvl="0" indent="0" algn="l" rtl="0">
-              <a:lnSpc>
-                <a:spcPct val="100000"/>
-              </a:lnSpc>
-              <a:spcBef>
-                <a:spcPts val="0"/>
-              </a:spcBef>
-              <a:spcAft>
-                <a:spcPts val="0"/>
-              </a:spcAft>
-              <a:buClr>
-                <a:srgbClr val="000000"/>
-              </a:buClr>
-              <a:buSzPts val="2500"/>
-              <a:buFont typeface="Arial"/>
-              <a:buNone/>
+            <a:pPr>
+              <a:defRPr sz="2300" b="1">
+                <a:solidFill>
+                  <a:srgbClr val="193354"/>
+                </a:solidFill>
+                <a:latin typeface="Arial"/>
+              </a:defRPr>
             </a:pPr>
             <a:r>
-              <a:rPr lang="en" sz="2500" b="1" i="0" u="none" strike="noStrike" cap="none">
-                <a:solidFill>
-                  <a:srgbClr val="162849"/>
-                </a:solidFill>
-                <a:latin typeface="Arial"/>
-                <a:ea typeface="Arial"/>
-                <a:cs typeface="Arial"/>
-                <a:sym typeface="Arial"/>
-              </a:rPr>
-              <a:t>BFCL V4: Evaluating Tool-Calling Behavior</a:t>
+              <a:t>BFCL V4: Can the Model Use Tools Correctly?</a:t>
             </a:r>
-            <a:endParaRPr sz="1400" b="0" i="0" u="none" strike="noStrike" cap="none">
-              <a:solidFill>
-                <a:srgbClr val="000000"/>
-              </a:solidFill>
-              <a:latin typeface="Arial"/>
-              <a:ea typeface="Arial"/>
-              <a:cs typeface="Arial"/>
-              <a:sym typeface="Arial"/>
-            </a:endParaRPr>
-          </a:p>
-        </p:txBody>
-      </p:sp>
-      <p:sp>
-        <p:nvSpPr>
-          <p:cNvPr id="272" name="Google Shape;272;p44"/>
-          <p:cNvSpPr/>
-          <p:nvPr/>
-        </p:nvSpPr>
-        <p:spPr>
-          <a:xfrm>
-            <a:off x="566928" y="1024128"/>
-            <a:ext cx="2788800" cy="3383400"/>
-          </a:xfrm>
-          <a:prstGeom prst="roundRect">
-            <a:avLst>
-              <a:gd name="adj" fmla="val 16667"/>
-            </a:avLst>
-          </a:prstGeom>
-          <a:solidFill>
-            <a:srgbClr val="F7F9FD"/>
-          </a:solidFill>
-          <a:ln>
-            <a:noFill/>
-          </a:ln>
-          <a:effectLst>
-            <a:outerShdw blurRad="40000" dist="23000" dir="5400000" rotWithShape="0">
-              <a:srgbClr val="000000">
-                <a:alpha val="34902"/>
-              </a:srgbClr>
-            </a:outerShdw>
-          </a:effectLst>
-        </p:spPr>
-        <p:txBody>
-          <a:bodyPr spcFirstLastPara="1" wrap="square" lIns="54850" tIns="18275" rIns="54850" bIns="18275" anchor="ctr" anchorCtr="0">
-            <a:noAutofit/>
-          </a:bodyPr>
-          <a:lstStyle/>
-          <a:p>
-            <a:pPr marL="0" marR="0" lvl="0" indent="0" algn="l" rtl="0">
-              <a:lnSpc>
-                <a:spcPct val="100000"/>
-              </a:lnSpc>
-              <a:spcBef>
-                <a:spcPts val="0"/>
-              </a:spcBef>
-              <a:spcAft>
-                <a:spcPts val="0"/>
-              </a:spcAft>
-              <a:buClr>
-                <a:srgbClr val="000000"/>
-              </a:buClr>
-              <a:buSzPts val="1400"/>
-              <a:buFont typeface="Arial"/>
-              <a:buNone/>
-            </a:pPr>
-            <a:endParaRPr sz="1400" b="0" i="0" u="none" strike="noStrike" cap="none">
-              <a:solidFill>
-                <a:schemeClr val="lt1"/>
-              </a:solidFill>
-              <a:latin typeface="Arial"/>
-              <a:ea typeface="Arial"/>
-              <a:cs typeface="Arial"/>
-              <a:sym typeface="Arial"/>
-            </a:endParaRPr>
-          </a:p>
-        </p:txBody>
-      </p:sp>
-      <p:sp>
-        <p:nvSpPr>
-          <p:cNvPr id="273" name="Google Shape;273;p44"/>
-          <p:cNvSpPr txBox="1"/>
-          <p:nvPr/>
-        </p:nvSpPr>
-        <p:spPr>
-          <a:xfrm>
-            <a:off x="786384" y="1261872"/>
-            <a:ext cx="2359200" cy="175500"/>
-          </a:xfrm>
-          <a:prstGeom prst="rect">
-            <a:avLst/>
-          </a:prstGeom>
-          <a:noFill/>
-          <a:ln>
-            <a:noFill/>
-          </a:ln>
-        </p:spPr>
-        <p:txBody>
-          <a:bodyPr spcFirstLastPara="1" wrap="square" lIns="54850" tIns="18275" rIns="54850" bIns="18275" anchor="ctr" anchorCtr="0">
-            <a:spAutoFit/>
-          </a:bodyPr>
-          <a:lstStyle/>
-          <a:p>
-            <a:pPr marL="0" marR="0" lvl="0" indent="0" algn="l" rtl="0">
-              <a:lnSpc>
-                <a:spcPct val="100000"/>
-              </a:lnSpc>
-              <a:spcBef>
-                <a:spcPts val="0"/>
-              </a:spcBef>
-              <a:spcAft>
-                <a:spcPts val="0"/>
-              </a:spcAft>
-              <a:buClr>
-                <a:srgbClr val="000000"/>
-              </a:buClr>
-              <a:buSzPts val="900"/>
-              <a:buFont typeface="Arial"/>
-              <a:buNone/>
-            </a:pPr>
-            <a:r>
-              <a:rPr lang="en" sz="900" b="1" i="0" u="none" strike="noStrike" cap="none">
-                <a:solidFill>
-                  <a:srgbClr val="2870E6"/>
-                </a:solidFill>
-                <a:latin typeface="Arial"/>
-                <a:ea typeface="Arial"/>
-                <a:cs typeface="Arial"/>
-                <a:sym typeface="Arial"/>
-              </a:rPr>
-              <a:t>WHAT IT TESTS</a:t>
-            </a:r>
-            <a:endParaRPr sz="1400" b="0" i="0" u="none" strike="noStrike" cap="none">
-              <a:solidFill>
-                <a:srgbClr val="000000"/>
-              </a:solidFill>
-              <a:latin typeface="Arial"/>
-              <a:ea typeface="Arial"/>
-              <a:cs typeface="Arial"/>
-              <a:sym typeface="Arial"/>
-            </a:endParaRPr>
-          </a:p>
-        </p:txBody>
-      </p:sp>
-      <p:sp>
-        <p:nvSpPr>
-          <p:cNvPr id="274" name="Google Shape;274;p44"/>
-          <p:cNvSpPr txBox="1"/>
-          <p:nvPr/>
-        </p:nvSpPr>
-        <p:spPr>
-          <a:xfrm>
-            <a:off x="786384" y="1609344"/>
-            <a:ext cx="2359200" cy="1114500"/>
-          </a:xfrm>
-          <a:prstGeom prst="rect">
-            <a:avLst/>
-          </a:prstGeom>
-          <a:noFill/>
-          <a:ln>
-            <a:noFill/>
-          </a:ln>
-        </p:spPr>
-        <p:txBody>
-          <a:bodyPr spcFirstLastPara="1" wrap="square" lIns="54850" tIns="18275" rIns="54850" bIns="18275" anchor="ctr" anchorCtr="0">
-            <a:spAutoFit/>
-          </a:bodyPr>
-          <a:lstStyle/>
-          <a:p>
-            <a:pPr marL="0" marR="0" lvl="0" indent="0" algn="l" rtl="0">
-              <a:lnSpc>
-                <a:spcPct val="100000"/>
-              </a:lnSpc>
-              <a:spcBef>
-                <a:spcPts val="0"/>
-              </a:spcBef>
-              <a:spcAft>
-                <a:spcPts val="0"/>
-              </a:spcAft>
-              <a:buClr>
-                <a:srgbClr val="000000"/>
-              </a:buClr>
-              <a:buSzPts val="1400"/>
-              <a:buFont typeface="Arial"/>
-              <a:buNone/>
-            </a:pPr>
-            <a:r>
-              <a:rPr lang="en" sz="1400" b="1" i="0" u="none" strike="noStrike" cap="none">
-                <a:solidFill>
-                  <a:srgbClr val="162849"/>
-                </a:solidFill>
-                <a:latin typeface="Arial"/>
-                <a:ea typeface="Arial"/>
-                <a:cs typeface="Arial"/>
-                <a:sym typeface="Arial"/>
-              </a:rPr>
-              <a:t>Can a model select the correct function, construct valid arguments, and coordinate multiple calls?</a:t>
-            </a:r>
-            <a:endParaRPr sz="1400" b="0" i="0" u="none" strike="noStrike" cap="none">
-              <a:solidFill>
-                <a:srgbClr val="000000"/>
-              </a:solidFill>
-              <a:latin typeface="Arial"/>
-              <a:ea typeface="Arial"/>
-              <a:cs typeface="Arial"/>
-              <a:sym typeface="Arial"/>
-            </a:endParaRPr>
-          </a:p>
-        </p:txBody>
-      </p:sp>
-      <p:sp>
-        <p:nvSpPr>
-          <p:cNvPr id="275" name="Google Shape;275;p44"/>
-          <p:cNvSpPr txBox="1"/>
-          <p:nvPr/>
-        </p:nvSpPr>
-        <p:spPr>
-          <a:xfrm>
-            <a:off x="786384" y="2679192"/>
-            <a:ext cx="2359200" cy="175500"/>
-          </a:xfrm>
-          <a:prstGeom prst="rect">
-            <a:avLst/>
-          </a:prstGeom>
-          <a:noFill/>
-          <a:ln>
-            <a:noFill/>
-          </a:ln>
-        </p:spPr>
-        <p:txBody>
-          <a:bodyPr spcFirstLastPara="1" wrap="square" lIns="54850" tIns="18275" rIns="54850" bIns="18275" anchor="ctr" anchorCtr="0">
-            <a:spAutoFit/>
-          </a:bodyPr>
-          <a:lstStyle/>
-          <a:p>
-            <a:pPr marL="0" marR="0" lvl="0" indent="0" algn="l" rtl="0">
-              <a:lnSpc>
-                <a:spcPct val="100000"/>
-              </a:lnSpc>
-              <a:spcBef>
-                <a:spcPts val="0"/>
-              </a:spcBef>
-              <a:spcAft>
-                <a:spcPts val="0"/>
-              </a:spcAft>
-              <a:buClr>
-                <a:srgbClr val="000000"/>
-              </a:buClr>
-              <a:buSzPts val="900"/>
-              <a:buFont typeface="Arial"/>
-              <a:buNone/>
-            </a:pPr>
-            <a:r>
-              <a:rPr lang="en" sz="900" b="1" i="0" u="none" strike="noStrike" cap="none">
-                <a:solidFill>
-                  <a:srgbClr val="2870E6"/>
-                </a:solidFill>
-                <a:latin typeface="Arial"/>
-                <a:ea typeface="Arial"/>
-                <a:cs typeface="Arial"/>
-                <a:sym typeface="Arial"/>
-              </a:rPr>
-              <a:t>OUTPUT</a:t>
-            </a:r>
-            <a:endParaRPr sz="1400" b="0" i="0" u="none" strike="noStrike" cap="none">
-              <a:solidFill>
-                <a:srgbClr val="000000"/>
-              </a:solidFill>
-              <a:latin typeface="Arial"/>
-              <a:ea typeface="Arial"/>
-              <a:cs typeface="Arial"/>
-              <a:sym typeface="Arial"/>
-            </a:endParaRPr>
-          </a:p>
-        </p:txBody>
-      </p:sp>
-      <p:sp>
-        <p:nvSpPr>
-          <p:cNvPr id="276" name="Google Shape;276;p44"/>
-          <p:cNvSpPr txBox="1"/>
-          <p:nvPr/>
-        </p:nvSpPr>
-        <p:spPr>
-          <a:xfrm>
-            <a:off x="786384" y="2999232"/>
-            <a:ext cx="2359200" cy="614100"/>
-          </a:xfrm>
-          <a:prstGeom prst="rect">
-            <a:avLst/>
-          </a:prstGeom>
-          <a:noFill/>
-          <a:ln>
-            <a:noFill/>
-          </a:ln>
-        </p:spPr>
-        <p:txBody>
-          <a:bodyPr spcFirstLastPara="1" wrap="square" lIns="54850" tIns="18275" rIns="54850" bIns="18275" anchor="ctr" anchorCtr="0">
-            <a:spAutoFit/>
-          </a:bodyPr>
-          <a:lstStyle/>
-          <a:p>
-            <a:pPr marL="0" marR="0" lvl="0" indent="0" algn="l" rtl="0">
-              <a:lnSpc>
-                <a:spcPct val="100000"/>
-              </a:lnSpc>
-              <a:spcBef>
-                <a:spcPts val="0"/>
-              </a:spcBef>
-              <a:spcAft>
-                <a:spcPts val="0"/>
-              </a:spcAft>
-              <a:buClr>
-                <a:srgbClr val="000000"/>
-              </a:buClr>
-              <a:buSzPts val="1250"/>
-              <a:buFont typeface="Arial"/>
-              <a:buNone/>
-            </a:pPr>
-            <a:r>
-              <a:rPr lang="en" sz="1250" b="0" i="0" u="none" strike="noStrike" cap="none">
-                <a:solidFill>
-                  <a:srgbClr val="596881"/>
-                </a:solidFill>
-                <a:latin typeface="Arial"/>
-                <a:ea typeface="Arial"/>
-                <a:cs typeface="Arial"/>
-                <a:sym typeface="Arial"/>
-              </a:rPr>
-              <a:t>One or more executable function calls—not a free-form final answer.</a:t>
-            </a:r>
-            <a:endParaRPr sz="1400" b="0" i="0" u="none" strike="noStrike" cap="none">
-              <a:solidFill>
-                <a:srgbClr val="000000"/>
-              </a:solidFill>
-              <a:latin typeface="Arial"/>
-              <a:ea typeface="Arial"/>
-              <a:cs typeface="Arial"/>
-              <a:sym typeface="Arial"/>
-            </a:endParaRPr>
-          </a:p>
-        </p:txBody>
-      </p:sp>
-      <p:sp>
-        <p:nvSpPr>
-          <p:cNvPr id="277" name="Google Shape;277;p44"/>
-          <p:cNvSpPr txBox="1"/>
-          <p:nvPr/>
-        </p:nvSpPr>
-        <p:spPr>
-          <a:xfrm>
-            <a:off x="786384" y="3840480"/>
-            <a:ext cx="2359200" cy="167700"/>
-          </a:xfrm>
-          <a:prstGeom prst="rect">
-            <a:avLst/>
-          </a:prstGeom>
-          <a:noFill/>
-          <a:ln>
-            <a:noFill/>
-          </a:ln>
-        </p:spPr>
-        <p:txBody>
-          <a:bodyPr spcFirstLastPara="1" wrap="square" lIns="54850" tIns="18275" rIns="54850" bIns="18275" anchor="ctr" anchorCtr="0">
-            <a:spAutoFit/>
-          </a:bodyPr>
-          <a:lstStyle/>
-          <a:p>
-            <a:pPr marL="0" marR="0" lvl="0" indent="0" algn="l" rtl="0">
-              <a:lnSpc>
-                <a:spcPct val="100000"/>
-              </a:lnSpc>
-              <a:spcBef>
-                <a:spcPts val="0"/>
-              </a:spcBef>
-              <a:spcAft>
-                <a:spcPts val="0"/>
-              </a:spcAft>
-              <a:buClr>
-                <a:srgbClr val="000000"/>
-              </a:buClr>
-              <a:buSzPts val="850"/>
-              <a:buFont typeface="Arial"/>
-              <a:buNone/>
-            </a:pPr>
-            <a:r>
-              <a:rPr lang="en" sz="850" b="1" i="0" u="none" strike="noStrike" cap="none">
-                <a:solidFill>
-                  <a:srgbClr val="596881"/>
-                </a:solidFill>
-                <a:latin typeface="Arial"/>
-                <a:ea typeface="Arial"/>
-                <a:cs typeface="Arial"/>
-                <a:sym typeface="Arial"/>
-              </a:rPr>
-              <a:t>Berkeley Function Calling Leaderboard · V4</a:t>
-            </a:r>
-            <a:endParaRPr sz="1400" b="0" i="0" u="none" strike="noStrike" cap="none">
-              <a:solidFill>
-                <a:srgbClr val="000000"/>
-              </a:solidFill>
-              <a:latin typeface="Arial"/>
-              <a:ea typeface="Arial"/>
-              <a:cs typeface="Arial"/>
-              <a:sym typeface="Arial"/>
-            </a:endParaRPr>
-          </a:p>
-        </p:txBody>
-      </p:sp>
-      <p:sp>
-        <p:nvSpPr>
-          <p:cNvPr id="278" name="Google Shape;278;p44"/>
-          <p:cNvSpPr/>
-          <p:nvPr/>
-        </p:nvSpPr>
-        <p:spPr>
-          <a:xfrm>
-            <a:off x="3639312" y="1024128"/>
-            <a:ext cx="4937700" cy="1417200"/>
-          </a:xfrm>
-          <a:prstGeom prst="roundRect">
-            <a:avLst>
-              <a:gd name="adj" fmla="val 16667"/>
-            </a:avLst>
-          </a:prstGeom>
-          <a:solidFill>
-            <a:srgbClr val="E8F0FE"/>
-          </a:solidFill>
-          <a:ln>
-            <a:noFill/>
-          </a:ln>
-          <a:effectLst>
-            <a:outerShdw blurRad="40000" dist="23000" dir="5400000" rotWithShape="0">
-              <a:srgbClr val="000000">
-                <a:alpha val="34902"/>
-              </a:srgbClr>
-            </a:outerShdw>
-          </a:effectLst>
-        </p:spPr>
-        <p:txBody>
-          <a:bodyPr spcFirstLastPara="1" wrap="square" lIns="54850" tIns="18275" rIns="54850" bIns="18275" anchor="ctr" anchorCtr="0">
-            <a:noAutofit/>
-          </a:bodyPr>
-          <a:lstStyle/>
-          <a:p>
-            <a:pPr marL="0" marR="0" lvl="0" indent="0" algn="l" rtl="0">
-              <a:lnSpc>
-                <a:spcPct val="100000"/>
-              </a:lnSpc>
-              <a:spcBef>
-                <a:spcPts val="0"/>
-              </a:spcBef>
-              <a:spcAft>
-                <a:spcPts val="0"/>
-              </a:spcAft>
-              <a:buClr>
-                <a:srgbClr val="000000"/>
-              </a:buClr>
-              <a:buSzPts val="1400"/>
-              <a:buFont typeface="Arial"/>
-              <a:buNone/>
-            </a:pPr>
-            <a:endParaRPr sz="1400" b="0" i="0" u="none" strike="noStrike" cap="none">
-              <a:solidFill>
-                <a:schemeClr val="lt1"/>
-              </a:solidFill>
-              <a:latin typeface="Arial"/>
-              <a:ea typeface="Arial"/>
-              <a:cs typeface="Arial"/>
-              <a:sym typeface="Arial"/>
-            </a:endParaRPr>
-          </a:p>
-        </p:txBody>
-      </p:sp>
-      <p:sp>
-        <p:nvSpPr>
-          <p:cNvPr id="279" name="Google Shape;279;p44"/>
-          <p:cNvSpPr txBox="1"/>
-          <p:nvPr/>
-        </p:nvSpPr>
-        <p:spPr>
-          <a:xfrm>
-            <a:off x="3858768" y="1225296"/>
-            <a:ext cx="4498800" cy="175500"/>
-          </a:xfrm>
-          <a:prstGeom prst="rect">
-            <a:avLst/>
-          </a:prstGeom>
-          <a:noFill/>
-          <a:ln>
-            <a:noFill/>
-          </a:ln>
-        </p:spPr>
-        <p:txBody>
-          <a:bodyPr spcFirstLastPara="1" wrap="square" lIns="54850" tIns="18275" rIns="54850" bIns="18275" anchor="ctr" anchorCtr="0">
-            <a:spAutoFit/>
-          </a:bodyPr>
-          <a:lstStyle/>
-          <a:p>
-            <a:pPr marL="0" marR="0" lvl="0" indent="0" algn="l" rtl="0">
-              <a:lnSpc>
-                <a:spcPct val="100000"/>
-              </a:lnSpc>
-              <a:spcBef>
-                <a:spcPts val="0"/>
-              </a:spcBef>
-              <a:spcAft>
-                <a:spcPts val="0"/>
-              </a:spcAft>
-              <a:buClr>
-                <a:srgbClr val="000000"/>
-              </a:buClr>
-              <a:buSzPts val="900"/>
-              <a:buFont typeface="Arial"/>
-              <a:buNone/>
-            </a:pPr>
-            <a:r>
-              <a:rPr lang="en" sz="900" b="1" i="0" u="none" strike="noStrike" cap="none">
-                <a:solidFill>
-                  <a:srgbClr val="2870E6"/>
-                </a:solidFill>
-                <a:latin typeface="Arial"/>
-                <a:ea typeface="Arial"/>
-                <a:cs typeface="Arial"/>
-                <a:sym typeface="Arial"/>
-              </a:rPr>
-              <a:t>ILLUSTRATIVE TASK FORMAT</a:t>
-            </a:r>
-            <a:endParaRPr sz="1400" b="0" i="0" u="none" strike="noStrike" cap="none">
-              <a:solidFill>
-                <a:srgbClr val="000000"/>
-              </a:solidFill>
-              <a:latin typeface="Arial"/>
-              <a:ea typeface="Arial"/>
-              <a:cs typeface="Arial"/>
-              <a:sym typeface="Arial"/>
-            </a:endParaRPr>
-          </a:p>
-        </p:txBody>
-      </p:sp>
-      <p:sp>
-        <p:nvSpPr>
-          <p:cNvPr id="280" name="Google Shape;280;p44"/>
-          <p:cNvSpPr txBox="1"/>
-          <p:nvPr/>
-        </p:nvSpPr>
-        <p:spPr>
-          <a:xfrm>
-            <a:off x="3858768" y="1536192"/>
-            <a:ext cx="4498800" cy="498600"/>
-          </a:xfrm>
-          <a:prstGeom prst="rect">
-            <a:avLst/>
-          </a:prstGeom>
-          <a:noFill/>
-          <a:ln>
-            <a:noFill/>
-          </a:ln>
-        </p:spPr>
-        <p:txBody>
-          <a:bodyPr spcFirstLastPara="1" wrap="square" lIns="54850" tIns="18275" rIns="54850" bIns="18275" anchor="ctr" anchorCtr="0">
-            <a:spAutoFit/>
-          </a:bodyPr>
-          <a:lstStyle/>
-          <a:p>
-            <a:pPr marL="0" marR="0" lvl="0" indent="0" algn="ctr" rtl="0">
-              <a:lnSpc>
-                <a:spcPct val="100000"/>
-              </a:lnSpc>
-              <a:spcBef>
-                <a:spcPts val="0"/>
-              </a:spcBef>
-              <a:spcAft>
-                <a:spcPts val="0"/>
-              </a:spcAft>
-              <a:buClr>
-                <a:srgbClr val="000000"/>
-              </a:buClr>
-              <a:buSzPts val="1500"/>
-              <a:buFont typeface="Arial"/>
-              <a:buNone/>
-            </a:pPr>
-            <a:r>
-              <a:rPr lang="en" sz="1500" b="1" i="0" u="none" strike="noStrike" cap="none">
-                <a:solidFill>
-                  <a:srgbClr val="162849"/>
-                </a:solidFill>
-                <a:latin typeface="Arial"/>
-                <a:ea typeface="Arial"/>
-                <a:cs typeface="Arial"/>
-                <a:sym typeface="Arial"/>
-              </a:rPr>
-              <a:t>User request + available function schemas</a:t>
-            </a:r>
-            <a:br>
-              <a:rPr lang="en" sz="1500" b="1" i="0" u="none" strike="noStrike" cap="none">
-                <a:solidFill>
-                  <a:srgbClr val="162849"/>
-                </a:solidFill>
-                <a:latin typeface="Arial"/>
-                <a:ea typeface="Arial"/>
-                <a:cs typeface="Arial"/>
-                <a:sym typeface="Arial"/>
-              </a:rPr>
-            </a:br>
-            <a:r>
-              <a:rPr lang="en" sz="1500" b="1" i="0" u="none" strike="noStrike" cap="none">
-                <a:solidFill>
-                  <a:srgbClr val="162849"/>
-                </a:solidFill>
-                <a:latin typeface="Arial"/>
-                <a:ea typeface="Arial"/>
-                <a:cs typeface="Arial"/>
-                <a:sym typeface="Arial"/>
-              </a:rPr>
-              <a:t>→ choose tool(s) → fill arguments → order calls</a:t>
-            </a:r>
-            <a:endParaRPr sz="1400" b="0" i="0" u="none" strike="noStrike" cap="none">
-              <a:solidFill>
-                <a:srgbClr val="000000"/>
-              </a:solidFill>
-              <a:latin typeface="Arial"/>
-              <a:ea typeface="Arial"/>
-              <a:cs typeface="Arial"/>
-              <a:sym typeface="Arial"/>
-            </a:endParaRPr>
-          </a:p>
-        </p:txBody>
-      </p:sp>
-      <p:sp>
-        <p:nvSpPr>
-          <p:cNvPr id="281" name="Google Shape;281;p44"/>
-          <p:cNvSpPr/>
-          <p:nvPr/>
-        </p:nvSpPr>
-        <p:spPr>
-          <a:xfrm>
-            <a:off x="3639312" y="2670048"/>
-            <a:ext cx="2377500" cy="658500"/>
-          </a:xfrm>
-          <a:prstGeom prst="roundRect">
-            <a:avLst>
-              <a:gd name="adj" fmla="val 16667"/>
-            </a:avLst>
-          </a:prstGeom>
-          <a:solidFill>
-            <a:srgbClr val="FFFFFF"/>
-          </a:solidFill>
-          <a:ln>
-            <a:noFill/>
-          </a:ln>
-          <a:effectLst>
-            <a:outerShdw blurRad="40000" dist="23000" dir="5400000" rotWithShape="0">
-              <a:srgbClr val="000000">
-                <a:alpha val="34902"/>
-              </a:srgbClr>
-            </a:outerShdw>
-          </a:effectLst>
-        </p:spPr>
-        <p:txBody>
-          <a:bodyPr spcFirstLastPara="1" wrap="square" lIns="128000" tIns="18275" rIns="128000" bIns="18275" anchor="ctr" anchorCtr="0">
-            <a:noAutofit/>
-          </a:bodyPr>
-          <a:lstStyle/>
-          <a:p>
-            <a:pPr marL="0" marR="0" lvl="0" indent="0" algn="l" rtl="0">
-              <a:lnSpc>
-                <a:spcPct val="100000"/>
-              </a:lnSpc>
-              <a:spcBef>
-                <a:spcPts val="0"/>
-              </a:spcBef>
-              <a:spcAft>
-                <a:spcPts val="0"/>
-              </a:spcAft>
-              <a:buClr>
-                <a:srgbClr val="000000"/>
-              </a:buClr>
-              <a:buSzPts val="1018"/>
-              <a:buFont typeface="Arial"/>
-              <a:buNone/>
-            </a:pPr>
-            <a:r>
-              <a:rPr lang="en" sz="1019" b="1" i="0" u="none" strike="noStrike" cap="none">
-                <a:solidFill>
-                  <a:srgbClr val="162849"/>
-                </a:solidFill>
-                <a:latin typeface="Arial"/>
-                <a:ea typeface="Arial"/>
-                <a:cs typeface="Arial"/>
-                <a:sym typeface="Arial"/>
-              </a:rPr>
-              <a:t>Web Search</a:t>
-            </a:r>
-            <a:br>
-              <a:rPr lang="en" sz="1019" b="1" i="0" u="none" strike="noStrike" cap="none">
-                <a:solidFill>
-                  <a:srgbClr val="162849"/>
-                </a:solidFill>
-                <a:latin typeface="Arial"/>
-                <a:ea typeface="Arial"/>
-                <a:cs typeface="Arial"/>
-                <a:sym typeface="Arial"/>
-              </a:rPr>
-            </a:br>
-            <a:r>
-              <a:rPr lang="en" sz="1019" b="1" i="0" u="none" strike="noStrike" cap="none">
-                <a:solidFill>
-                  <a:srgbClr val="162849"/>
-                </a:solidFill>
-                <a:latin typeface="Arial"/>
-                <a:ea typeface="Arial"/>
-                <a:cs typeface="Arial"/>
-                <a:sym typeface="Arial"/>
-              </a:rPr>
-              <a:t>Retrieve information through search tools</a:t>
-            </a:r>
-            <a:endParaRPr sz="1400" b="0" i="0" u="none" strike="noStrike" cap="none">
-              <a:solidFill>
-                <a:srgbClr val="000000"/>
-              </a:solidFill>
-              <a:latin typeface="Arial"/>
-              <a:ea typeface="Arial"/>
-              <a:cs typeface="Arial"/>
-              <a:sym typeface="Arial"/>
-            </a:endParaRPr>
-          </a:p>
-        </p:txBody>
-      </p:sp>
-      <p:sp>
-        <p:nvSpPr>
-          <p:cNvPr id="282" name="Google Shape;282;p44"/>
-          <p:cNvSpPr/>
-          <p:nvPr/>
-        </p:nvSpPr>
-        <p:spPr>
-          <a:xfrm>
-            <a:off x="6181344" y="2670048"/>
-            <a:ext cx="2377500" cy="658500"/>
-          </a:xfrm>
-          <a:prstGeom prst="roundRect">
-            <a:avLst>
-              <a:gd name="adj" fmla="val 16667"/>
-            </a:avLst>
-          </a:prstGeom>
-          <a:solidFill>
-            <a:srgbClr val="FFFFFF"/>
-          </a:solidFill>
-          <a:ln>
-            <a:noFill/>
-          </a:ln>
-          <a:effectLst>
-            <a:outerShdw blurRad="40000" dist="23000" dir="5400000" rotWithShape="0">
-              <a:srgbClr val="000000">
-                <a:alpha val="34902"/>
-              </a:srgbClr>
-            </a:outerShdw>
-          </a:effectLst>
-        </p:spPr>
-        <p:txBody>
-          <a:bodyPr spcFirstLastPara="1" wrap="square" lIns="128000" tIns="18275" rIns="128000" bIns="18275" anchor="ctr" anchorCtr="0">
-            <a:noAutofit/>
-          </a:bodyPr>
-          <a:lstStyle/>
-          <a:p>
-            <a:pPr marL="0" marR="0" lvl="0" indent="0" algn="l" rtl="0">
-              <a:lnSpc>
-                <a:spcPct val="100000"/>
-              </a:lnSpc>
-              <a:spcBef>
-                <a:spcPts val="0"/>
-              </a:spcBef>
-              <a:spcAft>
-                <a:spcPts val="0"/>
-              </a:spcAft>
-              <a:buClr>
-                <a:srgbClr val="000000"/>
-              </a:buClr>
-              <a:buSzPts val="1018"/>
-              <a:buFont typeface="Arial"/>
-              <a:buNone/>
-            </a:pPr>
-            <a:r>
-              <a:rPr lang="en" sz="1019" b="1" i="0" u="none" strike="noStrike" cap="none">
-                <a:solidFill>
-                  <a:srgbClr val="162849"/>
-                </a:solidFill>
-                <a:latin typeface="Arial"/>
-                <a:ea typeface="Arial"/>
-                <a:cs typeface="Arial"/>
-                <a:sym typeface="Arial"/>
-              </a:rPr>
-              <a:t>Memory</a:t>
-            </a:r>
-            <a:br>
-              <a:rPr lang="en" sz="1019" b="1" i="0" u="none" strike="noStrike" cap="none">
-                <a:solidFill>
-                  <a:srgbClr val="162849"/>
-                </a:solidFill>
-                <a:latin typeface="Arial"/>
-                <a:ea typeface="Arial"/>
-                <a:cs typeface="Arial"/>
-                <a:sym typeface="Arial"/>
-              </a:rPr>
-            </a:br>
-            <a:r>
-              <a:rPr lang="en" sz="1019" b="1" i="0" u="none" strike="noStrike" cap="none">
-                <a:solidFill>
-                  <a:srgbClr val="162849"/>
-                </a:solidFill>
-                <a:latin typeface="Arial"/>
-                <a:ea typeface="Arial"/>
-                <a:cs typeface="Arial"/>
-                <a:sym typeface="Arial"/>
-              </a:rPr>
-              <a:t>Store and retrieve user-specific information</a:t>
-            </a:r>
-            <a:endParaRPr sz="1400" b="0" i="0" u="none" strike="noStrike" cap="none">
-              <a:solidFill>
-                <a:srgbClr val="000000"/>
-              </a:solidFill>
-              <a:latin typeface="Arial"/>
-              <a:ea typeface="Arial"/>
-              <a:cs typeface="Arial"/>
-              <a:sym typeface="Arial"/>
-            </a:endParaRPr>
-          </a:p>
-        </p:txBody>
-      </p:sp>
-      <p:sp>
-        <p:nvSpPr>
-          <p:cNvPr id="283" name="Google Shape;283;p44"/>
-          <p:cNvSpPr/>
-          <p:nvPr/>
-        </p:nvSpPr>
-        <p:spPr>
-          <a:xfrm>
-            <a:off x="3639312" y="3493008"/>
-            <a:ext cx="2377500" cy="658500"/>
-          </a:xfrm>
-          <a:prstGeom prst="roundRect">
-            <a:avLst>
-              <a:gd name="adj" fmla="val 16667"/>
-            </a:avLst>
-          </a:prstGeom>
-          <a:solidFill>
-            <a:srgbClr val="FFFFFF"/>
-          </a:solidFill>
-          <a:ln>
-            <a:noFill/>
-          </a:ln>
-          <a:effectLst>
-            <a:outerShdw blurRad="40000" dist="23000" dir="5400000" rotWithShape="0">
-              <a:srgbClr val="000000">
-                <a:alpha val="34902"/>
-              </a:srgbClr>
-            </a:outerShdw>
-          </a:effectLst>
-        </p:spPr>
-        <p:txBody>
-          <a:bodyPr spcFirstLastPara="1" wrap="square" lIns="128000" tIns="18275" rIns="128000" bIns="18275" anchor="ctr" anchorCtr="0">
-            <a:noAutofit/>
-          </a:bodyPr>
-          <a:lstStyle/>
-          <a:p>
-            <a:pPr marL="0" marR="0" lvl="0" indent="0" algn="l" rtl="0">
-              <a:lnSpc>
-                <a:spcPct val="100000"/>
-              </a:lnSpc>
-              <a:spcBef>
-                <a:spcPts val="0"/>
-              </a:spcBef>
-              <a:spcAft>
-                <a:spcPts val="0"/>
-              </a:spcAft>
-              <a:buClr>
-                <a:srgbClr val="000000"/>
-              </a:buClr>
-              <a:buSzPts val="1018"/>
-              <a:buFont typeface="Arial"/>
-              <a:buNone/>
-            </a:pPr>
-            <a:r>
-              <a:rPr lang="en" sz="1019" b="1" i="0" u="none" strike="noStrike" cap="none">
-                <a:solidFill>
-                  <a:srgbClr val="162849"/>
-                </a:solidFill>
-                <a:latin typeface="Arial"/>
-                <a:ea typeface="Arial"/>
-                <a:cs typeface="Arial"/>
-                <a:sym typeface="Arial"/>
-              </a:rPr>
-              <a:t>Single</a:t>
-            </a:r>
-            <a:br>
-              <a:rPr lang="en" sz="1019" b="1" i="0" u="none" strike="noStrike" cap="none">
-                <a:solidFill>
-                  <a:srgbClr val="162849"/>
-                </a:solidFill>
-                <a:latin typeface="Arial"/>
-                <a:ea typeface="Arial"/>
-                <a:cs typeface="Arial"/>
-                <a:sym typeface="Arial"/>
-              </a:rPr>
-            </a:br>
-            <a:r>
-              <a:rPr lang="en" sz="1019" b="1" i="0" u="none" strike="noStrike" cap="none">
-                <a:solidFill>
-                  <a:srgbClr val="162849"/>
-                </a:solidFill>
-                <a:latin typeface="Arial"/>
-                <a:ea typeface="Arial"/>
-                <a:cs typeface="Arial"/>
-                <a:sym typeface="Arial"/>
-              </a:rPr>
-              <a:t>Execute one live or non-live function call</a:t>
-            </a:r>
-            <a:endParaRPr sz="1400" b="0" i="0" u="none" strike="noStrike" cap="none">
-              <a:solidFill>
-                <a:srgbClr val="000000"/>
-              </a:solidFill>
-              <a:latin typeface="Arial"/>
-              <a:ea typeface="Arial"/>
-              <a:cs typeface="Arial"/>
-              <a:sym typeface="Arial"/>
-            </a:endParaRPr>
-          </a:p>
-        </p:txBody>
-      </p:sp>
-      <p:sp>
-        <p:nvSpPr>
-          <p:cNvPr id="284" name="Google Shape;284;p44"/>
-          <p:cNvSpPr/>
-          <p:nvPr/>
-        </p:nvSpPr>
-        <p:spPr>
-          <a:xfrm>
-            <a:off x="6181344" y="3493008"/>
-            <a:ext cx="2377500" cy="658500"/>
-          </a:xfrm>
-          <a:prstGeom prst="roundRect">
-            <a:avLst>
-              <a:gd name="adj" fmla="val 16667"/>
-            </a:avLst>
-          </a:prstGeom>
-          <a:solidFill>
-            <a:srgbClr val="FFFFFF"/>
-          </a:solidFill>
-          <a:ln>
-            <a:noFill/>
-          </a:ln>
-          <a:effectLst>
-            <a:outerShdw blurRad="40000" dist="23000" dir="5400000" rotWithShape="0">
-              <a:srgbClr val="000000">
-                <a:alpha val="34902"/>
-              </a:srgbClr>
-            </a:outerShdw>
-          </a:effectLst>
-        </p:spPr>
-        <p:txBody>
-          <a:bodyPr spcFirstLastPara="1" wrap="square" lIns="128000" tIns="18275" rIns="128000" bIns="18275" anchor="ctr" anchorCtr="0">
-            <a:noAutofit/>
-          </a:bodyPr>
-          <a:lstStyle/>
-          <a:p>
-            <a:pPr marL="0" marR="0" lvl="0" indent="0" algn="l" rtl="0">
-              <a:lnSpc>
-                <a:spcPct val="100000"/>
-              </a:lnSpc>
-              <a:spcBef>
-                <a:spcPts val="0"/>
-              </a:spcBef>
-              <a:spcAft>
-                <a:spcPts val="0"/>
-              </a:spcAft>
-              <a:buClr>
-                <a:srgbClr val="000000"/>
-              </a:buClr>
-              <a:buSzPts val="1018"/>
-              <a:buFont typeface="Arial"/>
-              <a:buNone/>
-            </a:pPr>
-            <a:r>
-              <a:rPr lang="en" sz="1019" b="1" i="0" u="none" strike="noStrike" cap="none">
-                <a:solidFill>
-                  <a:srgbClr val="162849"/>
-                </a:solidFill>
-                <a:latin typeface="Arial"/>
-                <a:ea typeface="Arial"/>
-                <a:cs typeface="Arial"/>
-                <a:sym typeface="Arial"/>
-              </a:rPr>
-              <a:t>Multi</a:t>
-            </a:r>
-            <a:br>
-              <a:rPr lang="en" sz="1019" b="1" i="0" u="none" strike="noStrike" cap="none">
-                <a:solidFill>
-                  <a:srgbClr val="162849"/>
-                </a:solidFill>
-                <a:latin typeface="Arial"/>
-                <a:ea typeface="Arial"/>
-                <a:cs typeface="Arial"/>
-                <a:sym typeface="Arial"/>
-              </a:rPr>
-            </a:br>
-            <a:r>
-              <a:rPr lang="en" sz="1019" b="1" i="0" u="none" strike="noStrike" cap="none">
-                <a:solidFill>
-                  <a:srgbClr val="162849"/>
-                </a:solidFill>
-                <a:latin typeface="Arial"/>
-                <a:ea typeface="Arial"/>
-                <a:cs typeface="Arial"/>
-                <a:sym typeface="Arial"/>
-              </a:rPr>
-              <a:t>Coordinate multiple calls for one request</a:t>
-            </a:r>
-            <a:endParaRPr sz="1400" b="0" i="0" u="none" strike="noStrike" cap="none">
-              <a:solidFill>
-                <a:srgbClr val="000000"/>
-              </a:solidFill>
-              <a:latin typeface="Arial"/>
-              <a:ea typeface="Arial"/>
-              <a:cs typeface="Arial"/>
-              <a:sym typeface="Arial"/>
-            </a:endParaRPr>
-          </a:p>
-        </p:txBody>
-      </p:sp>
-      <p:sp>
-        <p:nvSpPr>
-          <p:cNvPr id="285" name="Google Shape;285;p44"/>
-          <p:cNvSpPr txBox="1"/>
-          <p:nvPr/>
-        </p:nvSpPr>
-        <p:spPr>
-          <a:xfrm>
-            <a:off x="3639312" y="4370832"/>
-            <a:ext cx="4937700" cy="375600"/>
-          </a:xfrm>
-          <a:prstGeom prst="rect">
-            <a:avLst/>
-          </a:prstGeom>
-          <a:noFill/>
-          <a:ln>
-            <a:noFill/>
-          </a:ln>
-        </p:spPr>
-        <p:txBody>
-          <a:bodyPr spcFirstLastPara="1" wrap="square" lIns="54850" tIns="18275" rIns="54850" bIns="18275" anchor="ctr" anchorCtr="0">
-            <a:spAutoFit/>
-          </a:bodyPr>
-          <a:lstStyle/>
-          <a:p>
-            <a:pPr marL="0" marR="0" lvl="0" indent="0" algn="ctr" rtl="0">
-              <a:lnSpc>
-                <a:spcPct val="100000"/>
-              </a:lnSpc>
-              <a:spcBef>
-                <a:spcPts val="0"/>
-              </a:spcBef>
-              <a:spcAft>
-                <a:spcPts val="0"/>
-              </a:spcAft>
-              <a:buClr>
-                <a:srgbClr val="000000"/>
-              </a:buClr>
-              <a:buSzPts val="1100"/>
-              <a:buFont typeface="Arial"/>
-              <a:buNone/>
-            </a:pPr>
-            <a:r>
-              <a:rPr lang="en" sz="1100" b="1" i="0" u="none" strike="noStrike" cap="none">
-                <a:solidFill>
-                  <a:srgbClr val="2870E6"/>
-                </a:solidFill>
-                <a:latin typeface="Arial"/>
-                <a:ea typeface="Arial"/>
-                <a:cs typeface="Arial"/>
-                <a:sym typeface="Arial"/>
-              </a:rPr>
-              <a:t>Why SCRIBE: reliable process rewards must recognize complete intermediate tool-use behavior.</a:t>
-            </a:r>
-            <a:endParaRPr sz="1400" b="0" i="0" u="none" strike="noStrike" cap="none">
-              <a:solidFill>
-                <a:srgbClr val="000000"/>
-              </a:solidFill>
-              <a:latin typeface="Arial"/>
-              <a:ea typeface="Arial"/>
-              <a:cs typeface="Arial"/>
-              <a:sym typeface="Arial"/>
-            </a:endParaRPr>
-          </a:p>
-        </p:txBody>
-      </p:sp>
-      <p:sp>
-        <p:nvSpPr>
-          <p:cNvPr id="286" name="Google Shape;286;p44"/>
-          <p:cNvSpPr txBox="1"/>
-          <p:nvPr/>
-        </p:nvSpPr>
-        <p:spPr>
-          <a:xfrm>
-            <a:off x="566928" y="4882896"/>
-            <a:ext cx="8010000" cy="137100"/>
-          </a:xfrm>
-          <a:prstGeom prst="rect">
-            <a:avLst/>
-          </a:prstGeom>
-          <a:noFill/>
-          <a:ln>
-            <a:noFill/>
-          </a:ln>
-        </p:spPr>
-        <p:txBody>
-          <a:bodyPr spcFirstLastPara="1" wrap="square" lIns="54850" tIns="18275" rIns="54850" bIns="18275" anchor="ctr" anchorCtr="0">
-            <a:spAutoFit/>
-          </a:bodyPr>
-          <a:lstStyle/>
-          <a:p>
-            <a:pPr marL="0" marR="0" lvl="0" indent="0" algn="ctr" rtl="0">
-              <a:lnSpc>
-                <a:spcPct val="100000"/>
-              </a:lnSpc>
-              <a:spcBef>
-                <a:spcPts val="0"/>
-              </a:spcBef>
-              <a:spcAft>
-                <a:spcPts val="0"/>
-              </a:spcAft>
-              <a:buClr>
-                <a:srgbClr val="000000"/>
-              </a:buClr>
-              <a:buSzPts val="650"/>
-              <a:buFont typeface="Arial"/>
-              <a:buNone/>
-            </a:pPr>
-            <a:r>
-              <a:rPr lang="en" sz="650" b="0" i="0" u="none" strike="noStrike" cap="none">
-                <a:solidFill>
-                  <a:srgbClr val="596881"/>
-                </a:solidFill>
-                <a:latin typeface="Arial"/>
-                <a:ea typeface="Arial"/>
-                <a:cs typeface="Arial"/>
-                <a:sym typeface="Arial"/>
-              </a:rPr>
-              <a:t>Patil et al. Berkeley Function Calling Leaderboard (BFCL V4).</a:t>
-            </a:r>
-            <a:endParaRPr sz="1400" b="0" i="0" u="none" strike="noStrike" cap="none">
-              <a:solidFill>
-                <a:srgbClr val="000000"/>
-              </a:solidFill>
-              <a:latin typeface="Arial"/>
-              <a:ea typeface="Arial"/>
-              <a:cs typeface="Arial"/>
-              <a:sym typeface="Arial"/>
-            </a:endParaRPr>
           </a:p>
         </p:txBody>
       </p:sp>
@@ -23742,6 +22568,728 @@
               <a:cs typeface="Arial"/>
               <a:sym typeface="Arial"/>
             </a:endParaRPr>
+          </a:p>
+        </p:txBody>
+      </p:sp>
+      <p:sp>
+        <p:nvSpPr>
+          <p:cNvPr id="288" name="TextBox 287"/>
+          <p:cNvSpPr txBox="1"/>
+          <p:nvPr/>
+        </p:nvSpPr>
+        <p:spPr>
+          <a:xfrm>
+            <a:off x="566928" y="914400"/>
+            <a:ext cx="8010144" cy="329184"/>
+          </a:xfrm>
+          <a:prstGeom prst="rect">
+            <a:avLst/>
+          </a:prstGeom>
+          <a:noFill/>
+        </p:spPr>
+        <p:txBody>
+          <a:bodyPr wrap="square" lIns="0" rIns="0" tIns="0" bIns="0">
+            <a:spAutoFit/>
+          </a:bodyPr>
+          <a:lstStyle/>
+          <a:p>
+            <a:pPr algn="l">
+              <a:spcAft>
+                <a:spcPts val="200"/>
+              </a:spcAft>
+              <a:defRPr sz="1600" b="0">
+                <a:solidFill>
+                  <a:srgbClr val="193354"/>
+                </a:solidFill>
+                <a:latin typeface="Arial"/>
+              </a:defRPr>
+            </a:pPr>
+            <a:r>
+              <a:t>Example: answering a weather question requires two dependent tool calls.</a:t>
+            </a:r>
+          </a:p>
+        </p:txBody>
+      </p:sp>
+      <p:sp>
+        <p:nvSpPr>
+          <p:cNvPr id="289" name="Rounded Rectangle 288"/>
+          <p:cNvSpPr/>
+          <p:nvPr/>
+        </p:nvSpPr>
+        <p:spPr>
+          <a:xfrm>
+            <a:off x="566928" y="1371600"/>
+            <a:ext cx="8010144" cy="594360"/>
+          </a:xfrm>
+          <a:prstGeom prst="roundRect">
+            <a:avLst>
+              <a:gd name="adj" fmla="val 6000"/>
+            </a:avLst>
+          </a:prstGeom>
+          <a:solidFill>
+            <a:srgbClr val="E6F4EF"/>
+          </a:solidFill>
+          <a:ln>
+            <a:noFill/>
+          </a:ln>
+        </p:spPr>
+        <p:style>
+          <a:lnRef idx="1">
+            <a:schemeClr val="accent1"/>
+          </a:lnRef>
+          <a:fillRef idx="3">
+            <a:schemeClr val="accent1"/>
+          </a:fillRef>
+          <a:effectRef idx="2">
+            <a:schemeClr val="accent1"/>
+          </a:effectRef>
+          <a:fontRef idx="minor">
+            <a:schemeClr val="lt1"/>
+          </a:fontRef>
+        </p:style>
+        <p:txBody>
+          <a:bodyPr rtlCol="0" anchor="ctr"/>
+          <a:lstStyle/>
+          <a:p>
+            <a:pPr algn="ctr"/>
+          </a:p>
+        </p:txBody>
+      </p:sp>
+      <p:sp>
+        <p:nvSpPr>
+          <p:cNvPr id="290" name="TextBox 289"/>
+          <p:cNvSpPr txBox="1"/>
+          <p:nvPr/>
+        </p:nvSpPr>
+        <p:spPr>
+          <a:xfrm>
+            <a:off x="749808" y="1536192"/>
+            <a:ext cx="1060704" cy="246888"/>
+          </a:xfrm>
+          <a:prstGeom prst="rect">
+            <a:avLst/>
+          </a:prstGeom>
+          <a:noFill/>
+        </p:spPr>
+        <p:txBody>
+          <a:bodyPr wrap="square" lIns="0" rIns="0" tIns="0" bIns="0">
+            <a:spAutoFit/>
+          </a:bodyPr>
+          <a:lstStyle/>
+          <a:p>
+            <a:pPr algn="l">
+              <a:spcAft>
+                <a:spcPts val="200"/>
+              </a:spcAft>
+              <a:defRPr sz="1200" b="1">
+                <a:solidFill>
+                  <a:srgbClr val="087F8C"/>
+                </a:solidFill>
+                <a:latin typeface="Arial"/>
+              </a:defRPr>
+            </a:pPr>
+            <a:r>
+              <a:t>USER ASKS</a:t>
+            </a:r>
+          </a:p>
+        </p:txBody>
+      </p:sp>
+      <p:sp>
+        <p:nvSpPr>
+          <p:cNvPr id="291" name="TextBox 290"/>
+          <p:cNvSpPr txBox="1"/>
+          <p:nvPr/>
+        </p:nvSpPr>
+        <p:spPr>
+          <a:xfrm>
+            <a:off x="1847088" y="1508760"/>
+            <a:ext cx="6355080" cy="320040"/>
+          </a:xfrm>
+          <a:prstGeom prst="rect">
+            <a:avLst/>
+          </a:prstGeom>
+          <a:noFill/>
+        </p:spPr>
+        <p:txBody>
+          <a:bodyPr wrap="square" lIns="0" rIns="0" tIns="0" bIns="0">
+            <a:spAutoFit/>
+          </a:bodyPr>
+          <a:lstStyle/>
+          <a:p>
+            <a:pPr algn="l">
+              <a:spcAft>
+                <a:spcPts val="200"/>
+              </a:spcAft>
+              <a:defRPr sz="1900" b="1">
+                <a:solidFill>
+                  <a:srgbClr val="193354"/>
+                </a:solidFill>
+                <a:latin typeface="Arial"/>
+              </a:defRPr>
+            </a:pPr>
+            <a:r>
+              <a:t>“What is the weather in Berkeley?”</a:t>
+            </a:r>
+          </a:p>
+        </p:txBody>
+      </p:sp>
+      <p:sp>
+        <p:nvSpPr>
+          <p:cNvPr id="292" name="Rounded Rectangle 291"/>
+          <p:cNvSpPr/>
+          <p:nvPr/>
+        </p:nvSpPr>
+        <p:spPr>
+          <a:xfrm>
+            <a:off x="566928" y="2221992"/>
+            <a:ext cx="3730752" cy="1481328"/>
+          </a:xfrm>
+          <a:prstGeom prst="roundRect">
+            <a:avLst>
+              <a:gd name="adj" fmla="val 6000"/>
+            </a:avLst>
+          </a:prstGeom>
+          <a:solidFill>
+            <a:srgbClr val="EFF5FB"/>
+          </a:solidFill>
+          <a:ln>
+            <a:noFill/>
+          </a:ln>
+        </p:spPr>
+        <p:style>
+          <a:lnRef idx="1">
+            <a:schemeClr val="accent1"/>
+          </a:lnRef>
+          <a:fillRef idx="3">
+            <a:schemeClr val="accent1"/>
+          </a:fillRef>
+          <a:effectRef idx="2">
+            <a:schemeClr val="accent1"/>
+          </a:effectRef>
+          <a:fontRef idx="minor">
+            <a:schemeClr val="lt1"/>
+          </a:fontRef>
+        </p:style>
+        <p:txBody>
+          <a:bodyPr rtlCol="0" anchor="ctr"/>
+          <a:lstStyle/>
+          <a:p>
+            <a:pPr algn="ctr"/>
+          </a:p>
+        </p:txBody>
+      </p:sp>
+      <p:sp>
+        <p:nvSpPr>
+          <p:cNvPr id="293" name="TextBox 292"/>
+          <p:cNvSpPr txBox="1"/>
+          <p:nvPr/>
+        </p:nvSpPr>
+        <p:spPr>
+          <a:xfrm>
+            <a:off x="749808" y="2368296"/>
+            <a:ext cx="3364992" cy="274320"/>
+          </a:xfrm>
+          <a:prstGeom prst="rect">
+            <a:avLst/>
+          </a:prstGeom>
+          <a:noFill/>
+        </p:spPr>
+        <p:txBody>
+          <a:bodyPr wrap="square" lIns="0" rIns="0" tIns="0" bIns="0">
+            <a:spAutoFit/>
+          </a:bodyPr>
+          <a:lstStyle/>
+          <a:p>
+            <a:pPr algn="l">
+              <a:spcAft>
+                <a:spcPts val="200"/>
+              </a:spcAft>
+              <a:defRPr sz="1600" b="1">
+                <a:solidFill>
+                  <a:srgbClr val="193354"/>
+                </a:solidFill>
+                <a:latin typeface="Arial"/>
+              </a:defRPr>
+            </a:pPr>
+            <a:r>
+              <a:t>1  Look Up the City</a:t>
+            </a:r>
+          </a:p>
+        </p:txBody>
+      </p:sp>
+      <p:sp>
+        <p:nvSpPr>
+          <p:cNvPr id="294" name="TextBox 293"/>
+          <p:cNvSpPr txBox="1"/>
+          <p:nvPr/>
+        </p:nvSpPr>
+        <p:spPr>
+          <a:xfrm>
+            <a:off x="749808" y="2770632"/>
+            <a:ext cx="3364992" cy="640080"/>
+          </a:xfrm>
+          <a:prstGeom prst="rect">
+            <a:avLst/>
+          </a:prstGeom>
+          <a:noFill/>
+        </p:spPr>
+        <p:txBody>
+          <a:bodyPr wrap="square" lIns="0" rIns="0" tIns="0" bIns="0">
+            <a:spAutoFit/>
+          </a:bodyPr>
+          <a:lstStyle/>
+          <a:p>
+            <a:pPr algn="l">
+              <a:spcAft>
+                <a:spcPts val="200"/>
+              </a:spcAft>
+              <a:defRPr sz="1300" b="0">
+                <a:solidFill>
+                  <a:srgbClr val="193354"/>
+                </a:solidFill>
+                <a:latin typeface="Courier New"/>
+              </a:defRPr>
+            </a:pPr>
+            <a:r>
+              <a:t>get_zipcode_by_city(</a:t>
+            </a:r>
+          </a:p>
+          <a:p>
+            <a:pPr algn="l">
+              <a:spcAft>
+                <a:spcPts val="200"/>
+              </a:spcAft>
+              <a:defRPr sz="1300" b="0">
+                <a:solidFill>
+                  <a:srgbClr val="193354"/>
+                </a:solidFill>
+                <a:latin typeface="Courier New"/>
+              </a:defRPr>
+            </a:pPr>
+            <a:r>
+              <a:t>    "Berkeley"</a:t>
+            </a:r>
+          </a:p>
+          <a:p>
+            <a:pPr algn="l">
+              <a:spcAft>
+                <a:spcPts val="200"/>
+              </a:spcAft>
+              <a:defRPr sz="1300" b="0">
+                <a:solidFill>
+                  <a:srgbClr val="193354"/>
+                </a:solidFill>
+                <a:latin typeface="Courier New"/>
+              </a:defRPr>
+            </a:pPr>
+            <a:r>
+              <a:t>)</a:t>
+            </a:r>
+          </a:p>
+        </p:txBody>
+      </p:sp>
+      <p:sp>
+        <p:nvSpPr>
+          <p:cNvPr id="295" name="TextBox 294"/>
+          <p:cNvSpPr txBox="1"/>
+          <p:nvPr/>
+        </p:nvSpPr>
+        <p:spPr>
+          <a:xfrm>
+            <a:off x="749808" y="3410712"/>
+            <a:ext cx="3364992" cy="228600"/>
+          </a:xfrm>
+          <a:prstGeom prst="rect">
+            <a:avLst/>
+          </a:prstGeom>
+          <a:noFill/>
+        </p:spPr>
+        <p:txBody>
+          <a:bodyPr wrap="square" lIns="0" rIns="0" tIns="0" bIns="0">
+            <a:spAutoFit/>
+          </a:bodyPr>
+          <a:lstStyle/>
+          <a:p>
+            <a:pPr algn="l">
+              <a:spcAft>
+                <a:spcPts val="200"/>
+              </a:spcAft>
+              <a:defRPr sz="1200" b="1">
+                <a:solidFill>
+                  <a:srgbClr val="087F8C"/>
+                </a:solidFill>
+                <a:latin typeface="Arial"/>
+              </a:defRPr>
+            </a:pPr>
+            <a:r>
+              <a:t>Tool returns: 94710</a:t>
+            </a:r>
+          </a:p>
+        </p:txBody>
+      </p:sp>
+      <p:sp>
+        <p:nvSpPr>
+          <p:cNvPr id="296" name="Rounded Rectangle 295"/>
+          <p:cNvSpPr/>
+          <p:nvPr/>
+        </p:nvSpPr>
+        <p:spPr>
+          <a:xfrm>
+            <a:off x="4846320" y="2221992"/>
+            <a:ext cx="3730752" cy="1481328"/>
+          </a:xfrm>
+          <a:prstGeom prst="roundRect">
+            <a:avLst>
+              <a:gd name="adj" fmla="val 6000"/>
+            </a:avLst>
+          </a:prstGeom>
+          <a:solidFill>
+            <a:srgbClr val="EFF5FB"/>
+          </a:solidFill>
+          <a:ln>
+            <a:noFill/>
+          </a:ln>
+        </p:spPr>
+        <p:style>
+          <a:lnRef idx="1">
+            <a:schemeClr val="accent1"/>
+          </a:lnRef>
+          <a:fillRef idx="3">
+            <a:schemeClr val="accent1"/>
+          </a:fillRef>
+          <a:effectRef idx="2">
+            <a:schemeClr val="accent1"/>
+          </a:effectRef>
+          <a:fontRef idx="minor">
+            <a:schemeClr val="lt1"/>
+          </a:fontRef>
+        </p:style>
+        <p:txBody>
+          <a:bodyPr rtlCol="0" anchor="ctr"/>
+          <a:lstStyle/>
+          <a:p>
+            <a:pPr algn="ctr"/>
+          </a:p>
+        </p:txBody>
+      </p:sp>
+      <p:sp>
+        <p:nvSpPr>
+          <p:cNvPr id="297" name="TextBox 296"/>
+          <p:cNvSpPr txBox="1"/>
+          <p:nvPr/>
+        </p:nvSpPr>
+        <p:spPr>
+          <a:xfrm>
+            <a:off x="5029200" y="2368296"/>
+            <a:ext cx="3364992" cy="274320"/>
+          </a:xfrm>
+          <a:prstGeom prst="rect">
+            <a:avLst/>
+          </a:prstGeom>
+          <a:noFill/>
+        </p:spPr>
+        <p:txBody>
+          <a:bodyPr wrap="square" lIns="0" rIns="0" tIns="0" bIns="0">
+            <a:spAutoFit/>
+          </a:bodyPr>
+          <a:lstStyle/>
+          <a:p>
+            <a:pPr algn="l">
+              <a:spcAft>
+                <a:spcPts val="200"/>
+              </a:spcAft>
+              <a:defRPr sz="1600" b="1">
+                <a:solidFill>
+                  <a:srgbClr val="193354"/>
+                </a:solidFill>
+                <a:latin typeface="Arial"/>
+              </a:defRPr>
+            </a:pPr>
+            <a:r>
+              <a:t>2  Use the Returned ZIP Code</a:t>
+            </a:r>
+          </a:p>
+        </p:txBody>
+      </p:sp>
+      <p:sp>
+        <p:nvSpPr>
+          <p:cNvPr id="298" name="TextBox 297"/>
+          <p:cNvSpPr txBox="1"/>
+          <p:nvPr/>
+        </p:nvSpPr>
+        <p:spPr>
+          <a:xfrm>
+            <a:off x="5029200" y="2770632"/>
+            <a:ext cx="3364992" cy="640080"/>
+          </a:xfrm>
+          <a:prstGeom prst="rect">
+            <a:avLst/>
+          </a:prstGeom>
+          <a:noFill/>
+        </p:spPr>
+        <p:txBody>
+          <a:bodyPr wrap="square" lIns="0" rIns="0" tIns="0" bIns="0">
+            <a:spAutoFit/>
+          </a:bodyPr>
+          <a:lstStyle/>
+          <a:p>
+            <a:pPr algn="l">
+              <a:spcAft>
+                <a:spcPts val="200"/>
+              </a:spcAft>
+              <a:defRPr sz="1300" b="0">
+                <a:solidFill>
+                  <a:srgbClr val="193354"/>
+                </a:solidFill>
+                <a:latin typeface="Courier New"/>
+              </a:defRPr>
+            </a:pPr>
+            <a:r>
+              <a:t>get_weather_by_zipcode(</a:t>
+            </a:r>
+          </a:p>
+          <a:p>
+            <a:pPr algn="l">
+              <a:spcAft>
+                <a:spcPts val="200"/>
+              </a:spcAft>
+              <a:defRPr sz="1300" b="0">
+                <a:solidFill>
+                  <a:srgbClr val="193354"/>
+                </a:solidFill>
+                <a:latin typeface="Courier New"/>
+              </a:defRPr>
+            </a:pPr>
+            <a:r>
+              <a:t>    94710</a:t>
+            </a:r>
+          </a:p>
+          <a:p>
+            <a:pPr algn="l">
+              <a:spcAft>
+                <a:spcPts val="200"/>
+              </a:spcAft>
+              <a:defRPr sz="1300" b="0">
+                <a:solidFill>
+                  <a:srgbClr val="193354"/>
+                </a:solidFill>
+                <a:latin typeface="Courier New"/>
+              </a:defRPr>
+            </a:pPr>
+            <a:r>
+              <a:t>)</a:t>
+            </a:r>
+          </a:p>
+        </p:txBody>
+      </p:sp>
+      <p:sp>
+        <p:nvSpPr>
+          <p:cNvPr id="299" name="TextBox 298"/>
+          <p:cNvSpPr txBox="1"/>
+          <p:nvPr/>
+        </p:nvSpPr>
+        <p:spPr>
+          <a:xfrm>
+            <a:off x="5029200" y="3410712"/>
+            <a:ext cx="3364992" cy="228600"/>
+          </a:xfrm>
+          <a:prstGeom prst="rect">
+            <a:avLst/>
+          </a:prstGeom>
+          <a:noFill/>
+        </p:spPr>
+        <p:txBody>
+          <a:bodyPr wrap="square" lIns="0" rIns="0" tIns="0" bIns="0">
+            <a:spAutoFit/>
+          </a:bodyPr>
+          <a:lstStyle/>
+          <a:p>
+            <a:pPr algn="l">
+              <a:spcAft>
+                <a:spcPts val="200"/>
+              </a:spcAft>
+              <a:defRPr sz="1200" b="1">
+                <a:solidFill>
+                  <a:srgbClr val="087F8C"/>
+                </a:solidFill>
+                <a:latin typeface="Arial"/>
+              </a:defRPr>
+            </a:pPr>
+            <a:r>
+              <a:t>Tool returns: weather data</a:t>
+            </a:r>
+          </a:p>
+        </p:txBody>
+      </p:sp>
+      <p:sp>
+        <p:nvSpPr>
+          <p:cNvPr id="300" name="TextBox 299"/>
+          <p:cNvSpPr txBox="1"/>
+          <p:nvPr/>
+        </p:nvSpPr>
+        <p:spPr>
+          <a:xfrm>
+            <a:off x="4352544" y="2761488"/>
+            <a:ext cx="420624" cy="365760"/>
+          </a:xfrm>
+          <a:prstGeom prst="rect">
+            <a:avLst/>
+          </a:prstGeom>
+          <a:noFill/>
+        </p:spPr>
+        <p:txBody>
+          <a:bodyPr wrap="square" lIns="0" rIns="0" tIns="0" bIns="0">
+            <a:spAutoFit/>
+          </a:bodyPr>
+          <a:lstStyle/>
+          <a:p>
+            <a:pPr algn="ctr">
+              <a:spcAft>
+                <a:spcPts val="200"/>
+              </a:spcAft>
+              <a:defRPr sz="2400" b="1">
+                <a:solidFill>
+                  <a:srgbClr val="087F8C"/>
+                </a:solidFill>
+                <a:latin typeface="Arial"/>
+              </a:defRPr>
+            </a:pPr>
+            <a:r>
+              <a:t>→</a:t>
+            </a:r>
+          </a:p>
+        </p:txBody>
+      </p:sp>
+      <p:sp>
+        <p:nvSpPr>
+          <p:cNvPr id="301" name="TextBox 300"/>
+          <p:cNvSpPr txBox="1"/>
+          <p:nvPr/>
+        </p:nvSpPr>
+        <p:spPr>
+          <a:xfrm>
+            <a:off x="566928" y="3895344"/>
+            <a:ext cx="8010144" cy="292608"/>
+          </a:xfrm>
+          <a:prstGeom prst="rect">
+            <a:avLst/>
+          </a:prstGeom>
+          <a:noFill/>
+        </p:spPr>
+        <p:txBody>
+          <a:bodyPr wrap="square" lIns="0" rIns="0" tIns="0" bIns="0">
+            <a:spAutoFit/>
+          </a:bodyPr>
+          <a:lstStyle/>
+          <a:p>
+            <a:pPr algn="l">
+              <a:spcAft>
+                <a:spcPts val="200"/>
+              </a:spcAft>
+              <a:defRPr sz="1500" b="1">
+                <a:solidFill>
+                  <a:srgbClr val="193354"/>
+                </a:solidFill>
+                <a:latin typeface="Arial"/>
+              </a:defRPr>
+            </a:pPr>
+            <a:r>
+              <a:t>What is checked?  Correct tools • Correct arguments • Correct dependencies</a:t>
+            </a:r>
+          </a:p>
+        </p:txBody>
+      </p:sp>
+      <p:sp>
+        <p:nvSpPr>
+          <p:cNvPr id="302" name="TextBox 301"/>
+          <p:cNvSpPr txBox="1"/>
+          <p:nvPr/>
+        </p:nvSpPr>
+        <p:spPr>
+          <a:xfrm>
+            <a:off x="566928" y="4343400"/>
+            <a:ext cx="8010144" cy="338328"/>
+          </a:xfrm>
+          <a:prstGeom prst="rect">
+            <a:avLst/>
+          </a:prstGeom>
+          <a:noFill/>
+        </p:spPr>
+        <p:txBody>
+          <a:bodyPr wrap="square" lIns="0" rIns="0" tIns="0" bIns="0">
+            <a:spAutoFit/>
+          </a:bodyPr>
+          <a:lstStyle/>
+          <a:p>
+            <a:pPr algn="l">
+              <a:spcAft>
+                <a:spcPts val="200"/>
+              </a:spcAft>
+              <a:defRPr sz="1300" b="0">
+                <a:solidFill>
+                  <a:srgbClr val="53657C"/>
+                </a:solidFill>
+                <a:latin typeface="Arial"/>
+              </a:defRPr>
+            </a:pPr>
+            <a:r>
+              <a:t>V4 covers single-turn and multi-turn tool use, plus web search and memory.</a:t>
+            </a:r>
+          </a:p>
+        </p:txBody>
+      </p:sp>
+      <p:sp>
+        <p:nvSpPr>
+          <p:cNvPr id="303" name="TextBox 302"/>
+          <p:cNvSpPr txBox="1"/>
+          <p:nvPr/>
+        </p:nvSpPr>
+        <p:spPr>
+          <a:xfrm>
+            <a:off x="566928" y="4791456"/>
+            <a:ext cx="8010144" cy="292608"/>
+          </a:xfrm>
+          <a:prstGeom prst="rect">
+            <a:avLst/>
+          </a:prstGeom>
+          <a:noFill/>
+        </p:spPr>
+        <p:txBody>
+          <a:bodyPr wrap="square" lIns="0" rIns="0" tIns="0" bIns="0">
+            <a:spAutoFit/>
+          </a:bodyPr>
+          <a:lstStyle/>
+          <a:p>
+            <a:pPr algn="l">
+              <a:spcAft>
+                <a:spcPts val="200"/>
+              </a:spcAft>
+              <a:defRPr sz="900" b="0">
+                <a:solidFill>
+                  <a:srgbClr val="53657C"/>
+                </a:solidFill>
+                <a:latin typeface="Arial"/>
+              </a:defRPr>
+            </a:pPr>
+            <a:r>
+              <a:t>Adapted from BFCL’s official multi-step example (V3 category retained in V4).</a:t>
+            </a:r>
+          </a:p>
+          <a:p>
+            <a:pPr algn="l">
+              <a:spcAft>
+                <a:spcPts val="200"/>
+              </a:spcAft>
+              <a:defRPr sz="900" b="0">
+                <a:solidFill>
+                  <a:srgbClr val="53657C"/>
+                </a:solidFill>
+                <a:latin typeface="Arial"/>
+              </a:defRPr>
+            </a:pPr>
+            <a:r>
+              <a:t>gorilla.cs.berkeley.edu/blogs/13_bfcl_v3_multi_turn.html</a:t>
+            </a:r>
           </a:p>
         </p:txBody>
       </p:sp>

</xml_diff>